<commit_message>
Revise supplier and Dahua slides and add presentation script
Fix inventory gap range (38-71 days) and the Dahua cost-share claim
(stable in COGS, rising in payables); add speaker notes with talk track,
likely questions and calculations; add storytelling and chart rationale.

Co-Authored-By: Claude Opus 5.5 <noreply@anthropic.com>
Claude-Session: https://claude.ai/code/session_01KnzCLDRo32uUYqhzKjGgJD
</commit_message>
<xml_diff>
--- a/intelbras_fornecedores_dahua.pptx
+++ b/intelbras_fornecedores_dahua.pptx
@@ -513,7 +513,7 @@
                           <a:srgbClr val="FFFFFF"/>
                         </a:solidFill>
                       </a:rPr>
-                      <a:t>80%</a:t>
+                      <a:t>~80%</a:t>
                     </a:r>
                   </a:p>
                 </c:rich>
@@ -641,93 +641,6 @@
               <a:srgbClr val="E3E3E3"/>
             </a:solidFill>
           </c:spPr>
-          <c:dLbls>
-            <c:dLbl>
-              <c:idx val="0"/>
-              <c:tx>
-                <c:rich>
-                  <a:bodyPr/>
-                  <a:lstStyle/>
-                  <a:p>
-                    <a:r>
-                      <a:rPr sz="900" b="0">
-                        <a:solidFill>
-                          <a:srgbClr val="595959"/>
-                        </a:solidFill>
-                      </a:rPr>
-                      <a:t>20%</a:t>
-                    </a:r>
-                  </a:p>
-                </c:rich>
-              </c:tx>
-              <c:dLblPos val="ctr"/>
-              <c:showLegendKey val="0"/>
-              <c:showVal val="1"/>
-              <c:showCatName val="0"/>
-              <c:showSerName val="0"/>
-              <c:showPercent val="0"/>
-              <c:showBubbleSize val="0"/>
-            </c:dLbl>
-            <c:dLbl>
-              <c:idx val="1"/>
-              <c:tx>
-                <c:rich>
-                  <a:bodyPr/>
-                  <a:lstStyle/>
-                  <a:p>
-                    <a:r>
-                      <a:rPr sz="900" b="0">
-                        <a:solidFill>
-                          <a:srgbClr val="595959"/>
-                        </a:solidFill>
-                      </a:rPr>
-                      <a:t>8%</a:t>
-                    </a:r>
-                  </a:p>
-                </c:rich>
-              </c:tx>
-              <c:dLblPos val="ctr"/>
-              <c:showLegendKey val="0"/>
-              <c:showVal val="1"/>
-              <c:showCatName val="0"/>
-              <c:showSerName val="0"/>
-              <c:showPercent val="0"/>
-              <c:showBubbleSize val="0"/>
-            </c:dLbl>
-            <c:dLbl>
-              <c:idx val="2"/>
-              <c:tx>
-                <c:rich>
-                  <a:bodyPr/>
-                  <a:lstStyle/>
-                  <a:p>
-                    <a:r>
-                      <a:rPr sz="900" b="0">
-                        <a:solidFill>
-                          <a:srgbClr val="595959"/>
-                        </a:solidFill>
-                      </a:rPr>
-                      <a:t>15%</a:t>
-                    </a:r>
-                  </a:p>
-                </c:rich>
-              </c:tx>
-              <c:dLblPos val="ctr"/>
-              <c:showLegendKey val="0"/>
-              <c:showVal val="1"/>
-              <c:showCatName val="0"/>
-              <c:showSerName val="0"/>
-              <c:showPercent val="0"/>
-              <c:showBubbleSize val="0"/>
-            </c:dLbl>
-            <c:showLegendKey val="0"/>
-            <c:showVal val="0"/>
-            <c:showCatName val="0"/>
-            <c:showSerName val="0"/>
-            <c:showPercent val="0"/>
-            <c:showBubbleSize val="0"/>
-            <c:showLeaderLines val="1"/>
-          </c:dLbls>
           <c:cat>
             <c:strRef>
               <c:f>Sheet1!$A$2:$A$4</c:f>
@@ -977,7 +890,7 @@
                   <c:v>Memória DRAM (3T25)</c:v>
                 </c:pt>
                 <c:pt idx="2">
-                  <c:v>Fundição de chips (2025)</c:v>
+                  <c:v>Fabricação de chips (2025)</c:v>
                 </c:pt>
               </c:strCache>
             </c:strRef>
@@ -1106,7 +1019,7 @@
                   <c:v>Memória DRAM (3T25)</c:v>
                 </c:pt>
                 <c:pt idx="2">
-                  <c:v>Fundição de chips (2025)</c:v>
+                  <c:v>Fabricação de chips (2025)</c:v>
                 </c:pt>
               </c:strCache>
             </c:strRef>
@@ -1201,7 +1114,7 @@
                   <c:v>Memória DRAM (3T25)</c:v>
                 </c:pt>
                 <c:pt idx="2">
-                  <c:v>Fundição de chips (2025)</c:v>
+                  <c:v>Fabricação de chips (2025)</c:v>
                 </c:pt>
               </c:strCache>
             </c:strRef>
@@ -1322,7 +1235,7 @@
                   <c:v>Memória DRAM (3T25)</c:v>
                 </c:pt>
                 <c:pt idx="2">
-                  <c:v>Fundição de chips (2025)</c:v>
+                  <c:v>Fabricação de chips (2025)</c:v>
                 </c:pt>
               </c:strCache>
             </c:strRef>
@@ -1468,7 +1381,7 @@
                   <c:v>Caixa e recebíveis em US$</c:v>
                 </c:pt>
                 <c:pt idx="2">
-                  <c:v>Hedge (contratos a termo)</c:v>
+                  <c:v>Hedge (NDF)</c:v>
                 </c:pt>
                 <c:pt idx="3">
                   <c:v>Exposição líquida</c:v>
@@ -1674,7 +1587,7 @@
                   <c:v>Caixa e recebíveis em US$</c:v>
                 </c:pt>
                 <c:pt idx="2">
-                  <c:v>Hedge (contratos a termo)</c:v>
+                  <c:v>Hedge (NDF)</c:v>
                 </c:pt>
                 <c:pt idx="3">
                   <c:v>Exposição líquida</c:v>
@@ -2202,7 +2115,7 @@
                   <c:v>Dahua · nº 2 global (16,0%)</c:v>
                 </c:pt>
                 <c:pt idx="2">
-                  <c:v>Intelbras</c:v>
+                  <c:v>Intelbras (todas as BUs)</c:v>
                 </c:pt>
               </c:strCache>
             </c:strRef>
@@ -2671,6 +2584,16 @@
                       <a:t>36%</a:t>
                     </a:r>
                   </a:p>
+                  <a:p>
+                    <a:r>
+                      <a:rPr sz="900" b="1">
+                        <a:solidFill>
+                          <a:srgbClr val="1A1A1A"/>
+                        </a:solidFill>
+                      </a:rPr>
+                      <a:t>(estoque)</a:t>
+                    </a:r>
+                  </a:p>
                 </c:rich>
               </c:tx>
               <c:dLblPos val="b"/>
@@ -3260,27 +3183,125 @@
           <a:lstStyle/>
           <a:p>
             <a:r>
-              <a:t>Mensagem: a Intelbras não tem poder de barganha com fornecedores. Compra insumos e produtos de oligopólios globais, em dólar, e compensa com estoque alto, prazo de fornecedores e hedge parcial.</a:t>
-            </a:r>
-          </a:p>
-          <a:p>
-            <a:r>
-              <a:t>I. DFP 2025 NE 27: matéria-prima e revenda = R$2.666,9 mi de R$3.117,8 mi de CPV (85,5%). NE 14: fornecedores + risco sacado no mercado externo = R$972,6 mi de R$1.062,6 mi (91,5%). FRE 2.2: ~80% do CPV atrelado a moeda estrangeira.</a:t>
-            </a:r>
-          </a:p>
-          <a:p>
-            <a:r>
-              <a:t>II. TrendForce: TSMC 69,9% da fundição em 2025 (Samsung 7,2%, SMIC 5,3%); DRAM 3T25: SK hynix 33,2%, Samsung 32,6%, Micron 25,7%. Câmeras de rede 2024: Hikvision 19,8%, Dahua 16,0% (Novaira Insights). FRE 1.4.e: poucas opções de chipsets.</a:t>
-            </a:r>
-          </a:p>
-          <a:p>
-            <a:r>
-              <a:t>III. DFP NE 25 (só US$): fornecedores R$894,4 mi; caixa R$157,2 mi + recebíveis R$26,6 mi; NDF R$450,6 mi → exposição líquida R$260,0 mi. Sensibilidade: 80% × CPV R$3.117,8 mi × 10% = R$249 mi; ÷ receita R$4.460 mi = 5,6 p.p. de margem bruta, sem repasse.</a:t>
-            </a:r>
-          </a:p>
-          <a:p>
-            <a:r>
-              <a:t>IV. Estoque ÷ CPV × 365 e (fornecedores + risco sacado) ÷ CPV × 365. 2025: 173 − 123 = 50 dias × CPV/365 ≈ R$427 mi.</a:t>
+              <a:t>ROTEIRO (≈2 min) — Slide 1: Fornecedores</a:t>
+            </a:r>
+          </a:p>
+          <a:p/>
+          <a:p>
+            <a:r>
+              <a:t>ABERTURA (título + subtítulo, 10s)</a:t>
+            </a:r>
+          </a:p>
+          <a:p>
+            <a:r>
+              <a:t>"Para entender a margem da Intelbras, primeiro é preciso entender de quem ela compra. A resposta curta: compra de gigantes, em dólar, e não define o preço."</a:t>
+            </a:r>
+          </a:p>
+          <a:p/>
+          <a:p>
+            <a:r>
+              <a:t>I. CUSTO IMPORTADO (aponte para o 85%, 25s)</a:t>
+            </a:r>
+          </a:p>
+          <a:p>
+            <a:r>
+              <a:t>"85% do custo é insumo ou produto comprado pronto. 92% do que ela deve a fornecedores está no exterior. E cerca de 80% do custo segue o dólar. Antes de ser fabricante, a Intelbras é uma compradora global."</a:t>
+            </a:r>
+          </a:p>
+          <a:p/>
+          <a:p>
+            <a:r>
+              <a:t>II. OLIGOPÓLIOS (aponte para TSMC 70%, depois para Dahua em verde, 25s)</a:t>
+            </a:r>
+          </a:p>
+          <a:p>
+            <a:r>
+              <a:t>"E de quem ela compra? De mercados com dois ou três donos. A TSMC fabrica 70% dos chips do mundo; três empresas fazem 92% da memória. Em câmeras, os dois maiores são chineses, e um deles, a Dahua, em verde, é fornecedora da própria Intelbras. Voltamos a ela no próximo slide. A companhia admite no FRE que há poucas opções de chip."</a:t>
+            </a:r>
+          </a:p>
+          <a:p/>
+          <a:p>
+            <a:r>
+              <a:t>III. DÓLAR (aponte para R$249 mi, 25s)</a:t>
+            </a:r>
+          </a:p>
+          <a:p>
+            <a:r>
+              <a:t>"O resultado é dólar no custo, não na receita. A empresa deve R$894 milhões em dólar; tirando caixa em dólar e o hedge, sobram R$260 milhões expostos no balanço. Mas o efeito grande está no custo do ano: cada 10% de alta do dólar soma R$249 milhões, ou 5,6 pontos de margem bruta, se não houver repasse."</a:t>
+            </a:r>
+          </a:p>
+          <a:p/>
+          <a:p>
+            <a:r>
+              <a:t>IV. ESTOQUE (aponte para ~40–70 dias, 25s)</a:t>
+            </a:r>
+          </a:p>
+          <a:p>
+            <a:r>
+              <a:t>"Sem poder de barganha, a defesa é estoque. Ela carrega uns 170 dias de estoque contra uns 120 dias de prazo dos fornecedores. Essa diferença, de 40 a 70 dias, é dinheiro da Intelbras parado: perto de R$0,4 bilhão em 2025. É o custo de garantir produto ao instalador e de se proteger de falta de chip."</a:t>
+            </a:r>
+          </a:p>
+          <a:p/>
+          <a:p>
+            <a:r>
+              <a:t>PONTE PARA O SLIDE 2 (10s)</a:t>
+            </a:r>
+          </a:p>
+          <a:p>
+            <a:r>
+              <a:t>"Resumo: a Intelbras é tomadora de preço, e paga isso em margem volátil e capital de giro alto. E entre todos esses fornecedores, um pesa mais que os outros: a Dahua."</a:t>
+            </a:r>
+          </a:p>
+          <a:p/>
+          <a:p>
+            <a:r>
+              <a:t>PERGUNTAS PROVÁVEIS</a:t>
+            </a:r>
+          </a:p>
+          <a:p>
+            <a:r>
+              <a:t>• "A Intelbras compra direto da TSMC?" Não. Compra chips de fabricantes que produzem nessas fábricas. O ponto é que o topo da cadeia é concentrado: escassez e aumento de preço chegam de qualquer jeito (ex.: memória em 2026, que elevou custos no 2T26).</a:t>
+            </a:r>
+          </a:p>
+          <a:p>
+            <a:r>
+              <a:t>• "Os 85% incluem revenda?" Sim: matéria-prima e revenda (DFP NE 27). A Intelbras agrega montagem, marca e canal, não o componente.</a:t>
+            </a:r>
+          </a:p>
+          <a:p>
+            <a:r>
+              <a:t>• "Por que o hedge cobre só metade?" NDF de ~90 dias protege o caixa de curto prazo; política de cobrir ~70% das importações nacionalizadas (FRE 5.1). Hedge longo é caro com Selic alta.</a:t>
+            </a:r>
+          </a:p>
+          <a:p>
+            <a:r>
+              <a:t>• "Isso já apareceu na margem?" Sim: em 2024 o dólar subiu 28% e a margem bruta caiu de 33,9% (1T24) para 29,0% (4T24); o repasse vem com defasagem.</a:t>
+            </a:r>
+          </a:p>
+          <a:p/>
+          <a:p>
+            <a:r>
+              <a:t>FONTES E CONTAS</a:t>
+            </a:r>
+          </a:p>
+          <a:p>
+            <a:r>
+              <a:t>I: DFP 2025 NE 27 (matéria-prima e revenda R$2.666,9 mi ÷ CPV R$3.117,8 mi = 85,5%); NE 14 (fornecedores + risco sacado no exterior R$972,6 mi ÷ R$1.062,6 mi = 91,5%); FRE 2.2 (~80% do CPV em moeda estrangeira).</a:t>
+            </a:r>
+          </a:p>
+          <a:p>
+            <a:r>
+              <a:t>II: TrendForce (fabricação de chips 2025: TSMC 69,9%, Samsung 7,2%, SMIC 5,3%; DRAM 3T25: SK hynix 33,2%, Samsung 32,6%, Micron 25,7%); Novaira Insights/Security World Market (câmeras de rede 2024: Hikvision 19,8%, Dahua 16,0%); FRE 1.4.e.</a:t>
+            </a:r>
+          </a:p>
+          <a:p>
+            <a:r>
+              <a:t>III: DFP NE 25, posições em US$: fornecedores 894,4; caixa 157,2 + recebíveis 26,6; NDF 450,6 → exposição 260,0. Sensibilidade: 80% × 3.117,8 × 10% = 249; ÷ receita 4.460 = 5,6 p.p.</a:t>
+            </a:r>
+          </a:p>
+          <a:p>
+            <a:r>
+              <a:t>IV: dias de estoque = estoque ÷ CPV × 365 (217/161/151/196/173); prazo = (fornecedores + risco sacado) ÷ CPV × 365 (146/121/113/135/123); gap 71/40/38/61/50 dias; 2025: 50 × 3.117,8/365 ≈ R$427 mi.</a:t>
             </a:r>
           </a:p>
         </p:txBody>
@@ -3350,27 +3371,146 @@
           <a:lstStyle/>
           <a:p>
             <a:r>
-              <a:t>Mensagem: a Dahua dá à Intelbras o que ela não tem escala para fazer (P&amp;D de câmeras) e recebe o canal; mas os sinais de afastamento se acumulam antes da renovação de dez/2028.</a:t>
-            </a:r>
-          </a:p>
-          <a:p>
-            <a:r>
-              <a:t>I. P&amp;D: Hikvision RMB 11,75 bi (US$1,65 bi) em 2025; Dahua RMB 4,213 bi em 2024 (÷7,18 ≈ US$587 mi); Intelbras R$179 mi em 2025 (FRE 2.10) ÷ 5,58 ≈ US$32 mi. Shares de câmeras de rede 2024: Hikvision 19,8%, Dahua 16,0% (Novaira Insights). Hikvision é montada pela Multilaser em Manaus desde 2022.</a:t>
-            </a:r>
-          </a:p>
-          <a:p>
-            <a:r>
-              <a:t>II. Acordo de Cooperação de 31/12/2018 por 10 anos: prioridade/exclusividade de compra de CFTV pela Intelbras; exclusividade dos produtos Dahua no Brasil para a Intelbras; a prioridade cai se a Dahua cobrar ≥5% acima de produto equivalente. Saldo a pagar à Dahua R$448,8 mi (DFP 2025). Assimetria: compras R$729,2 mi = 23,4% do CPV de R$3.117,8 mi; R$729,2 mi ÷ 5,58 ≈ US$131 mi ≈ 2,9% da receita da Dahua (RMB 32,3 bi ≈ US$4,5 bi).</a:t>
-            </a:r>
-          </a:p>
-          <a:p>
-            <a:r>
-              <a:t>III. Série consolidada (R$ mi): compras 515 / 664 / 545 / 1.187 / 729; saldo 263 / 350 / 225 / 506 / 449; fornecedores + risco sacado 870 / 1.003 / 877 / 1.220 / 1.049; CPV 2.178 / 3.031 / 2.827 / 3.294 / 3.118. Prazo implícito = saldo ÷ compras × 365: 187 / 192 / 151 / 156 / 225 dias. Prazo de 90 dias: 729 × 90/365 = R$180 mi de saldo → +R$269 mi de capital; ROIC LTM 2T26 18,8% → 17,1%.</a:t>
-            </a:r>
-          </a:p>
-          <a:p>
-            <a:r>
-              <a:t>IV. 2019: compra de 10% (FRE). Out/2021: recompõe 10% após diluição no IPO (compra de 1,4% da família). Jun/2023: vende 2,44% → 7,56% (Brazil Journal). Ago/2025: conselho da Dahua aprova vender os 7,56% em até 36 meses (FilingReader). Dahua Brasil: região independente após crescer três dígitos em 2020. FiberHome: exclusividade de GPON encerrada em 12/01/2026 (Teletime). ~metade do custo de Segurança = compras da Dahua ÷ CPV de Segurança, média 2021–25 ≈ 50%.</a:t>
+              <a:t>ROTEIRO (≈2,5 min) — Slide 2: Dahua</a:t>
+            </a:r>
+          </a:p>
+          <a:p/>
+          <a:p>
+            <a:r>
+              <a:t>ABERTURA (10s)</a:t>
+            </a:r>
+          </a:p>
+          <a:p>
+            <a:r>
+              <a:t>"A Dahua é o fornecedor mais importante da Intelbras. A metade de cima mostra por que essa relação existe; a de baixo, por que ela está perdendo força."</a:t>
+            </a:r>
+          </a:p>
+          <a:p/>
+          <a:p>
+            <a:r>
+              <a:t>I. POR QUE DAHUA (aponte para 18x, 30s)</a:t>
+            </a:r>
+          </a:p>
+          <a:p>
+            <a:r>
+              <a:t>"Por que comprar câmera da Dahua em vez de desenvolver? Porque câmera é uma corrida de P&amp;D. A Dahua investe US$587 milhões por ano, 18 vezes o P&amp;D da Intelbras inteira, somando todas as unidades. E a alternativa nº 1, a Hikvision, já é concorrente direta no Brasil. A Dahua é a única gigante disponível."</a:t>
+            </a:r>
+          </a:p>
+          <a:p/>
+          <a:p>
+            <a:r>
+              <a:t>II. A TROCA (aponte para as setas, depois para 23% vs ~3%, 30s)</a:t>
+            </a:r>
+          </a:p>
+          <a:p>
+            <a:r>
+              <a:t>"A troca é clara. A Dahua entrega tecnologia, exclusividade da marca e crédito: são R$449 milhões a pagar, uns 7 meses de prazo. A Intelbras entrega o que a Dahua não tem aqui: canal, com 500 distribuidores e 90 mil instaladores. Mas a dependência é assimétrica: a Dahua é 23% do custo da Intelbras, e a Intelbras é só ~3% da receita da Dahua. Quem precisa mais de quem? A Intelbras."</a:t>
+            </a:r>
+          </a:p>
+          <a:p/>
+          <a:p>
+            <a:r>
+              <a:t>[se usar animação, revele a metade de baixo aqui]</a:t>
+            </a:r>
+          </a:p>
+          <a:p>
+            <a:r>
+              <a:t>"Agora, por que essa relação está perdendo força."</a:t>
+            </a:r>
+          </a:p>
+          <a:p/>
+          <a:p>
+            <a:r>
+              <a:t>III. CRÉDITO (aponte para a linha verde, 30s)</a:t>
+            </a:r>
+          </a:p>
+          <a:p>
+            <a:r>
+              <a:t>"O peso da Dahua no custo está estável, na faixa de 20% a 25%; o pico de 2024 foi compra antecipada para estoque. Mas o peso no crédito subiu de 30% para 43%, e o prazo implícito chegou a 225 dias. Se a Dahua voltar a cobrar em 90 dias, a Intelbras precisa de R$269 milhões a mais de capital de giro, e o ROIC cai 1,7 ponto."</a:t>
+            </a:r>
+          </a:p>
+          <a:p/>
+          <a:p>
+            <a:r>
+              <a:t>IV. AFASTAMENTO (percorra as colunas, depois os marcos, 30s)</a:t>
+            </a:r>
+          </a:p>
+          <a:p>
+            <a:r>
+              <a:t>"Ao mesmo tempo, a Dahua está se afastando. Comprou 10% em 2019, vendeu parte em 2023 e, em agosto de 2025, aprovou vender o restante em até três anos. Montou operação própria no Brasil. E a FiberHome, outra parceira chinesa, já encerrou a exclusividade com a Intelbras este ano. Tudo converge para dezembro de 2028, quando o acordo vence."</a:t>
+            </a:r>
+          </a:p>
+          <a:p/>
+          <a:p>
+            <a:r>
+              <a:t>FECHO (15s)</a:t>
+            </a:r>
+          </a:p>
+          <a:p>
+            <a:r>
+              <a:t>"Em jogo na renovação: cerca de metade do custo de Segurança, o negócio que gera 68% do lucro bruto, e R$449 milhões de crédito. Não é previsão de rompimento: é o maior risco isolado da tese, e por isso a Dahua precisava de um slide próprio."</a:t>
+            </a:r>
+          </a:p>
+          <a:p/>
+          <a:p>
+            <a:r>
+              <a:t>PERGUNTAS PROVÁVEIS</a:t>
+            </a:r>
+          </a:p>
+          <a:p>
+            <a:r>
+              <a:t>• "Por que não troca de fornecedor?" A Hikvision é concorrente; os outros são menores ou mais caros. Trocar exige redesenvolver produto, firmware e app (FRE: a troca pode suspender a produção). A prioridade só cai se a Dahua cobrar ≥5% acima de produto equivalente ou falhar em tecnologia ou qualidade.</a:t>
+            </a:r>
+          </a:p>
+          <a:p>
+            <a:r>
+              <a:t>• "225 dias de prazo não é bom?" No curto prazo, sim: é financiamento barato. Mas concentra risco em um credor que está saindo do capital.</a:t>
+            </a:r>
+          </a:p>
+          <a:p>
+            <a:r>
+              <a:t>• "A Dahua pode entrar sozinha?" Há exclusividade até o fim do acordo + 6 meses. Já tem subsidiária no Brasil e marca de consumo (Imou) vendida via cross-border. O que falta é canal, e é isso que dá poder à Intelbras na negociação. [inferência]</a:t>
+            </a:r>
+          </a:p>
+          <a:p>
+            <a:r>
+              <a:t>• "Por que a Dahua vende a participação?" Não foi divulgado. A Dahua vendeu a operação nos EUA após queda de lucro em 2024; pode ser realocação de capital. Leitura conservadora: menos alinhamento.</a:t>
+            </a:r>
+          </a:p>
+          <a:p>
+            <a:r>
+              <a:t>• "Por que 23% e não os 36% do FRE?" Os 36% são sobre gastos com fornecedores (FRE); os 23%, sobre o CPV total (DFP). Bases diferentes, ambos corretos.</a:t>
+            </a:r>
+          </a:p>
+          <a:p>
+            <a:r>
+              <a:t>• "Isso é red flag?" É risco de evento, não piora comprovada de termos: preços e condições não são divulgados. Acompanhar: prazo de fornecedores, % do CPV, comunicados sobre renovação e venda das ações.</a:t>
+            </a:r>
+          </a:p>
+          <a:p/>
+          <a:p>
+            <a:r>
+              <a:t>FONTES E CONTAS</a:t>
+            </a:r>
+          </a:p>
+          <a:p>
+            <a:r>
+              <a:t>I: Hikvision P&amp;D RMB 11,75 bi (US$1,65 bi, 2025); Dahua P&amp;D RMB 4,213 bi (2024) ÷ 7,18 ≈ US$587 mi; Intelbras P&amp;D R$179 mi (FRE 2.10) ÷ 5,58 ≈ US$32 mi; shares Novaira 2024; Multilaser monta Hikvision em Manaus desde 2022 (Forbes).</a:t>
+            </a:r>
+          </a:p>
+          <a:p>
+            <a:r>
+              <a:t>II: Acordo de 31/12/2018, 10 anos (FRE 1.2/11.3); saldo Dahua R$448,8 mi (DFP NE 32); compras R$729,2 mi ÷ CPV R$3.117,8 mi = 23,4%; R$729,2 mi ÷ 5,58 ≈ US$131 mi ÷ receita Dahua ≈ US$4,5 bi (RMB 32,3 bi) ≈ 2,9%.</a:t>
+            </a:r>
+          </a:p>
+          <a:p>
+            <a:r>
+              <a:t>III: DFPs 2021–25. Compras 515/664/545/1.187/729; saldo 263/350/225/506/449; fornecedores + risco sacado 870/1.003/877/1.220/1.049; CPV 2.178/3.031/2.827/3.294/3.118. Prazo = saldo ÷ compras × 365 = 187/192/151/156/225. Se 90 dias: saldo 180 → +269; ROIC LTM 2T26 18,8% → 17,1%.</a:t>
+            </a:r>
+          </a:p>
+          <a:p>
+            <a:r>
+              <a:t>IV: 10% em ago/2019 (FRE); recomposição de 10% em out/2021 (comunicado Intelbras); venda de 2,44% em jun/2023 (Brazil Journal); aprovação da venda de 7,56% em até 36 meses em ago/2025 (FilingReader); Dahua Brasil região independente após crescer três dígitos em 2020 (comunicado Dahua, data aproximada); FiberHome em 12/01/2026 (Teletime). ~metade = compras Dahua ÷ CPV de Segurança, média 2021–25 ≈ 50% (40% em 2025).</a:t>
             </a:r>
           </a:p>
         </p:txBody>
@@ -7997,7 +8137,7 @@
           <a:lstStyle/>
           <a:p>
             <a:r>
-              <a:t>Quase todo o custo é insumo importado e dolarizado, vendido por poucos gigantes: a Intelbras aceita o preço na origem e se protege com estoque e hedge</a:t>
+              <a:t>Quase todo o custo é importado, dolarizado e vendido por poucos gigantes: a Intelbras aceita o preço e paga isso em margem e capital de giro</a:t>
             </a:r>
           </a:p>
         </p:txBody>
@@ -8186,7 +8326,7 @@
           <a:lstStyle/>
           <a:p>
             <a:r>
-              <a:t>Fontes: Intelbras DFP 2025 (NE 8, 14, 25 e 27) e FRE 2026 (itens 1.4.e e 2.2); TrendForce (fundição 2025; DRAM 3T25); Security World Market/Novaira Insights (câmeras de rede 2024). Dias = estoque e fornecedores (incl. risco sacado) ÷ CPV × 365.</a:t>
+              <a:t>Fontes: Intelbras DFP 2025 (NE 8, 14, 25 e 27) e FRE 2026 (itens 1.4.e e 2.2); TrendForce (fabricação de chips 2025; DRAM 3T25); Security World Market/Novaira Insights (câmeras de rede 2024). Dias = estoque e fornecedores (incl. risco sacado) ÷ CPV × 365.</a:t>
             </a:r>
           </a:p>
         </p:txBody>
@@ -8418,7 +8558,7 @@
                   <a:srgbClr val="009F41"/>
                 </a:solidFill>
               </a:rPr>
-              <a:t>50–70 dias</a:t>
+              <a:t>~40–70 dias</a:t>
             </a:r>
           </a:p>
           <a:p>
@@ -8433,7 +8573,7 @@
                   <a:srgbClr val="595959"/>
                 </a:solidFill>
               </a:rPr>
-              <a:t>de compras que a Intelbras carrega no balanço</a:t>
+              <a:t>de compras que a Intelbras carrega a mais no balanço (2021–25)</a:t>
             </a:r>
           </a:p>
           <a:p>
@@ -8516,7 +8656,7 @@
           <a:lstStyle/>
           <a:p>
             <a:r>
-              <a:t>A Dahua troca tecnologia e crédito pelo canal da Intelbras, mas a compra relativa cai, a Dahua sai do capital e o acordo vence em dez/2028</a:t>
+              <a:t>A Dahua troca tecnologia e crédito pelo canal da Intelbras, mas está saindo do capital justo quando a Intelbras mais depende do seu crédito</a:t>
             </a:r>
           </a:p>
         </p:txBody>
@@ -8621,7 +8761,7 @@
           <a:lstStyle/>
           <a:p>
             <a:r>
-              <a:t>III. A Intelbras compra menos da Dahua, mas depende mais do crédito dela</a:t>
+              <a:t>III. O peso da Dahua no custo é estável, mas no crédito subiu de 30% para 43%</a:t>
             </a:r>
           </a:p>
         </p:txBody>
@@ -9463,7 +9603,7 @@
                   <a:srgbClr val="009F41"/>
                 </a:solidFill>
               </a:rPr>
-              <a:t>2021  </a:t>
+              <a:t>c.2021  </a:t>
             </a:r>
             <a:r>
               <a:rPr sz="900" b="0" i="0">

</xml_diff>

<commit_message>
Keep supplier slide within business-model scope
Replace global chip market shares and the USD vs gross margin chart
(sector-analysis content) with Intelbras's own supply map, Dahua's
share of supplier spend, and inventory vs supplier payment days.

Co-Authored-By: Claude Opus 5.5 <noreply@anthropic.com>
Claude-Session: https://claude.ai/code/session_01KnzCLDRo32uUYqhzKjGgJD
</commit_message>
<xml_diff>
--- a/intelbras_fornecedores_dahua.pptx
+++ b/intelbras_fornecedores_dahua.pptx
@@ -128,809 +128,6 @@
 </file>
 
 <file path=ppt/charts/chart10.xml><?xml version="1.0" encoding="utf-8"?>
-<c:chartSpace xmlns:c="http://schemas.openxmlformats.org/drawingml/2006/chart" xmlns:a="http://schemas.openxmlformats.org/drawingml/2006/main" xmlns:r="http://schemas.openxmlformats.org/officeDocument/2006/relationships">
-  <c:date1904 val="0"/>
-  <c:chart>
-    <c:autoTitleDeleted val="1"/>
-    <c:plotArea>
-      <c:lineChart>
-        <c:grouping val="standard"/>
-        <c:varyColors val="0"/>
-        <c:ser>
-          <c:idx val="0"/>
-          <c:order val="0"/>
-          <c:tx>
-            <c:strRef>
-              <c:f>Sheet1!$B$1</c:f>
-              <c:strCache>
-                <c:ptCount val="1"/>
-                <c:pt idx="0">
-                  <c:v>Margem bruta</c:v>
-                </c:pt>
-              </c:strCache>
-            </c:strRef>
-          </c:tx>
-          <c:spPr>
-            <a:ln w="28575">
-              <a:solidFill>
-                <a:srgbClr val="009F41"/>
-              </a:solidFill>
-            </a:ln>
-          </c:spPr>
-          <c:marker>
-            <c:symbol val="circle"/>
-            <c:size val="5"/>
-            <c:spPr>
-              <a:solidFill>
-                <a:srgbClr val="009F41"/>
-              </a:solidFill>
-              <a:ln>
-                <a:solidFill>
-                  <a:srgbClr val="009F41"/>
-                </a:solidFill>
-              </a:ln>
-            </c:spPr>
-          </c:marker>
-          <c:dLbls>
-            <c:dLbl>
-              <c:idx val="4"/>
-              <c:tx>
-                <c:rich>
-                  <a:bodyPr/>
-                  <a:lstStyle/>
-                  <a:p>
-                    <a:r>
-                      <a:rPr sz="900" b="1">
-                        <a:solidFill>
-                          <a:srgbClr val="009F41"/>
-                        </a:solidFill>
-                      </a:rPr>
-                      <a:t>33,9%</a:t>
-                    </a:r>
-                  </a:p>
-                </c:rich>
-              </c:tx>
-              <c:dLblPos val="t"/>
-              <c:showLegendKey val="0"/>
-              <c:showVal val="1"/>
-              <c:showCatName val="0"/>
-              <c:showSerName val="0"/>
-              <c:showPercent val="0"/>
-              <c:showBubbleSize val="0"/>
-            </c:dLbl>
-            <c:dLbl>
-              <c:idx val="7"/>
-              <c:tx>
-                <c:rich>
-                  <a:bodyPr/>
-                  <a:lstStyle/>
-                  <a:p>
-                    <a:r>
-                      <a:rPr sz="900" b="1">
-                        <a:solidFill>
-                          <a:srgbClr val="009F41"/>
-                        </a:solidFill>
-                      </a:rPr>
-                      <a:t>29,0%</a:t>
-                    </a:r>
-                  </a:p>
-                </c:rich>
-              </c:tx>
-              <c:dLblPos val="b"/>
-              <c:showLegendKey val="0"/>
-              <c:showVal val="1"/>
-              <c:showCatName val="0"/>
-              <c:showSerName val="0"/>
-              <c:showPercent val="0"/>
-              <c:showBubbleSize val="0"/>
-            </c:dLbl>
-            <c:dLbl>
-              <c:idx val="13"/>
-              <c:tx>
-                <c:rich>
-                  <a:bodyPr/>
-                  <a:lstStyle/>
-                  <a:p>
-                    <a:r>
-                      <a:rPr sz="900" b="1">
-                        <a:solidFill>
-                          <a:srgbClr val="009F41"/>
-                        </a:solidFill>
-                      </a:rPr>
-                      <a:t>33,1%</a:t>
-                    </a:r>
-                  </a:p>
-                </c:rich>
-              </c:tx>
-              <c:dLblPos val="t"/>
-              <c:showLegendKey val="0"/>
-              <c:showVal val="1"/>
-              <c:showCatName val="0"/>
-              <c:showSerName val="0"/>
-              <c:showPercent val="0"/>
-              <c:showBubbleSize val="0"/>
-            </c:dLbl>
-            <c:showLegendKey val="0"/>
-            <c:showVal val="0"/>
-            <c:showCatName val="0"/>
-            <c:showSerName val="0"/>
-            <c:showPercent val="0"/>
-            <c:showBubbleSize val="0"/>
-            <c:showLeaderLines val="1"/>
-          </c:dLbls>
-          <c:cat>
-            <c:strRef>
-              <c:f>Sheet1!$A$2:$A$15</c:f>
-              <c:strCache>
-                <c:ptCount val="14"/>
-                <c:pt idx="0">
-                  <c:v>1T23</c:v>
-                </c:pt>
-                <c:pt idx="1">
-                  <c:v>2T23</c:v>
-                </c:pt>
-                <c:pt idx="2">
-                  <c:v>3T23</c:v>
-                </c:pt>
-                <c:pt idx="3">
-                  <c:v>4T23</c:v>
-                </c:pt>
-                <c:pt idx="4">
-                  <c:v>1T24</c:v>
-                </c:pt>
-                <c:pt idx="5">
-                  <c:v>2T24</c:v>
-                </c:pt>
-                <c:pt idx="6">
-                  <c:v>3T24</c:v>
-                </c:pt>
-                <c:pt idx="7">
-                  <c:v>4T24</c:v>
-                </c:pt>
-                <c:pt idx="8">
-                  <c:v>1T25</c:v>
-                </c:pt>
-                <c:pt idx="9">
-                  <c:v>2T25</c:v>
-                </c:pt>
-                <c:pt idx="10">
-                  <c:v>3T25</c:v>
-                </c:pt>
-                <c:pt idx="11">
-                  <c:v>4T25</c:v>
-                </c:pt>
-                <c:pt idx="12">
-                  <c:v>1T26</c:v>
-                </c:pt>
-                <c:pt idx="13">
-                  <c:v>2T26</c:v>
-                </c:pt>
-              </c:strCache>
-            </c:strRef>
-          </c:cat>
-          <c:val>
-            <c:numRef>
-              <c:f>Sheet1!$B$2:$B$15</c:f>
-              <c:numCache>
-                <c:formatCode>General</c:formatCode>
-                <c:ptCount val="14"/>
-                <c:pt idx="0">
-                  <c:v>31.6</c:v>
-                </c:pt>
-                <c:pt idx="1">
-                  <c:v>34.4</c:v>
-                </c:pt>
-                <c:pt idx="2">
-                  <c:v>32.4</c:v>
-                </c:pt>
-                <c:pt idx="3">
-                  <c:v>29.5</c:v>
-                </c:pt>
-                <c:pt idx="4">
-                  <c:v>33.9</c:v>
-                </c:pt>
-                <c:pt idx="5">
-                  <c:v>31.5</c:v>
-                </c:pt>
-                <c:pt idx="6">
-                  <c:v>29.3</c:v>
-                </c:pt>
-                <c:pt idx="7">
-                  <c:v>29.0</c:v>
-                </c:pt>
-                <c:pt idx="8">
-                  <c:v>29.4</c:v>
-                </c:pt>
-                <c:pt idx="9">
-                  <c:v>29.3</c:v>
-                </c:pt>
-                <c:pt idx="10">
-                  <c:v>30.9</c:v>
-                </c:pt>
-                <c:pt idx="11">
-                  <c:v>30.7</c:v>
-                </c:pt>
-                <c:pt idx="12">
-                  <c:v>30.7</c:v>
-                </c:pt>
-                <c:pt idx="13">
-                  <c:v>33.1</c:v>
-                </c:pt>
-              </c:numCache>
-            </c:numRef>
-          </c:val>
-          <c:smooth val="0"/>
-        </c:ser>
-        <c:marker val="1"/>
-        <c:smooth val="0"/>
-        <c:axId val="2118791784"/>
-        <c:axId val="2140495176"/>
-      </c:lineChart>
-      <c:catAx>
-        <c:axId val="2118791784"/>
-        <c:scaling>
-          <c:orientation val="minMax"/>
-        </c:scaling>
-        <c:delete val="0"/>
-        <c:axPos val="b"/>
-        <c:majorTickMark val="none"/>
-        <c:minorTickMark val="none"/>
-        <c:tickLblPos val="nextTo"/>
-        <c:spPr>
-          <a:ln w="9525">
-            <a:solidFill>
-              <a:srgbClr val="BFBFBF"/>
-            </a:solidFill>
-          </a:ln>
-        </c:spPr>
-        <c:txPr>
-          <a:bodyPr/>
-          <a:lstStyle/>
-          <a:p>
-            <a:pPr>
-              <a:defRPr sz="800">
-                <a:solidFill>
-                  <a:srgbClr val="595959"/>
-                </a:solidFill>
-              </a:defRPr>
-            </a:pPr>
-          </a:p>
-        </c:txPr>
-        <c:crossAx val="2140495176"/>
-        <c:crosses val="autoZero"/>
-        <c:auto val="1"/>
-        <c:lblAlgn val="ctr"/>
-        <c:lblOffset val="100"/>
-        <c:noMultiLvlLbl val="0"/>
-      </c:catAx>
-      <c:valAx>
-        <c:axId val="2140495176"/>
-        <c:scaling>
-          <c:max val="37.0"/>
-          <c:min val="25.0"/>
-        </c:scaling>
-        <c:delete/>
-        <c:axPos val="l"/>
-        <c:majorTickMark val="out"/>
-        <c:minorTickMark val="none"/>
-        <c:tickLblPos val="nextTo"/>
-        <c:crossAx val="2118791784"/>
-        <c:crosses val="autoZero"/>
-      </c:valAx>
-    </c:plotArea>
-    <c:plotVisOnly val="1"/>
-    <c:dispBlanksAs val="gap"/>
-    <c:showDLblsOverMax val="0"/>
-  </c:chart>
-  <c:spPr>
-    <a:noFill/>
-    <a:ln>
-      <a:noFill/>
-    </a:ln>
-  </c:spPr>
-  <c:txPr>
-    <a:bodyPr/>
-    <a:lstStyle/>
-    <a:p>
-      <a:pPr>
-        <a:defRPr sz="900">
-          <a:solidFill>
-            <a:srgbClr val="595959"/>
-          </a:solidFill>
-          <a:latin typeface="Calibri"/>
-        </a:defRPr>
-      </a:pPr>
-      <a:endParaRPr lang="en-US"/>
-    </a:p>
-  </c:txPr>
-  <c:externalData r:id="rId1">
-    <c:autoUpdate val="0"/>
-  </c:externalData>
-</c:chartSpace>
-</file>
-
-<file path=ppt/charts/chart11.xml><?xml version="1.0" encoding="utf-8"?>
-<c:chartSpace xmlns:c="http://schemas.openxmlformats.org/drawingml/2006/chart" xmlns:a="http://schemas.openxmlformats.org/drawingml/2006/main" xmlns:r="http://schemas.openxmlformats.org/officeDocument/2006/relationships">
-  <c:date1904 val="0"/>
-  <c:chart>
-    <c:autoTitleDeleted val="1"/>
-    <c:plotArea>
-      <c:lineChart>
-        <c:grouping val="standard"/>
-        <c:varyColors val="0"/>
-        <c:ser>
-          <c:idx val="0"/>
-          <c:order val="0"/>
-          <c:tx>
-            <c:strRef>
-              <c:f>Sheet1!$B$1</c:f>
-              <c:strCache>
-                <c:ptCount val="1"/>
-                <c:pt idx="0">
-                  <c:v>% dos gastos com fornecedores</c:v>
-                </c:pt>
-              </c:strCache>
-            </c:strRef>
-          </c:tx>
-          <c:spPr>
-            <a:ln w="28575">
-              <a:solidFill>
-                <a:srgbClr val="009F41"/>
-              </a:solidFill>
-              <a:prstDash val="dash"/>
-            </a:ln>
-          </c:spPr>
-          <c:marker>
-            <c:symbol val="circle"/>
-            <c:size val="6"/>
-            <c:spPr>
-              <a:solidFill>
-                <a:srgbClr val="009F41"/>
-              </a:solidFill>
-              <a:ln>
-                <a:solidFill>
-                  <a:srgbClr val="009F41"/>
-                </a:solidFill>
-              </a:ln>
-            </c:spPr>
-          </c:marker>
-          <c:dLbls>
-            <c:dLbl>
-              <c:idx val="0"/>
-              <c:tx>
-                <c:rich>
-                  <a:bodyPr/>
-                  <a:lstStyle/>
-                  <a:p>
-                    <a:r>
-                      <a:rPr sz="1000" b="1">
-                        <a:solidFill>
-                          <a:srgbClr val="009F41"/>
-                        </a:solidFill>
-                      </a:rPr>
-                      <a:t>28,6%</a:t>
-                    </a:r>
-                  </a:p>
-                </c:rich>
-              </c:tx>
-              <c:dLblPos val="t"/>
-              <c:showLegendKey val="0"/>
-              <c:showVal val="1"/>
-              <c:showCatName val="0"/>
-              <c:showSerName val="0"/>
-              <c:showPercent val="0"/>
-              <c:showBubbleSize val="0"/>
-            </c:dLbl>
-            <c:dLbl>
-              <c:idx val="4"/>
-              <c:tx>
-                <c:rich>
-                  <a:bodyPr/>
-                  <a:lstStyle/>
-                  <a:p>
-                    <a:r>
-                      <a:rPr sz="1000" b="1">
-                        <a:solidFill>
-                          <a:srgbClr val="009F41"/>
-                        </a:solidFill>
-                      </a:rPr>
-                      <a:t>36%</a:t>
-                    </a:r>
-                  </a:p>
-                </c:rich>
-              </c:tx>
-              <c:dLblPos val="t"/>
-              <c:showLegendKey val="0"/>
-              <c:showVal val="1"/>
-              <c:showCatName val="0"/>
-              <c:showSerName val="0"/>
-              <c:showPercent val="0"/>
-              <c:showBubbleSize val="0"/>
-            </c:dLbl>
-            <c:showLegendKey val="0"/>
-            <c:showVal val="0"/>
-            <c:showCatName val="0"/>
-            <c:showSerName val="0"/>
-            <c:showPercent val="0"/>
-            <c:showBubbleSize val="0"/>
-            <c:showLeaderLines val="1"/>
-          </c:dLbls>
-          <c:cat>
-            <c:strRef>
-              <c:f>Sheet1!$A$2:$A$6</c:f>
-              <c:strCache>
-                <c:ptCount val="5"/>
-                <c:pt idx="0">
-                  <c:v>2021</c:v>
-                </c:pt>
-                <c:pt idx="1">
-                  <c:v>2022</c:v>
-                </c:pt>
-                <c:pt idx="2">
-                  <c:v>2023</c:v>
-                </c:pt>
-                <c:pt idx="3">
-                  <c:v>2024</c:v>
-                </c:pt>
-                <c:pt idx="4">
-                  <c:v>2025</c:v>
-                </c:pt>
-              </c:strCache>
-            </c:strRef>
-          </c:cat>
-          <c:val>
-            <c:numRef>
-              <c:f>Sheet1!$B$2:$B$6</c:f>
-              <c:numCache>
-                <c:formatCode>General</c:formatCode>
-                <c:ptCount val="5"/>
-                <c:pt idx="0">
-                  <c:v>28.6</c:v>
-                </c:pt>
-                <c:pt idx="4">
-                  <c:v>36.0</c:v>
-                </c:pt>
-              </c:numCache>
-            </c:numRef>
-          </c:val>
-          <c:smooth val="0"/>
-        </c:ser>
-        <c:ser>
-          <c:idx val="1"/>
-          <c:order val="1"/>
-          <c:tx>
-            <c:strRef>
-              <c:f>Sheet1!$C$1</c:f>
-              <c:strCache>
-                <c:ptCount val="1"/>
-                <c:pt idx="0">
-                  <c:v>% do custo dos produtos vendidos</c:v>
-                </c:pt>
-              </c:strCache>
-            </c:strRef>
-          </c:tx>
-          <c:spPr>
-            <a:ln w="28575">
-              <a:solidFill>
-                <a:srgbClr val="1A1A1A"/>
-              </a:solidFill>
-            </a:ln>
-          </c:spPr>
-          <c:marker>
-            <c:symbol val="circle"/>
-            <c:size val="6"/>
-            <c:spPr>
-              <a:solidFill>
-                <a:srgbClr val="1A1A1A"/>
-              </a:solidFill>
-              <a:ln>
-                <a:solidFill>
-                  <a:srgbClr val="1A1A1A"/>
-                </a:solidFill>
-              </a:ln>
-            </c:spPr>
-          </c:marker>
-          <c:dLbls>
-            <c:dLbl>
-              <c:idx val="0"/>
-              <c:tx>
-                <c:rich>
-                  <a:bodyPr/>
-                  <a:lstStyle/>
-                  <a:p>
-                    <a:r>
-                      <a:rPr sz="900" b="1">
-                        <a:solidFill>
-                          <a:srgbClr val="1A1A1A"/>
-                        </a:solidFill>
-                      </a:rPr>
-                      <a:t>24%</a:t>
-                    </a:r>
-                  </a:p>
-                </c:rich>
-              </c:tx>
-              <c:dLblPos val="b"/>
-              <c:showLegendKey val="0"/>
-              <c:showVal val="1"/>
-              <c:showCatName val="0"/>
-              <c:showSerName val="0"/>
-              <c:showPercent val="0"/>
-              <c:showBubbleSize val="0"/>
-            </c:dLbl>
-            <c:dLbl>
-              <c:idx val="1"/>
-              <c:tx>
-                <c:rich>
-                  <a:bodyPr/>
-                  <a:lstStyle/>
-                  <a:p>
-                    <a:r>
-                      <a:rPr sz="900" b="1">
-                        <a:solidFill>
-                          <a:srgbClr val="1A1A1A"/>
-                        </a:solidFill>
-                      </a:rPr>
-                      <a:t>22%</a:t>
-                    </a:r>
-                  </a:p>
-                </c:rich>
-              </c:tx>
-              <c:dLblPos val="b"/>
-              <c:showLegendKey val="0"/>
-              <c:showVal val="1"/>
-              <c:showCatName val="0"/>
-              <c:showSerName val="0"/>
-              <c:showPercent val="0"/>
-              <c:showBubbleSize val="0"/>
-            </c:dLbl>
-            <c:dLbl>
-              <c:idx val="2"/>
-              <c:tx>
-                <c:rich>
-                  <a:bodyPr/>
-                  <a:lstStyle/>
-                  <a:p>
-                    <a:r>
-                      <a:rPr sz="900" b="1">
-                        <a:solidFill>
-                          <a:srgbClr val="1A1A1A"/>
-                        </a:solidFill>
-                      </a:rPr>
-                      <a:t>19%</a:t>
-                    </a:r>
-                  </a:p>
-                </c:rich>
-              </c:tx>
-              <c:dLblPos val="b"/>
-              <c:showLegendKey val="0"/>
-              <c:showVal val="1"/>
-              <c:showCatName val="0"/>
-              <c:showSerName val="0"/>
-              <c:showPercent val="0"/>
-              <c:showBubbleSize val="0"/>
-            </c:dLbl>
-            <c:dLbl>
-              <c:idx val="3"/>
-              <c:tx>
-                <c:rich>
-                  <a:bodyPr/>
-                  <a:lstStyle/>
-                  <a:p>
-                    <a:r>
-                      <a:rPr sz="900" b="1">
-                        <a:solidFill>
-                          <a:srgbClr val="1A1A1A"/>
-                        </a:solidFill>
-                      </a:rPr>
-                      <a:t>36%</a:t>
-                    </a:r>
-                  </a:p>
-                  <a:p>
-                    <a:r>
-                      <a:rPr sz="900" b="1">
-                        <a:solidFill>
-                          <a:srgbClr val="1A1A1A"/>
-                        </a:solidFill>
-                      </a:rPr>
-                      <a:t>(estoque)</a:t>
-                    </a:r>
-                  </a:p>
-                </c:rich>
-              </c:tx>
-              <c:dLblPos val="b"/>
-              <c:showLegendKey val="0"/>
-              <c:showVal val="1"/>
-              <c:showCatName val="0"/>
-              <c:showSerName val="0"/>
-              <c:showPercent val="0"/>
-              <c:showBubbleSize val="0"/>
-            </c:dLbl>
-            <c:dLbl>
-              <c:idx val="4"/>
-              <c:tx>
-                <c:rich>
-                  <a:bodyPr/>
-                  <a:lstStyle/>
-                  <a:p>
-                    <a:r>
-                      <a:rPr sz="900" b="1">
-                        <a:solidFill>
-                          <a:srgbClr val="1A1A1A"/>
-                        </a:solidFill>
-                      </a:rPr>
-                      <a:t>23%</a:t>
-                    </a:r>
-                  </a:p>
-                </c:rich>
-              </c:tx>
-              <c:dLblPos val="b"/>
-              <c:showLegendKey val="0"/>
-              <c:showVal val="1"/>
-              <c:showCatName val="0"/>
-              <c:showSerName val="0"/>
-              <c:showPercent val="0"/>
-              <c:showBubbleSize val="0"/>
-            </c:dLbl>
-            <c:showLegendKey val="0"/>
-            <c:showVal val="0"/>
-            <c:showCatName val="0"/>
-            <c:showSerName val="0"/>
-            <c:showPercent val="0"/>
-            <c:showBubbleSize val="0"/>
-            <c:showLeaderLines val="1"/>
-          </c:dLbls>
-          <c:cat>
-            <c:strRef>
-              <c:f>Sheet1!$A$2:$A$6</c:f>
-              <c:strCache>
-                <c:ptCount val="5"/>
-                <c:pt idx="0">
-                  <c:v>2021</c:v>
-                </c:pt>
-                <c:pt idx="1">
-                  <c:v>2022</c:v>
-                </c:pt>
-                <c:pt idx="2">
-                  <c:v>2023</c:v>
-                </c:pt>
-                <c:pt idx="3">
-                  <c:v>2024</c:v>
-                </c:pt>
-                <c:pt idx="4">
-                  <c:v>2025</c:v>
-                </c:pt>
-              </c:strCache>
-            </c:strRef>
-          </c:cat>
-          <c:val>
-            <c:numRef>
-              <c:f>Sheet1!$C$2:$C$6</c:f>
-              <c:numCache>
-                <c:formatCode>General</c:formatCode>
-                <c:ptCount val="5"/>
-                <c:pt idx="0">
-                  <c:v>23.6</c:v>
-                </c:pt>
-                <c:pt idx="1">
-                  <c:v>21.9</c:v>
-                </c:pt>
-                <c:pt idx="2">
-                  <c:v>19.3</c:v>
-                </c:pt>
-                <c:pt idx="3">
-                  <c:v>36.0</c:v>
-                </c:pt>
-                <c:pt idx="4">
-                  <c:v>23.4</c:v>
-                </c:pt>
-              </c:numCache>
-            </c:numRef>
-          </c:val>
-          <c:smooth val="0"/>
-        </c:ser>
-        <c:marker val="1"/>
-        <c:smooth val="0"/>
-        <c:axId val="2118791784"/>
-        <c:axId val="2140495176"/>
-      </c:lineChart>
-      <c:catAx>
-        <c:axId val="2118791784"/>
-        <c:scaling>
-          <c:orientation val="minMax"/>
-        </c:scaling>
-        <c:delete val="0"/>
-        <c:axPos val="b"/>
-        <c:majorTickMark val="none"/>
-        <c:minorTickMark val="none"/>
-        <c:tickLblPos val="nextTo"/>
-        <c:spPr>
-          <a:ln w="9525">
-            <a:solidFill>
-              <a:srgbClr val="BFBFBF"/>
-            </a:solidFill>
-          </a:ln>
-        </c:spPr>
-        <c:txPr>
-          <a:bodyPr/>
-          <a:lstStyle/>
-          <a:p>
-            <a:pPr>
-              <a:defRPr sz="900">
-                <a:solidFill>
-                  <a:srgbClr val="595959"/>
-                </a:solidFill>
-              </a:defRPr>
-            </a:pPr>
-          </a:p>
-        </c:txPr>
-        <c:crossAx val="2140495176"/>
-        <c:crosses val="autoZero"/>
-        <c:auto val="1"/>
-        <c:lblAlgn val="ctr"/>
-        <c:lblOffset val="100"/>
-        <c:noMultiLvlLbl val="0"/>
-      </c:catAx>
-      <c:valAx>
-        <c:axId val="2140495176"/>
-        <c:scaling>
-          <c:max val="44.0"/>
-          <c:min val="10.0"/>
-        </c:scaling>
-        <c:delete/>
-        <c:axPos val="l"/>
-        <c:majorTickMark val="out"/>
-        <c:minorTickMark val="none"/>
-        <c:tickLblPos val="nextTo"/>
-        <c:crossAx val="2118791784"/>
-        <c:crosses val="autoZero"/>
-      </c:valAx>
-    </c:plotArea>
-    <c:legend>
-      <c:legendPos val="t"/>
-      <c:layout/>
-      <c:overlay val="0"/>
-      <c:txPr>
-        <a:bodyPr/>
-        <a:lstStyle/>
-        <a:p>
-          <a:pPr>
-            <a:defRPr sz="900"/>
-          </a:pPr>
-        </a:p>
-      </c:txPr>
-    </c:legend>
-    <c:plotVisOnly val="1"/>
-    <c:dispBlanksAs val="span"/>
-    <c:showDLblsOverMax val="0"/>
-  </c:chart>
-  <c:spPr>
-    <a:noFill/>
-    <a:ln>
-      <a:noFill/>
-    </a:ln>
-  </c:spPr>
-  <c:txPr>
-    <a:bodyPr/>
-    <a:lstStyle/>
-    <a:p>
-      <a:pPr>
-        <a:defRPr sz="900">
-          <a:solidFill>
-            <a:srgbClr val="595959"/>
-          </a:solidFill>
-          <a:latin typeface="Calibri"/>
-        </a:defRPr>
-      </a:pPr>
-      <a:endParaRPr lang="en-US"/>
-    </a:p>
-  </c:txPr>
-  <c:externalData r:id="rId1">
-    <c:autoUpdate val="0"/>
-  </c:externalData>
-</c:chartSpace>
-</file>
-
-<file path=ppt/charts/chart12.xml><?xml version="1.0" encoding="utf-8"?>
 <c:chartSpace xmlns:c="http://schemas.openxmlformats.org/drawingml/2006/chart" xmlns:a="http://schemas.openxmlformats.org/drawingml/2006/main" xmlns:r="http://schemas.openxmlformats.org/officeDocument/2006/relationships">
   <c:date1904 val="0"/>
   <c:chart>
@@ -1783,8 +980,8 @@
     <c:autoTitleDeleted val="1"/>
     <c:plotArea>
       <c:barChart>
-        <c:barDir val="bar"/>
-        <c:grouping val="percentStacked"/>
+        <c:barDir val="col"/>
+        <c:grouping val="clustered"/>
         <c:ser>
           <c:idx val="0"/>
           <c:order val="0"/>
@@ -1794,147 +991,59 @@
               <c:strCache>
                 <c:ptCount val="1"/>
                 <c:pt idx="0">
-                  <c:v>1º</c:v>
+                  <c:v>Dias de estoque</c:v>
                 </c:pt>
               </c:strCache>
             </c:strRef>
           </c:tx>
           <c:spPr>
             <a:solidFill>
-              <a:srgbClr val="1A1A1A"/>
+              <a:srgbClr val="009F41"/>
             </a:solidFill>
-            <a:ln w="9525">
-              <a:solidFill>
-                <a:srgbClr val="FFFFFF"/>
-              </a:solidFill>
-            </a:ln>
           </c:spPr>
-          <c:dPt>
-            <c:idx val="2"/>
-            <c:spPr>
-              <a:solidFill>
-                <a:srgbClr val="009F41"/>
-              </a:solidFill>
-            </c:spPr>
-          </c:dPt>
-          <c:dLbls>
-            <c:dLbl>
-              <c:idx val="0"/>
-              <c:tx>
-                <c:rich>
-                  <a:bodyPr/>
-                  <a:lstStyle/>
-                  <a:p>
-                    <a:r>
-                      <a:rPr sz="900" b="1">
-                        <a:solidFill>
-                          <a:srgbClr val="FFFFFF"/>
-                        </a:solidFill>
-                      </a:rPr>
-                      <a:t>TSMC 70%</a:t>
-                    </a:r>
-                  </a:p>
-                </c:rich>
-              </c:tx>
-              <c:dLblPos val="ctr"/>
-              <c:showLegendKey val="0"/>
-              <c:showVal val="1"/>
-              <c:showCatName val="0"/>
-              <c:showSerName val="0"/>
-              <c:showPercent val="0"/>
-              <c:showBubbleSize val="0"/>
-            </c:dLbl>
-            <c:dLbl>
-              <c:idx val="1"/>
-              <c:tx>
-                <c:rich>
-                  <a:bodyPr/>
-                  <a:lstStyle/>
-                  <a:p>
-                    <a:r>
-                      <a:rPr sz="900" b="1">
-                        <a:solidFill>
-                          <a:srgbClr val="FFFFFF"/>
-                        </a:solidFill>
-                      </a:rPr>
-                      <a:t>SK hynix 33%</a:t>
-                    </a:r>
-                  </a:p>
-                </c:rich>
-              </c:tx>
-              <c:dLblPos val="ctr"/>
-              <c:showLegendKey val="0"/>
-              <c:showVal val="1"/>
-              <c:showCatName val="0"/>
-              <c:showSerName val="0"/>
-              <c:showPercent val="0"/>
-              <c:showBubbleSize val="0"/>
-            </c:dLbl>
-            <c:dLbl>
-              <c:idx val="2"/>
-              <c:tx>
-                <c:rich>
-                  <a:bodyPr/>
-                  <a:lstStyle/>
-                  <a:p>
-                    <a:r>
-                      <a:rPr sz="1000" b="1">
-                        <a:solidFill>
-                          <a:srgbClr val="FFFFFF"/>
-                        </a:solidFill>
-                      </a:rPr>
-                      <a:t>Dahua</a:t>
-                    </a:r>
-                  </a:p>
-                </c:rich>
-              </c:tx>
-              <c:dLblPos val="ctr"/>
-              <c:showLegendKey val="0"/>
-              <c:showVal val="1"/>
-              <c:showCatName val="0"/>
-              <c:showSerName val="0"/>
-              <c:showPercent val="0"/>
-              <c:showBubbleSize val="0"/>
-            </c:dLbl>
-            <c:showLegendKey val="0"/>
-            <c:showVal val="0"/>
-            <c:showCatName val="0"/>
-            <c:showSerName val="0"/>
-            <c:showPercent val="0"/>
-            <c:showBubbleSize val="0"/>
-            <c:showLeaderLines val="1"/>
-          </c:dLbls>
           <c:cat>
             <c:strRef>
-              <c:f>Sheet1!$A$2:$A$4</c:f>
+              <c:f>Sheet1!$A$2:$A$6</c:f>
               <c:strCache>
-                <c:ptCount val="3"/>
+                <c:ptCount val="5"/>
                 <c:pt idx="0">
-                  <c:v>Chips (fabricação, 2025)</c:v>
+                  <c:v>2021</c:v>
                 </c:pt>
                 <c:pt idx="1">
-                  <c:v>Memória DRAM (3T25)</c:v>
+                  <c:v>2022</c:v>
                 </c:pt>
                 <c:pt idx="2">
-                  <c:v>CFTV pronto (contrato até 2028)</c:v>
+                  <c:v>2023</c:v>
+                </c:pt>
+                <c:pt idx="3">
+                  <c:v>2024</c:v>
+                </c:pt>
+                <c:pt idx="4">
+                  <c:v>2025</c:v>
                 </c:pt>
               </c:strCache>
             </c:strRef>
           </c:cat>
           <c:val>
             <c:numRef>
-              <c:f>Sheet1!$B$2:$B$4</c:f>
+              <c:f>Sheet1!$B$2:$B$6</c:f>
               <c:numCache>
                 <c:formatCode>General</c:formatCode>
-                <c:ptCount val="3"/>
+                <c:ptCount val="5"/>
                 <c:pt idx="0">
-                  <c:v>69.9</c:v>
+                  <c:v>217</c:v>
                 </c:pt>
                 <c:pt idx="1">
-                  <c:v>33.2</c:v>
+                  <c:v>161</c:v>
                 </c:pt>
                 <c:pt idx="2">
-                  <c:v>100.0</c:v>
+                  <c:v>151</c:v>
+                </c:pt>
+                <c:pt idx="3">
+                  <c:v>196</c:v>
+                </c:pt>
+                <c:pt idx="4">
+                  <c:v>173</c:v>
                 </c:pt>
               </c:numCache>
             </c:numRef>
@@ -1949,300 +1058,108 @@
               <c:strCache>
                 <c:ptCount val="1"/>
                 <c:pt idx="0">
-                  <c:v>2º</c:v>
+                  <c:v>Prazo pago aos fornecedores</c:v>
                 </c:pt>
               </c:strCache>
             </c:strRef>
           </c:tx>
           <c:spPr>
             <a:solidFill>
-              <a:srgbClr val="595959"/>
+              <a:srgbClr val="BFBFBF"/>
             </a:solidFill>
-            <a:ln w="9525">
-              <a:solidFill>
-                <a:srgbClr val="FFFFFF"/>
-              </a:solidFill>
-            </a:ln>
           </c:spPr>
-          <c:dLbls>
-            <c:dLbl>
-              <c:idx val="1"/>
-              <c:tx>
-                <c:rich>
-                  <a:bodyPr/>
-                  <a:lstStyle/>
-                  <a:p>
-                    <a:r>
-                      <a:rPr sz="900" b="1">
-                        <a:solidFill>
-                          <a:srgbClr val="FFFFFF"/>
-                        </a:solidFill>
-                      </a:rPr>
-                      <a:t>Samsung 33%</a:t>
-                    </a:r>
-                  </a:p>
-                </c:rich>
-              </c:tx>
-              <c:dLblPos val="ctr"/>
-              <c:showLegendKey val="0"/>
-              <c:showVal val="1"/>
-              <c:showCatName val="0"/>
-              <c:showSerName val="0"/>
-              <c:showPercent val="0"/>
-              <c:showBubbleSize val="0"/>
-            </c:dLbl>
-            <c:showLegendKey val="0"/>
-            <c:showVal val="0"/>
-            <c:showCatName val="0"/>
-            <c:showSerName val="0"/>
-            <c:showPercent val="0"/>
-            <c:showBubbleSize val="0"/>
-            <c:showLeaderLines val="1"/>
-          </c:dLbls>
           <c:cat>
             <c:strRef>
-              <c:f>Sheet1!$A$2:$A$4</c:f>
+              <c:f>Sheet1!$A$2:$A$6</c:f>
               <c:strCache>
-                <c:ptCount val="3"/>
+                <c:ptCount val="5"/>
                 <c:pt idx="0">
-                  <c:v>Chips (fabricação, 2025)</c:v>
+                  <c:v>2021</c:v>
                 </c:pt>
                 <c:pt idx="1">
-                  <c:v>Memória DRAM (3T25)</c:v>
+                  <c:v>2022</c:v>
                 </c:pt>
                 <c:pt idx="2">
-                  <c:v>CFTV pronto (contrato até 2028)</c:v>
+                  <c:v>2023</c:v>
+                </c:pt>
+                <c:pt idx="3">
+                  <c:v>2024</c:v>
+                </c:pt>
+                <c:pt idx="4">
+                  <c:v>2025</c:v>
                 </c:pt>
               </c:strCache>
             </c:strRef>
           </c:cat>
           <c:val>
             <c:numRef>
-              <c:f>Sheet1!$C$2:$C$4</c:f>
+              <c:f>Sheet1!$C$2:$C$6</c:f>
               <c:numCache>
                 <c:formatCode>General</c:formatCode>
-                <c:ptCount val="3"/>
+                <c:ptCount val="5"/>
                 <c:pt idx="0">
-                  <c:v>7.2</c:v>
+                  <c:v>146</c:v>
                 </c:pt>
                 <c:pt idx="1">
-                  <c:v>32.6</c:v>
+                  <c:v>121</c:v>
                 </c:pt>
                 <c:pt idx="2">
-                  <c:v>0.0</c:v>
+                  <c:v>113</c:v>
+                </c:pt>
+                <c:pt idx="3">
+                  <c:v>135</c:v>
+                </c:pt>
+                <c:pt idx="4">
+                  <c:v>123</c:v>
                 </c:pt>
               </c:numCache>
             </c:numRef>
           </c:val>
         </c:ser>
-        <c:ser>
-          <c:idx val="2"/>
-          <c:order val="2"/>
-          <c:tx>
-            <c:strRef>
-              <c:f>Sheet1!$D$1</c:f>
-              <c:strCache>
-                <c:ptCount val="1"/>
-                <c:pt idx="0">
-                  <c:v>3º</c:v>
-                </c:pt>
-              </c:strCache>
-            </c:strRef>
-          </c:tx>
-          <c:spPr>
-            <a:solidFill>
-              <a:srgbClr val="8C8C8C"/>
-            </a:solidFill>
-            <a:ln w="9525">
-              <a:solidFill>
-                <a:srgbClr val="FFFFFF"/>
-              </a:solidFill>
-            </a:ln>
-          </c:spPr>
-          <c:dLbls>
-            <c:dLbl>
-              <c:idx val="1"/>
-              <c:tx>
-                <c:rich>
-                  <a:bodyPr/>
-                  <a:lstStyle/>
-                  <a:p>
-                    <a:r>
-                      <a:rPr sz="900" b="1">
-                        <a:solidFill>
-                          <a:srgbClr val="FFFFFF"/>
-                        </a:solidFill>
-                      </a:rPr>
-                      <a:t>Micron 26%</a:t>
-                    </a:r>
-                  </a:p>
-                </c:rich>
-              </c:tx>
-              <c:dLblPos val="ctr"/>
-              <c:showLegendKey val="0"/>
-              <c:showVal val="1"/>
-              <c:showCatName val="0"/>
-              <c:showSerName val="0"/>
-              <c:showPercent val="0"/>
-              <c:showBubbleSize val="0"/>
-            </c:dLbl>
-            <c:showLegendKey val="0"/>
-            <c:showVal val="0"/>
-            <c:showCatName val="0"/>
-            <c:showSerName val="0"/>
-            <c:showPercent val="0"/>
-            <c:showBubbleSize val="0"/>
-            <c:showLeaderLines val="1"/>
-          </c:dLbls>
-          <c:cat>
-            <c:strRef>
-              <c:f>Sheet1!$A$2:$A$4</c:f>
-              <c:strCache>
-                <c:ptCount val="3"/>
-                <c:pt idx="0">
-                  <c:v>Chips (fabricação, 2025)</c:v>
-                </c:pt>
-                <c:pt idx="1">
-                  <c:v>Memória DRAM (3T25)</c:v>
-                </c:pt>
-                <c:pt idx="2">
-                  <c:v>CFTV pronto (contrato até 2028)</c:v>
-                </c:pt>
-              </c:strCache>
-            </c:strRef>
-          </c:cat>
-          <c:val>
-            <c:numRef>
-              <c:f>Sheet1!$D$2:$D$4</c:f>
-              <c:numCache>
-                <c:formatCode>General</c:formatCode>
-                <c:ptCount val="3"/>
-                <c:pt idx="0">
-                  <c:v>5.3</c:v>
-                </c:pt>
-                <c:pt idx="1">
-                  <c:v>25.7</c:v>
-                </c:pt>
-                <c:pt idx="2">
-                  <c:v>0.0</c:v>
-                </c:pt>
-              </c:numCache>
-            </c:numRef>
-          </c:val>
-        </c:ser>
-        <c:ser>
-          <c:idx val="3"/>
-          <c:order val="3"/>
-          <c:tx>
-            <c:strRef>
-              <c:f>Sheet1!$E$1</c:f>
-              <c:strCache>
-                <c:ptCount val="1"/>
-                <c:pt idx="0">
-                  <c:v>Outros</c:v>
-                </c:pt>
-              </c:strCache>
-            </c:strRef>
-          </c:tx>
-          <c:spPr>
-            <a:solidFill>
-              <a:srgbClr val="E3E3E3"/>
-            </a:solidFill>
-            <a:ln w="9525">
-              <a:solidFill>
-                <a:srgbClr val="FFFFFF"/>
-              </a:solidFill>
-            </a:ln>
-          </c:spPr>
-          <c:dLbls>
-            <c:dLbl>
-              <c:idx val="0"/>
-              <c:tx>
-                <c:rich>
-                  <a:bodyPr/>
-                  <a:lstStyle/>
-                  <a:p>
-                    <a:r>
-                      <a:rPr sz="900" b="0">
-                        <a:solidFill>
-                          <a:srgbClr val="595959"/>
-                        </a:solidFill>
-                      </a:rPr>
-                      <a:t>Outros 18%</a:t>
-                    </a:r>
-                  </a:p>
-                </c:rich>
-              </c:tx>
-              <c:dLblPos val="ctr"/>
-              <c:showLegendKey val="0"/>
-              <c:showVal val="1"/>
-              <c:showCatName val="0"/>
-              <c:showSerName val="0"/>
-              <c:showPercent val="0"/>
-              <c:showBubbleSize val="0"/>
-            </c:dLbl>
-            <c:showLegendKey val="0"/>
-            <c:showVal val="0"/>
-            <c:showCatName val="0"/>
-            <c:showSerName val="0"/>
-            <c:showPercent val="0"/>
-            <c:showBubbleSize val="0"/>
-            <c:showLeaderLines val="1"/>
-          </c:dLbls>
-          <c:cat>
-            <c:strRef>
-              <c:f>Sheet1!$A$2:$A$4</c:f>
-              <c:strCache>
-                <c:ptCount val="3"/>
-                <c:pt idx="0">
-                  <c:v>Chips (fabricação, 2025)</c:v>
-                </c:pt>
-                <c:pt idx="1">
-                  <c:v>Memória DRAM (3T25)</c:v>
-                </c:pt>
-                <c:pt idx="2">
-                  <c:v>CFTV pronto (contrato até 2028)</c:v>
-                </c:pt>
-              </c:strCache>
-            </c:strRef>
-          </c:cat>
-          <c:val>
-            <c:numRef>
-              <c:f>Sheet1!$E$2:$E$4</c:f>
-              <c:numCache>
-                <c:formatCode>General</c:formatCode>
-                <c:ptCount val="3"/>
-                <c:pt idx="0">
-                  <c:v>17.6</c:v>
-                </c:pt>
-                <c:pt idx="1">
-                  <c:v>8.5</c:v>
-                </c:pt>
-                <c:pt idx="2">
-                  <c:v>0.0</c:v>
-                </c:pt>
-              </c:numCache>
-            </c:numRef>
-          </c:val>
-        </c:ser>
-        <c:gapWidth val="35"/>
-        <c:overlap val="100"/>
+        <c:dLbls>
+          <c:numFmt formatCode="0" sourceLinked="0"/>
+          <c:txPr>
+            <a:bodyPr/>
+            <a:lstStyle/>
+            <a:p>
+              <a:pPr>
+                <a:defRPr sz="900">
+                  <a:solidFill>
+                    <a:srgbClr val="595959"/>
+                  </a:solidFill>
+                </a:defRPr>
+              </a:pPr>
+            </a:p>
+          </c:txPr>
+          <c:dLblPos val="outEnd"/>
+          <c:showLegendKey val="0"/>
+          <c:showVal val="1"/>
+          <c:showCatName val="0"/>
+          <c:showSerName val="0"/>
+          <c:showPercent val="0"/>
+          <c:showBubbleSize val="0"/>
+          <c:showLeaderLines val="1"/>
+        </c:dLbls>
+        <c:gapWidth val="60"/>
+        <c:overlap val="-10"/>
         <c:axId val="-2068027336"/>
         <c:axId val="-2113994440"/>
       </c:barChart>
       <c:catAx>
         <c:axId val="-2068027336"/>
         <c:scaling>
-          <c:orientation val="maxMin"/>
+          <c:orientation val="minMax"/>
         </c:scaling>
         <c:delete val="0"/>
-        <c:axPos val="l"/>
+        <c:axPos val="b"/>
         <c:majorTickMark val="none"/>
         <c:minorTickMark val="none"/>
         <c:tickLblPos val="nextTo"/>
         <c:spPr>
-          <a:ln>
-            <a:noFill/>
+          <a:ln w="9525">
+            <a:solidFill>
+              <a:srgbClr val="BFBFBF"/>
+            </a:solidFill>
           </a:ln>
         </c:spPr>
         <c:txPr>
@@ -2267,9 +1184,12 @@
       </c:catAx>
       <c:valAx>
         <c:axId val="-2113994440"/>
-        <c:scaling/>
+        <c:scaling>
+          <c:max val="250.0"/>
+          <c:min val="0.0"/>
+        </c:scaling>
         <c:delete/>
-        <c:axPos val="b"/>
+        <c:axPos val="l"/>
         <c:majorTickMark val="out"/>
         <c:minorTickMark val="none"/>
         <c:tickLblPos val="nextTo"/>
@@ -2277,6 +1197,19 @@
         <c:crosses val="autoZero"/>
       </c:valAx>
     </c:plotArea>
+    <c:legend>
+      <c:legendPos val="t"/>
+      <c:overlay val="0"/>
+      <c:txPr>
+        <a:bodyPr/>
+        <a:lstStyle/>
+        <a:p>
+          <a:pPr>
+            <a:defRPr sz="900"/>
+          </a:pPr>
+        </a:p>
+      </c:txPr>
+    </c:legend>
     <c:dispBlanksAs val="gap"/>
   </c:chart>
   <c:spPr>
@@ -2324,47 +1257,48 @@
               <c:strCache>
                 <c:ptCount val="1"/>
                 <c:pt idx="0">
-                  <c:v>Dólar</c:v>
+                  <c:v>% dos gastos com fornecedores</c:v>
                 </c:pt>
               </c:strCache>
             </c:strRef>
           </c:tx>
           <c:spPr>
-            <a:ln w="25400">
+            <a:ln w="28575">
               <a:solidFill>
-                <a:srgbClr val="595959"/>
+                <a:srgbClr val="009F41"/>
               </a:solidFill>
+              <a:prstDash val="dash"/>
             </a:ln>
           </c:spPr>
           <c:marker>
             <c:symbol val="circle"/>
-            <c:size val="4"/>
+            <c:size val="6"/>
             <c:spPr>
               <a:solidFill>
-                <a:srgbClr val="595959"/>
+                <a:srgbClr val="009F41"/>
               </a:solidFill>
               <a:ln>
                 <a:solidFill>
-                  <a:srgbClr val="595959"/>
+                  <a:srgbClr val="009F41"/>
                 </a:solidFill>
               </a:ln>
             </c:spPr>
           </c:marker>
           <c:dLbls>
             <c:dLbl>
-              <c:idx val="4"/>
+              <c:idx val="0"/>
               <c:tx>
                 <c:rich>
                   <a:bodyPr/>
                   <a:lstStyle/>
                   <a:p>
                     <a:r>
-                      <a:rPr sz="900" b="1">
+                      <a:rPr sz="1000" b="1">
                         <a:solidFill>
-                          <a:srgbClr val="595959"/>
+                          <a:srgbClr val="009F41"/>
                         </a:solidFill>
                       </a:rPr>
-                      <a:t>4,95</a:t>
+                      <a:t>28,6%</a:t>
                     </a:r>
                   </a:p>
                 </c:rich>
@@ -2378,45 +1312,19 @@
               <c:showBubbleSize val="0"/>
             </c:dLbl>
             <c:dLbl>
-              <c:idx val="7"/>
+              <c:idx val="4"/>
               <c:tx>
                 <c:rich>
                   <a:bodyPr/>
                   <a:lstStyle/>
                   <a:p>
                     <a:r>
-                      <a:rPr sz="900" b="1">
+                      <a:rPr sz="1000" b="1">
                         <a:solidFill>
-                          <a:srgbClr val="595959"/>
+                          <a:srgbClr val="009F41"/>
                         </a:solidFill>
                       </a:rPr>
-                      <a:t>5,84</a:t>
-                    </a:r>
-                  </a:p>
-                </c:rich>
-              </c:tx>
-              <c:dLblPos val="t"/>
-              <c:showLegendKey val="0"/>
-              <c:showVal val="1"/>
-              <c:showCatName val="0"/>
-              <c:showSerName val="0"/>
-              <c:showPercent val="0"/>
-              <c:showBubbleSize val="0"/>
-            </c:dLbl>
-            <c:dLbl>
-              <c:idx val="13"/>
-              <c:tx>
-                <c:rich>
-                  <a:bodyPr/>
-                  <a:lstStyle/>
-                  <a:p>
-                    <a:r>
-                      <a:rPr sz="900" b="1">
-                        <a:solidFill>
-                          <a:srgbClr val="595959"/>
-                        </a:solidFill>
-                      </a:rPr>
-                      <a:t>5,05</a:t>
+                      <a:t>36%</a:t>
                     </a:r>
                   </a:p>
                 </c:rich>
@@ -2439,101 +1347,271 @@
           </c:dLbls>
           <c:cat>
             <c:strRef>
-              <c:f>Sheet1!$A$2:$A$15</c:f>
+              <c:f>Sheet1!$A$2:$A$6</c:f>
               <c:strCache>
-                <c:ptCount val="14"/>
+                <c:ptCount val="5"/>
                 <c:pt idx="0">
-                  <c:v>1T23</c:v>
+                  <c:v>2021</c:v>
                 </c:pt>
                 <c:pt idx="1">
-                  <c:v>2T23</c:v>
+                  <c:v>2022</c:v>
                 </c:pt>
                 <c:pt idx="2">
-                  <c:v>3T23</c:v>
+                  <c:v>2023</c:v>
                 </c:pt>
                 <c:pt idx="3">
-                  <c:v>4T23</c:v>
+                  <c:v>2024</c:v>
                 </c:pt>
                 <c:pt idx="4">
-                  <c:v>1T24</c:v>
-                </c:pt>
-                <c:pt idx="5">
-                  <c:v>2T24</c:v>
-                </c:pt>
-                <c:pt idx="6">
-                  <c:v>3T24</c:v>
-                </c:pt>
-                <c:pt idx="7">
-                  <c:v>4T24</c:v>
-                </c:pt>
-                <c:pt idx="8">
-                  <c:v>1T25</c:v>
-                </c:pt>
-                <c:pt idx="9">
-                  <c:v>2T25</c:v>
-                </c:pt>
-                <c:pt idx="10">
-                  <c:v>3T25</c:v>
-                </c:pt>
-                <c:pt idx="11">
-                  <c:v>4T25</c:v>
-                </c:pt>
-                <c:pt idx="12">
-                  <c:v>1T26</c:v>
-                </c:pt>
-                <c:pt idx="13">
-                  <c:v>2T26</c:v>
+                  <c:v>2025</c:v>
                 </c:pt>
               </c:strCache>
             </c:strRef>
           </c:cat>
           <c:val>
             <c:numRef>
-              <c:f>Sheet1!$B$2:$B$15</c:f>
+              <c:f>Sheet1!$B$2:$B$6</c:f>
               <c:numCache>
                 <c:formatCode>General</c:formatCode>
-                <c:ptCount val="14"/>
+                <c:ptCount val="5"/>
                 <c:pt idx="0">
-                  <c:v>5.13</c:v>
+                  <c:v>28.6</c:v>
+                </c:pt>
+                <c:pt idx="4">
+                  <c:v>36.0</c:v>
+                </c:pt>
+              </c:numCache>
+            </c:numRef>
+          </c:val>
+          <c:smooth val="0"/>
+        </c:ser>
+        <c:ser>
+          <c:idx val="1"/>
+          <c:order val="1"/>
+          <c:tx>
+            <c:strRef>
+              <c:f>Sheet1!$C$1</c:f>
+              <c:strCache>
+                <c:ptCount val="1"/>
+                <c:pt idx="0">
+                  <c:v>% do custo dos produtos vendidos</c:v>
+                </c:pt>
+              </c:strCache>
+            </c:strRef>
+          </c:tx>
+          <c:spPr>
+            <a:ln w="28575">
+              <a:solidFill>
+                <a:srgbClr val="1A1A1A"/>
+              </a:solidFill>
+            </a:ln>
+          </c:spPr>
+          <c:marker>
+            <c:symbol val="circle"/>
+            <c:size val="6"/>
+            <c:spPr>
+              <a:solidFill>
+                <a:srgbClr val="1A1A1A"/>
+              </a:solidFill>
+              <a:ln>
+                <a:solidFill>
+                  <a:srgbClr val="1A1A1A"/>
+                </a:solidFill>
+              </a:ln>
+            </c:spPr>
+          </c:marker>
+          <c:dLbls>
+            <c:dLbl>
+              <c:idx val="0"/>
+              <c:tx>
+                <c:rich>
+                  <a:bodyPr/>
+                  <a:lstStyle/>
+                  <a:p>
+                    <a:r>
+                      <a:rPr sz="900" b="1">
+                        <a:solidFill>
+                          <a:srgbClr val="1A1A1A"/>
+                        </a:solidFill>
+                      </a:rPr>
+                      <a:t>24%</a:t>
+                    </a:r>
+                  </a:p>
+                </c:rich>
+              </c:tx>
+              <c:dLblPos val="b"/>
+              <c:showLegendKey val="0"/>
+              <c:showVal val="1"/>
+              <c:showCatName val="0"/>
+              <c:showSerName val="0"/>
+              <c:showPercent val="0"/>
+              <c:showBubbleSize val="0"/>
+            </c:dLbl>
+            <c:dLbl>
+              <c:idx val="1"/>
+              <c:tx>
+                <c:rich>
+                  <a:bodyPr/>
+                  <a:lstStyle/>
+                  <a:p>
+                    <a:r>
+                      <a:rPr sz="900" b="1">
+                        <a:solidFill>
+                          <a:srgbClr val="1A1A1A"/>
+                        </a:solidFill>
+                      </a:rPr>
+                      <a:t>22%</a:t>
+                    </a:r>
+                  </a:p>
+                </c:rich>
+              </c:tx>
+              <c:dLblPos val="b"/>
+              <c:showLegendKey val="0"/>
+              <c:showVal val="1"/>
+              <c:showCatName val="0"/>
+              <c:showSerName val="0"/>
+              <c:showPercent val="0"/>
+              <c:showBubbleSize val="0"/>
+            </c:dLbl>
+            <c:dLbl>
+              <c:idx val="2"/>
+              <c:tx>
+                <c:rich>
+                  <a:bodyPr/>
+                  <a:lstStyle/>
+                  <a:p>
+                    <a:r>
+                      <a:rPr sz="900" b="1">
+                        <a:solidFill>
+                          <a:srgbClr val="1A1A1A"/>
+                        </a:solidFill>
+                      </a:rPr>
+                      <a:t>19%</a:t>
+                    </a:r>
+                  </a:p>
+                </c:rich>
+              </c:tx>
+              <c:dLblPos val="b"/>
+              <c:showLegendKey val="0"/>
+              <c:showVal val="1"/>
+              <c:showCatName val="0"/>
+              <c:showSerName val="0"/>
+              <c:showPercent val="0"/>
+              <c:showBubbleSize val="0"/>
+            </c:dLbl>
+            <c:dLbl>
+              <c:idx val="3"/>
+              <c:tx>
+                <c:rich>
+                  <a:bodyPr/>
+                  <a:lstStyle/>
+                  <a:p>
+                    <a:r>
+                      <a:rPr sz="900" b="1">
+                        <a:solidFill>
+                          <a:srgbClr val="1A1A1A"/>
+                        </a:solidFill>
+                      </a:rPr>
+                      <a:t>36%</a:t>
+                    </a:r>
+                  </a:p>
+                  <a:p>
+                    <a:r>
+                      <a:rPr sz="900" b="1">
+                        <a:solidFill>
+                          <a:srgbClr val="1A1A1A"/>
+                        </a:solidFill>
+                      </a:rPr>
+                      <a:t>(estoque)</a:t>
+                    </a:r>
+                  </a:p>
+                </c:rich>
+              </c:tx>
+              <c:dLblPos val="b"/>
+              <c:showLegendKey val="0"/>
+              <c:showVal val="1"/>
+              <c:showCatName val="0"/>
+              <c:showSerName val="0"/>
+              <c:showPercent val="0"/>
+              <c:showBubbleSize val="0"/>
+            </c:dLbl>
+            <c:dLbl>
+              <c:idx val="4"/>
+              <c:tx>
+                <c:rich>
+                  <a:bodyPr/>
+                  <a:lstStyle/>
+                  <a:p>
+                    <a:r>
+                      <a:rPr sz="900" b="1">
+                        <a:solidFill>
+                          <a:srgbClr val="1A1A1A"/>
+                        </a:solidFill>
+                      </a:rPr>
+                      <a:t>23%</a:t>
+                    </a:r>
+                  </a:p>
+                </c:rich>
+              </c:tx>
+              <c:dLblPos val="b"/>
+              <c:showLegendKey val="0"/>
+              <c:showVal val="1"/>
+              <c:showCatName val="0"/>
+              <c:showSerName val="0"/>
+              <c:showPercent val="0"/>
+              <c:showBubbleSize val="0"/>
+            </c:dLbl>
+            <c:showLegendKey val="0"/>
+            <c:showVal val="0"/>
+            <c:showCatName val="0"/>
+            <c:showSerName val="0"/>
+            <c:showPercent val="0"/>
+            <c:showBubbleSize val="0"/>
+            <c:showLeaderLines val="1"/>
+          </c:dLbls>
+          <c:cat>
+            <c:strRef>
+              <c:f>Sheet1!$A$2:$A$6</c:f>
+              <c:strCache>
+                <c:ptCount val="5"/>
+                <c:pt idx="0">
+                  <c:v>2021</c:v>
                 </c:pt>
                 <c:pt idx="1">
-                  <c:v>4.97</c:v>
+                  <c:v>2022</c:v>
                 </c:pt>
                 <c:pt idx="2">
-                  <c:v>4.89</c:v>
+                  <c:v>2023</c:v>
                 </c:pt>
                 <c:pt idx="3">
-                  <c:v>4.94</c:v>
+                  <c:v>2024</c:v>
                 </c:pt>
                 <c:pt idx="4">
-                  <c:v>4.95</c:v>
+                  <c:v>2025</c:v>
                 </c:pt>
-                <c:pt idx="5">
-                  <c:v>5.22</c:v>
+              </c:strCache>
+            </c:strRef>
+          </c:cat>
+          <c:val>
+            <c:numRef>
+              <c:f>Sheet1!$C$2:$C$6</c:f>
+              <c:numCache>
+                <c:formatCode>General</c:formatCode>
+                <c:ptCount val="5"/>
+                <c:pt idx="0">
+                  <c:v>23.6</c:v>
                 </c:pt>
-                <c:pt idx="6">
-                  <c:v>5.54</c:v>
+                <c:pt idx="1">
+                  <c:v>21.9</c:v>
                 </c:pt>
-                <c:pt idx="7">
-                  <c:v>5.84</c:v>
+                <c:pt idx="2">
+                  <c:v>19.3</c:v>
                 </c:pt>
-                <c:pt idx="8">
-                  <c:v>5.84</c:v>
+                <c:pt idx="3">
+                  <c:v>36.0</c:v>
                 </c:pt>
-                <c:pt idx="9">
-                  <c:v>5.67</c:v>
-                </c:pt>
-                <c:pt idx="10">
-                  <c:v>5.45</c:v>
-                </c:pt>
-                <c:pt idx="11">
-                  <c:v>5.39</c:v>
-                </c:pt>
-                <c:pt idx="12">
-                  <c:v>5.26</c:v>
-                </c:pt>
-                <c:pt idx="13">
-                  <c:v>5.05</c:v>
+                <c:pt idx="4">
+                  <c:v>23.4</c:v>
                 </c:pt>
               </c:numCache>
             </c:numRef>
@@ -2554,10 +1632,12 @@
         <c:axPos val="b"/>
         <c:majorTickMark val="none"/>
         <c:minorTickMark val="none"/>
-        <c:tickLblPos val="none"/>
+        <c:tickLblPos val="nextTo"/>
         <c:spPr>
-          <a:ln>
-            <a:noFill/>
+          <a:ln w="9525">
+            <a:solidFill>
+              <a:srgbClr val="BFBFBF"/>
+            </a:solidFill>
           </a:ln>
         </c:spPr>
         <c:txPr>
@@ -2565,7 +1645,7 @@
           <a:lstStyle/>
           <a:p>
             <a:pPr>
-              <a:defRPr sz="800">
+              <a:defRPr sz="900">
                 <a:solidFill>
                   <a:srgbClr val="595959"/>
                 </a:solidFill>
@@ -2583,8 +1663,8 @@
       <c:valAx>
         <c:axId val="2140495176"/>
         <c:scaling>
-          <c:max val="6.3"/>
-          <c:min val="4.5"/>
+          <c:max val="44.0"/>
+          <c:min val="10.0"/>
         </c:scaling>
         <c:delete/>
         <c:axPos val="l"/>
@@ -2595,8 +1675,22 @@
         <c:crosses val="autoZero"/>
       </c:valAx>
     </c:plotArea>
+    <c:legend>
+      <c:legendPos val="t"/>
+      <c:layout/>
+      <c:overlay val="0"/>
+      <c:txPr>
+        <a:bodyPr/>
+        <a:lstStyle/>
+        <a:p>
+          <a:pPr>
+            <a:defRPr sz="900"/>
+          </a:pPr>
+        </a:p>
+      </c:txPr>
+    </c:legend>
     <c:plotVisOnly val="1"/>
-    <c:dispBlanksAs val="gap"/>
+    <c:dispBlanksAs val="span"/>
     <c:showDLblsOverMax val="0"/>
   </c:chart>
   <c:spPr>
@@ -3059,23 +2153,23 @@
           <a:p/>
           <a:p>
             <a:r>
-              <a:t>III. QUEM MANDA EM CADA ELO (percorra a faixa da esquerda para a direita, depois as barras, 25s)</a:t>
-            </a:r>
-          </a:p>
-          <a:p>
-            <a:r>
-              <a:t>"A Intelbras compra componentes, monta no Brasil e compra produtos prontos de parceiros asiáticos: Dahua em câmeras, H3C em redes. Nos elos críticos, poucos mandam: a TSMC fabrica 70% dos chips do mundo, três empresas fazem 92% da memória, e em câmeras prontas a Intelbras tem um único fornecedor por contrato, a Dahua. A própria empresa admite no FRE que há poucas opções de chipset."</a:t>
+              <a:t>III. MAPA DE SUPRIMENTO (percorra os três elos, depois a barra da Dahua, 25s)</a:t>
+            </a:r>
+          </a:p>
+          <a:p>
+            <a:r>
+              <a:t>"A Intelbras compra componentes, monta as placas no Brasil e compra produtos prontos de parceiros: Dahua em câmeras, H3C em redes, e até janeiro a FiberHome em GPON. Onde a troca é difícil, nos chips e nas câmeras, ela depende de poucos. E um único parceiro, a Dahua, responde por 36% de tudo que ela gasta com fornecedores."</a:t>
             </a:r>
           </a:p>
           <a:p/>
           <a:p>
             <a:r>
-              <a:t>IV. CONSEQUÊNCIA (aponte para o pico do dólar e o vale da margem, 25s)</a:t>
-            </a:r>
-          </a:p>
-          <a:p>
-            <a:r>
-              <a:t>"O resultado aparece na margem. Quando o dólar subiu 18% ao longo de 2024, a margem bruta caiu quase 5 pontos. Quando o dólar caiu 14%, a margem só se recuperou uns quatro trimestres depois. Os ~170 dias de estoque atrasam o efeito. A Intelbras repassa, mas com atraso, e o atraso custa margem."</a:t>
+              <a:t>IV. CONSEQUÊNCIA NO CAPITAL (aponte para o vão entre as barras, 25s)</a:t>
+            </a:r>
+          </a:p>
+          <a:p>
+            <a:r>
+              <a:t>"Comprar longe, em dólar e de poucos tem um custo de capital. A Intelbras carrega uns 170 dias de estoque contra uns 120 de prazo dos fornecedores. Esse vão, de 40 a 70 dias, ela financia com caixa próprio: perto de R$0,4 bilhão em 2025. Em 2021 e 2024 o estoque subiu de propósito, para não faltar produto. E parte do prazo vem da própria Dahua, como veremos agora."</a:t>
             </a:r>
           </a:p>
           <a:p/>
@@ -3086,7 +2180,7 @@
           </a:p>
           <a:p>
             <a:r>
-              <a:t>"Baixo poder de barganha, custo em dólar, repasse atrasado. E entre todos os fornecedores, um pesa mais que os outros: a Dahua."</a:t>
+              <a:t>"Baixo poder de barganha, custo em dólar e estoque alto. E entre todos os fornecedores, um pesa mais que os outros: a Dahua."</a:t>
             </a:r>
           </a:p>
           <a:p/>
@@ -3102,7 +2196,7 @@
           </a:p>
           <a:p>
             <a:r>
-              <a:t>• "A Intelbras compra direto da TSMC?" Não. Compra chips de fabricantes que produzem nessas fábricas. O topo da cadeia é concentrado, então escassez e preço chegam de qualquer jeito (memória em 2026 encareceu os custos no 2T26).</a:t>
+              <a:t>• "Por que os chips são escassos?" A própria Intelbras diz que há poucas opções de chipset e que trocar pode suspender parte da produção (FRE 1.4.e). A estrutura do mercado global de chips (TSMC, memória) fica na análise setorial.</a:t>
             </a:r>
           </a:p>
           <a:p>
@@ -3112,7 +2206,12 @@
           </a:p>
           <a:p>
             <a:r>
-              <a:t>• "Por que a margem subiu no 2T26 com o dólar caindo?" Dois efeitos: o estoque comprado com dólar mais baixo chegou ao custo, e a empresa reprecificou pelo custo de reposição quando os componentes subiram. A própria Intelbras diz que parte é transitória.</a:t>
+              <a:t>• "E o efeito do câmbio na margem?" Fica na análise setorial (eixo de preços): margem bruta × dólar trimestral. Aqui mostramos a exposição (I) e o mecanismo de defesa, que é o estoque (IV).</a:t>
+            </a:r>
+          </a:p>
+          <a:p>
+            <a:r>
+              <a:t>• "Estoque alto é ruim?" É o preço do modelo: garante disponibilidade ao instalador e protege contra falta de componentes. Mas custa capital (ciclo de caixa de 145 dias em 2025) e gera obsolescência (provisão de R$73 mi).</a:t>
             </a:r>
           </a:p>
           <a:p>
@@ -3138,12 +2237,12 @@
           </a:p>
           <a:p>
             <a:r>
-              <a:t>III: TrendForce (TSMC 69,9%, Samsung 7,2%, SMIC 5,3% em 2025; DRAM 3T25: SK hynix 33,2%, Samsung 32,6%, Micron 25,7%). FRE 1.4.e: poucas opções de chipsets; FRE 11.3: prioridade de compra de CFTV pela Dahua até 2028. H3C: parceria em redes corporativas (Teletime, out/2024). 4 fábricas: São José e Tubarão (SC), Manaus (AM), Santa Rita do Sapucaí (MG).</a:t>
-            </a:r>
-          </a:p>
-          <a:p>
-            <a:r>
-              <a:t>IV: Dólar = média trimestral da PTAX mensal (BCB/Numerando): 1T24 4,95; 4T24 5,84 (+18%); 2T26 5,05 (−14%). Margem bruta consolidada (planilha 2T26): 33,9% (1T24), 29,0% (4T24), 33,1% (2T26); 4T23 ajustado em 29,5% (reportado 26,9%, com provisão de estoque). Estoque ≈ 173 dias de CPV (DFP NE 8).</a:t>
+              <a:t>III: FRE 1.4.a (fábricas: São José e Tubarão/SC, Manaus/AM, Santa Rita do Sapucaí/MG; SMD ~450 mi componentes/mês); FRE 1.4.e (três categorias de fornecedores; produtos de fábricas na China, Coreia e Vietnã; poucas opções de chipsets; Dahua 36,0% dos gastos com fornecedores em 2025). FRE 11.3 (prioridade de compra de CFTV pela Dahua até 2028). H3C em redes corporativas (Teletime, out/2024); FiberHome em GPON até 12/01/2026 (Teletime).</a:t>
+            </a:r>
+          </a:p>
+          <a:p>
+            <a:r>
+              <a:t>IV: dias de estoque = estoque ÷ CPV × 365 = 217/161/151/196/173 (2021–25); prazo = (fornecedores + risco sacado) ÷ CPV × 365 = 146/121/113/135/123; vão = 71/40/38/61/50 dias; 2025: 50 × R$3.117,8 mi ÷ 365 ≈ R$427 mi. Estoque elevado para mitigar riscos de suprimento: teleconferências 4T21 (~180 dias) e 4T24. Provisão de obsolescência R$73,1 mi (DFP NE 8).</a:t>
             </a:r>
           </a:p>
         </p:txBody>
@@ -7968,7 +7067,7 @@
           <a:lstStyle/>
           <a:p>
             <a:r>
-              <a:t>Com custo dolarizado, chips escassos e um terço dos gastos em um único fornecedor, a Intelbras aceita o preço na origem e repassa com atraso</a:t>
+              <a:t>Custo em dólar, chips escassos e um terço dos gastos em um só fornecedor: a Intelbras aceita o preço e carrega estoque para garantir o suprimento</a:t>
             </a:r>
           </a:p>
         </p:txBody>
@@ -8073,7 +7172,7 @@
           <a:lstStyle/>
           <a:p>
             <a:r>
-              <a:t>III. Do chip ao produto pronto, poucos fornecedores mandam em cada elo</a:t>
+              <a:t>III. A Intelbras monta pouco e depende de poucos parceiros nos elos críticos</a:t>
             </a:r>
           </a:p>
         </p:txBody>
@@ -8094,7 +7193,7 @@
           <a:lstStyle/>
           <a:p>
             <a:r>
-              <a:t>O que a Intelbras compra e quem domina cada elo (% do mercado ou do fornecimento)</a:t>
+              <a:t>O que a Intelbras compra, de quem e se dá para trocar</a:t>
             </a:r>
           </a:p>
         </p:txBody>
@@ -8115,7 +7214,7 @@
           <a:lstStyle/>
           <a:p>
             <a:r>
-              <a:t>IV. Consequência: a margem anda contra o dólar, e o repasse chega com atraso</a:t>
+              <a:t>IV. Consequência: o modelo exige estoque alto, financiado em parte por fornecedores</a:t>
             </a:r>
           </a:p>
         </p:txBody>
@@ -8136,7 +7235,7 @@
           <a:lstStyle/>
           <a:p>
             <a:r>
-              <a:t>Dólar médio do trimestre (R$) e margem bruta consolidada (%)</a:t>
+              <a:t>Dias de estoque vs prazo médio pago aos fornecedores (dias de custo)</a:t>
             </a:r>
           </a:p>
         </p:txBody>
@@ -8157,7 +7256,7 @@
           <a:lstStyle/>
           <a:p>
             <a:r>
-              <a:t>Fontes: Intelbras DFP 2025 (NE 14, 23, 25, 27), FRE 2026 (1.4.e, 2.2) e planilha 2T26; TrendForce (chips 2025; DRAM 3T25); Teletime (H3C, FiberHome); BCB/Numerando (PTAX média). 4T23: margem ajustada (ex-provisão de estoque).</a:t>
+              <a:t>Fontes: Intelbras DFPs 2021–25 (NE 8, 14, 23, 25, 27), FRE 2026 (1.4.a, 1.4.e, 2.2), planilha 2T26 e teleconferências 4T21/4T24; Teletime (H3C, FiberHome). Dias = estoque e fornecedores (incl. risco sacado) ÷ custo dos produtos vendidos × 365.</a:t>
             </a:r>
           </a:p>
         </p:txBody>
@@ -8351,7 +7450,7 @@
         <p:spPr>
           <a:xfrm>
             <a:off x="566928" y="4425696"/>
-            <a:ext cx="1682496" cy="566928"/>
+            <a:ext cx="1682496" cy="530352"/>
           </a:xfrm>
           <a:prstGeom prst="roundRect">
             <a:avLst>
@@ -8415,7 +7514,7 @@
         </p:nvCxnSpPr>
         <p:spPr>
           <a:xfrm>
-            <a:off x="2276856" y="4709159"/>
+            <a:off x="2276856" y="4690872"/>
             <a:ext cx="192024" cy="0"/>
           </a:xfrm>
           <a:prstGeom prst="line">
@@ -8445,14 +7544,52 @@
       </p:cxnSp>
       <p:sp>
         <p:nvSpPr>
-          <p:cNvPr id="23" name="Elo 2"/>
+          <p:cNvPr id="23" name="Detalhe elo 1"/>
+          <p:cNvSpPr txBox="1"/>
+          <p:nvPr/>
+        </p:nvSpPr>
+        <p:spPr>
+          <a:xfrm>
+            <a:off x="566928" y="5020056"/>
+            <a:ext cx="1682496" cy="566928"/>
+          </a:xfrm>
+          <a:prstGeom prst="rect">
+            <a:avLst/>
+          </a:prstGeom>
+          <a:noFill/>
+        </p:spPr>
+        <p:txBody>
+          <a:bodyPr wrap="square" lIns="0" rIns="0" tIns="0" bIns="0" anchor="t">
+            <a:spAutoFit/>
+          </a:bodyPr>
+          <a:lstStyle/>
+          <a:p>
+            <a:pPr algn="ctr">
+              <a:spcAft>
+                <a:spcPts val="0"/>
+              </a:spcAft>
+            </a:pPr>
+            <a:r>
+              <a:rPr sz="850" b="0" i="0">
+                <a:solidFill>
+                  <a:srgbClr val="595959"/>
+                </a:solidFill>
+              </a:rPr>
+              <a:t>Fornecedores asiáticos. Chips: troca difícil (“poucas opções”, FRE). Placas e ABS: substituíveis</a:t>
+            </a:r>
+          </a:p>
+        </p:txBody>
+      </p:sp>
+      <p:sp>
+        <p:nvSpPr>
+          <p:cNvPr id="24" name="Elo 2"/>
           <p:cNvSpPr/>
           <p:nvPr/>
         </p:nvSpPr>
         <p:spPr>
           <a:xfrm>
             <a:off x="2496312" y="4425696"/>
-            <a:ext cx="1682496" cy="566928"/>
+            <a:ext cx="1682496" cy="530352"/>
           </a:xfrm>
           <a:prstGeom prst="roundRect">
             <a:avLst>
@@ -8510,13 +7647,13 @@
       </p:sp>
       <p:cxnSp>
         <p:nvCxnSpPr>
-          <p:cNvPr id="24" name="Connector 23"/>
+          <p:cNvPr id="25" name="Connector 24"/>
           <p:cNvCxnSpPr/>
           <p:nvPr/>
         </p:nvCxnSpPr>
         <p:spPr>
           <a:xfrm>
-            <a:off x="4206240" y="4709159"/>
+            <a:off x="4206240" y="4690872"/>
             <a:ext cx="192024" cy="0"/>
           </a:xfrm>
           <a:prstGeom prst="line">
@@ -8546,14 +7683,52 @@
       </p:cxnSp>
       <p:sp>
         <p:nvSpPr>
-          <p:cNvPr id="25" name="Elo 3"/>
+          <p:cNvPr id="26" name="Detalhe elo 2"/>
+          <p:cNvSpPr txBox="1"/>
+          <p:nvPr/>
+        </p:nvSpPr>
+        <p:spPr>
+          <a:xfrm>
+            <a:off x="2496312" y="5020056"/>
+            <a:ext cx="1682496" cy="566928"/>
+          </a:xfrm>
+          <a:prstGeom prst="rect">
+            <a:avLst/>
+          </a:prstGeom>
+          <a:noFill/>
+        </p:spPr>
+        <p:txBody>
+          <a:bodyPr wrap="square" lIns="0" rIns="0" tIns="0" bIns="0" anchor="t">
+            <a:spAutoFit/>
+          </a:bodyPr>
+          <a:lstStyle/>
+          <a:p>
+            <a:pPr algn="ctr">
+              <a:spcAft>
+                <a:spcPts val="0"/>
+              </a:spcAft>
+            </a:pPr>
+            <a:r>
+              <a:rPr sz="850" b="0" i="0">
+                <a:solidFill>
+                  <a:srgbClr val="595959"/>
+                </a:solidFill>
+              </a:rPr>
+              <a:t>Própria: placas montadas em linhas SMD, homologação e processo produtivo exigido pelos incentivos</a:t>
+            </a:r>
+          </a:p>
+        </p:txBody>
+      </p:sp>
+      <p:sp>
+        <p:nvSpPr>
+          <p:cNvPr id="27" name="Elo 3"/>
           <p:cNvSpPr/>
           <p:nvPr/>
         </p:nvSpPr>
         <p:spPr>
           <a:xfrm>
             <a:off x="4425696" y="4425696"/>
-            <a:ext cx="1682496" cy="566928"/>
+            <a:ext cx="1682496" cy="530352"/>
           </a:xfrm>
           <a:prstGeom prst="roundRect">
             <a:avLst>
@@ -8604,22 +7779,202 @@
                   <a:srgbClr val="FFFFFF"/>
                 </a:solidFill>
               </a:rPr>
-              <a:t>Dahua (CFTV), H3C (redes), OEMs na Ásia</a:t>
+              <a:t>comprado de parceiros</a:t>
+            </a:r>
+          </a:p>
+        </p:txBody>
+      </p:sp>
+      <p:sp>
+        <p:nvSpPr>
+          <p:cNvPr id="28" name="Detalhe elo 3"/>
+          <p:cNvSpPr txBox="1"/>
+          <p:nvPr/>
+        </p:nvSpPr>
+        <p:spPr>
+          <a:xfrm>
+            <a:off x="4425696" y="5020056"/>
+            <a:ext cx="1682496" cy="566928"/>
+          </a:xfrm>
+          <a:prstGeom prst="rect">
+            <a:avLst/>
+          </a:prstGeom>
+          <a:noFill/>
+        </p:spPr>
+        <p:txBody>
+          <a:bodyPr wrap="square" lIns="0" rIns="0" tIns="0" bIns="0" anchor="t">
+            <a:spAutoFit/>
+          </a:bodyPr>
+          <a:lstStyle/>
+          <a:p>
+            <a:pPr algn="ctr">
+              <a:spcAft>
+                <a:spcPts val="0"/>
+              </a:spcAft>
+            </a:pPr>
+            <a:r>
+              <a:rPr sz="850" b="0" i="0">
+                <a:solidFill>
+                  <a:srgbClr val="595959"/>
+                </a:solidFill>
+              </a:rPr>
+              <a:t>Dahua (CFTV, por contrato até 2028), H3C (redes), FiberHome (GPON, até jan/26), OEMs na Ásia</a:t>
+            </a:r>
+          </a:p>
+        </p:txBody>
+      </p:sp>
+      <p:sp>
+        <p:nvSpPr>
+          <p:cNvPr id="29" name="Rotulo peso Dahua"/>
+          <p:cNvSpPr txBox="1"/>
+          <p:nvPr/>
+        </p:nvSpPr>
+        <p:spPr>
+          <a:xfrm>
+            <a:off x="566928" y="5669280"/>
+            <a:ext cx="5532120" cy="164592"/>
+          </a:xfrm>
+          <a:prstGeom prst="rect">
+            <a:avLst/>
+          </a:prstGeom>
+          <a:noFill/>
+        </p:spPr>
+        <p:txBody>
+          <a:bodyPr wrap="square" lIns="0" rIns="0" tIns="0" bIns="0" anchor="t">
+            <a:spAutoFit/>
+          </a:bodyPr>
+          <a:lstStyle/>
+          <a:p>
+            <a:pPr algn="l">
+              <a:spcAft>
+                <a:spcPts val="0"/>
+              </a:spcAft>
+            </a:pPr>
+            <a:r>
+              <a:rPr sz="800" b="1" i="0">
+                <a:solidFill>
+                  <a:srgbClr val="6B6B6B"/>
+                </a:solidFill>
+              </a:rPr>
+              <a:t>Peso do maior fornecedor nos gastos, 2025</a:t>
+            </a:r>
+          </a:p>
+        </p:txBody>
+      </p:sp>
+      <p:sp>
+        <p:nvSpPr>
+          <p:cNvPr id="30" name="Barra Dahua 36"/>
+          <p:cNvSpPr/>
+          <p:nvPr/>
+        </p:nvSpPr>
+        <p:spPr>
+          <a:xfrm>
+            <a:off x="566928" y="5852160"/>
+            <a:ext cx="1991563" cy="384048"/>
+          </a:xfrm>
+          <a:prstGeom prst="rect">
+            <a:avLst/>
+          </a:prstGeom>
+          <a:solidFill>
+            <a:srgbClr val="009F41"/>
+          </a:solidFill>
+          <a:ln>
+            <a:noFill/>
+          </a:ln>
+          <a:effectLst/>
+        </p:spPr>
+        <p:style>
+          <a:lnRef idx="1">
+            <a:schemeClr val="accent1"/>
+          </a:lnRef>
+          <a:fillRef idx="3">
+            <a:schemeClr val="accent1"/>
+          </a:fillRef>
+          <a:effectRef idx="2">
+            <a:schemeClr val="accent1"/>
+          </a:effectRef>
+          <a:fontRef idx="minor">
+            <a:schemeClr val="lt1"/>
+          </a:fontRef>
+        </p:style>
+        <p:txBody>
+          <a:bodyPr rtlCol="0" anchor="ctr" lIns="45720" rIns="45720"/>
+          <a:lstStyle/>
+          <a:p>
+            <a:pPr algn="ctr"/>
+            <a:r>
+              <a:rPr sz="1100" b="1">
+                <a:solidFill>
+                  <a:srgbClr val="FFFFFF"/>
+                </a:solidFill>
+              </a:rPr>
+              <a:t>Dahua  36%</a:t>
+            </a:r>
+          </a:p>
+        </p:txBody>
+      </p:sp>
+      <p:sp>
+        <p:nvSpPr>
+          <p:cNvPr id="31" name="Barra demais 64"/>
+          <p:cNvSpPr/>
+          <p:nvPr/>
+        </p:nvSpPr>
+        <p:spPr>
+          <a:xfrm>
+            <a:off x="2585923" y="5852160"/>
+            <a:ext cx="3513124" cy="384048"/>
+          </a:xfrm>
+          <a:prstGeom prst="rect">
+            <a:avLst/>
+          </a:prstGeom>
+          <a:solidFill>
+            <a:srgbClr val="E3E3E3"/>
+          </a:solidFill>
+          <a:ln>
+            <a:noFill/>
+          </a:ln>
+          <a:effectLst/>
+        </p:spPr>
+        <p:style>
+          <a:lnRef idx="1">
+            <a:schemeClr val="accent1"/>
+          </a:lnRef>
+          <a:fillRef idx="3">
+            <a:schemeClr val="accent1"/>
+          </a:fillRef>
+          <a:effectRef idx="2">
+            <a:schemeClr val="accent1"/>
+          </a:effectRef>
+          <a:fontRef idx="minor">
+            <a:schemeClr val="lt1"/>
+          </a:fontRef>
+        </p:style>
+        <p:txBody>
+          <a:bodyPr rtlCol="0" anchor="ctr" lIns="45720" rIns="45720"/>
+          <a:lstStyle/>
+          <a:p>
+            <a:pPr algn="ctr"/>
+            <a:r>
+              <a:rPr sz="1100" b="0">
+                <a:solidFill>
+                  <a:srgbClr val="595959"/>
+                </a:solidFill>
+              </a:rPr>
+              <a:t>Todos os demais fornecedores  64%</a:t>
             </a:r>
           </a:p>
         </p:txBody>
       </p:sp>
       <p:graphicFrame>
         <p:nvGraphicFramePr>
-          <p:cNvPr id="26" name="Grafico concentracao por elo"/>
+          <p:cNvPr id="32" name="Grafico estoque vs prazo"/>
           <p:cNvGraphicFramePr>
             <a:graphicFrameLocks noGrp="1"/>
           </p:cNvGraphicFramePr>
           <p:nvPr/>
         </p:nvGraphicFramePr>
         <p:xfrm>
-          <a:off x="566928" y="5047488"/>
-          <a:ext cx="5532120" cy="1307592"/>
+          <a:off x="6428232" y="4407408"/>
+          <a:ext cx="3840480" cy="1984248"/>
         </p:xfrm>
         <a:graphic>
           <a:graphicData uri="http://schemas.openxmlformats.org/drawingml/2006/chart">
@@ -8629,14 +7984,14 @@
       </p:graphicFrame>
       <p:sp>
         <p:nvSpPr>
-          <p:cNvPr id="27" name="Rotulo dolar"/>
+          <p:cNvPr id="33" name="Callout capital de giro"/>
           <p:cNvSpPr txBox="1"/>
           <p:nvPr/>
         </p:nvSpPr>
         <p:spPr>
           <a:xfrm>
-            <a:off x="6428232" y="4398264"/>
-            <a:ext cx="3977639" cy="164592"/>
+            <a:off x="10405872" y="4498848"/>
+            <a:ext cx="1554480" cy="1874519"/>
           </a:xfrm>
           <a:prstGeom prst="rect">
             <a:avLst/>
@@ -8655,55 +8010,29 @@
               </a:spcAft>
             </a:pPr>
             <a:r>
-              <a:rPr sz="800" b="1" i="0">
+              <a:rPr sz="2000" b="1" i="0">
+                <a:solidFill>
+                  <a:srgbClr val="009F41"/>
+                </a:solidFill>
+              </a:rPr>
+              <a:t>~40–70 dias</a:t>
+            </a:r>
+          </a:p>
+          <a:p>
+            <a:pPr algn="l">
+              <a:spcAft>
+                <a:spcPts val="800"/>
+              </a:spcAft>
+            </a:pPr>
+            <a:r>
+              <a:rPr sz="1000" b="0" i="0">
                 <a:solidFill>
                   <a:srgbClr val="595959"/>
                 </a:solidFill>
               </a:rPr>
-              <a:t>Dólar médio (R$)</a:t>
-            </a:r>
-          </a:p>
-        </p:txBody>
-      </p:sp>
-      <p:graphicFrame>
-        <p:nvGraphicFramePr>
-          <p:cNvPr id="28" name="Grafico dolar trimestral"/>
-          <p:cNvGraphicFramePr>
-            <a:graphicFrameLocks noGrp="1"/>
-          </p:cNvGraphicFramePr>
-          <p:nvPr/>
-        </p:nvGraphicFramePr>
-        <p:xfrm>
-          <a:off x="6428232" y="4498848"/>
-          <a:ext cx="3977639" cy="713232"/>
-        </p:xfrm>
-        <a:graphic>
-          <a:graphicData uri="http://schemas.openxmlformats.org/drawingml/2006/chart">
-            <c:chart xmlns:c="http://schemas.openxmlformats.org/drawingml/2006/chart" r:id="rId5"/>
-          </a:graphicData>
-        </a:graphic>
-      </p:graphicFrame>
-      <p:sp>
-        <p:nvSpPr>
-          <p:cNvPr id="29" name="Rotulo margem"/>
-          <p:cNvSpPr txBox="1"/>
-          <p:nvPr/>
-        </p:nvSpPr>
-        <p:spPr>
-          <a:xfrm>
-            <a:off x="6428232" y="5230368"/>
-            <a:ext cx="3977639" cy="164592"/>
-          </a:xfrm>
-          <a:prstGeom prst="rect">
-            <a:avLst/>
-          </a:prstGeom>
-          <a:noFill/>
-        </p:spPr>
-        <p:txBody>
-          <a:bodyPr wrap="square" lIns="0" rIns="0" tIns="0" bIns="0" anchor="t">
-            <a:spAutoFit/>
-          </a:bodyPr>
-          <a:lstStyle/>
+              <a:t>de compras que a Intelbras financia com caixa próprio (≈R$0,4 bi em 2025)</a:t>
+            </a:r>
+          </a:p>
           <a:p>
             <a:pPr algn="l">
               <a:spcAft>
@@ -8711,152 +8040,20 @@
               </a:spcAft>
             </a:pPr>
             <a:r>
-              <a:rPr sz="800" b="1" i="0">
-                <a:solidFill>
-                  <a:srgbClr val="009F41"/>
+              <a:rPr sz="1000" b="1" i="0">
+                <a:solidFill>
+                  <a:srgbClr val="1A1A1A"/>
                 </a:solidFill>
               </a:rPr>
-              <a:t>Margem bruta (%)</a:t>
-            </a:r>
-          </a:p>
-        </p:txBody>
-      </p:sp>
-      <p:graphicFrame>
-        <p:nvGraphicFramePr>
-          <p:cNvPr id="30" name="Grafico margem trimestral"/>
-          <p:cNvGraphicFramePr>
-            <a:graphicFrameLocks noGrp="1"/>
-          </p:cNvGraphicFramePr>
-          <p:nvPr/>
-        </p:nvGraphicFramePr>
-        <p:xfrm>
-          <a:off x="6428232" y="5303520"/>
-          <a:ext cx="3977639" cy="1097280"/>
-        </p:xfrm>
-        <a:graphic>
-          <a:graphicData uri="http://schemas.openxmlformats.org/drawingml/2006/chart">
-            <c:chart xmlns:c="http://schemas.openxmlformats.org/drawingml/2006/chart" r:id="rId6"/>
-          </a:graphicData>
-        </a:graphic>
-      </p:graphicFrame>
-      <p:sp>
-        <p:nvSpPr>
-          <p:cNvPr id="31" name="Callout cambio margem"/>
-          <p:cNvSpPr txBox="1"/>
-          <p:nvPr/>
-        </p:nvSpPr>
-        <p:spPr>
-          <a:xfrm>
-            <a:off x="10515599" y="4453128"/>
-            <a:ext cx="1444752" cy="1920240"/>
-          </a:xfrm>
-          <a:prstGeom prst="rect">
-            <a:avLst/>
-          </a:prstGeom>
-          <a:noFill/>
-        </p:spPr>
-        <p:txBody>
-          <a:bodyPr wrap="square" lIns="0" rIns="0" tIns="0" bIns="0" anchor="t">
-            <a:spAutoFit/>
-          </a:bodyPr>
-          <a:lstStyle/>
-          <a:p>
-            <a:pPr algn="l">
-              <a:spcAft>
-                <a:spcPts val="0"/>
-              </a:spcAft>
-            </a:pPr>
-            <a:r>
-              <a:rPr sz="1200" b="1" i="0">
-                <a:solidFill>
-                  <a:srgbClr val="1A1A1A"/>
+              <a:t>2021 e 2024: </a:t>
+            </a:r>
+            <a:r>
+              <a:rPr sz="1000" b="0" i="0">
+                <a:solidFill>
+                  <a:srgbClr val="595959"/>
                 </a:solidFill>
               </a:rPr>
-              <a:t>Dólar +18%</a:t>
-            </a:r>
-            <a:r>
-              <a:rPr sz="900" b="0" i="0">
-                <a:solidFill>
-                  <a:srgbClr val="595959"/>
-                </a:solidFill>
-              </a:rPr>
-              <a:t> (1T→4T24)</a:t>
-            </a:r>
-          </a:p>
-          <a:p>
-            <a:pPr algn="l">
-              <a:spcAft>
-                <a:spcPts val="800"/>
-              </a:spcAft>
-            </a:pPr>
-            <a:r>
-              <a:rPr sz="1100" b="1" i="0">
-                <a:solidFill>
-                  <a:srgbClr val="009F41"/>
-                </a:solidFill>
-              </a:rPr>
-              <a:t>→ margem −4,9 p.p.</a:t>
-            </a:r>
-          </a:p>
-          <a:p>
-            <a:pPr algn="l">
-              <a:spcAft>
-                <a:spcPts val="0"/>
-              </a:spcAft>
-            </a:pPr>
-            <a:r>
-              <a:rPr sz="1200" b="1" i="0">
-                <a:solidFill>
-                  <a:srgbClr val="1A1A1A"/>
-                </a:solidFill>
-              </a:rPr>
-              <a:t>Dólar −14%</a:t>
-            </a:r>
-            <a:r>
-              <a:rPr sz="900" b="0" i="0">
-                <a:solidFill>
-                  <a:srgbClr val="595959"/>
-                </a:solidFill>
-              </a:rPr>
-              <a:t> (4T24→2T26)</a:t>
-            </a:r>
-          </a:p>
-          <a:p>
-            <a:pPr algn="l">
-              <a:spcAft>
-                <a:spcPts val="800"/>
-              </a:spcAft>
-            </a:pPr>
-            <a:r>
-              <a:rPr sz="1100" b="1" i="0">
-                <a:solidFill>
-                  <a:srgbClr val="009F41"/>
-                </a:solidFill>
-              </a:rPr>
-              <a:t>→ margem +4,1 p.p.</a:t>
-            </a:r>
-            <a:r>
-              <a:rPr sz="900" b="0" i="0">
-                <a:solidFill>
-                  <a:srgbClr val="595959"/>
-                </a:solidFill>
-              </a:rPr>
-              <a:t>, só ~4 trimestres depois</a:t>
-            </a:r>
-          </a:p>
-          <a:p>
-            <a:pPr algn="l">
-              <a:spcAft>
-                <a:spcPts val="0"/>
-              </a:spcAft>
-            </a:pPr>
-            <a:r>
-              <a:rPr sz="900" b="0" i="1">
-                <a:solidFill>
-                  <a:srgbClr val="595959"/>
-                </a:solidFill>
-              </a:rPr>
-              <a:t>~170 dias de estoque atrasam o efeito do câmbio</a:t>
+              <a:t>estoque elevado de propósito, para proteger o suprimento</a:t>
             </a:r>
           </a:p>
         </p:txBody>

</xml_diff>

<commit_message>
Make supplier and Dahua slides lean, Senna-style
Slide 1 moves to the two-block layout (cost in dollars vs revenue in
reais; inventory vs supplier terms) with one highlighted number each;
assembly content removed. Slide 2 keeps four quadrants with micro-thesis
headers, one chart each and minimal text; details moved to notes.

Co-Authored-By: Claude Opus 5.5 <noreply@anthropic.com>
Claude-Session: https://claude.ai/code/session_01KnzCLDRo32uUYqhzKjGgJD
</commit_message>
<xml_diff>
--- a/intelbras_fornecedores_dahua.pptx
+++ b/intelbras_fornecedores_dahua.pptx
@@ -199,7 +199,7 @@
                   <a:lstStyle/>
                   <a:p>
                     <a:r>
-                      <a:rPr sz="1000" b="1">
+                      <a:rPr sz="1100" b="1">
                         <a:solidFill>
                           <a:srgbClr val="1A1A1A"/>
                         </a:solidFill>
@@ -225,7 +225,7 @@
                   <a:lstStyle/>
                   <a:p>
                     <a:r>
-                      <a:rPr sz="1000" b="1">
+                      <a:rPr sz="1100" b="1">
                         <a:solidFill>
                           <a:srgbClr val="1A1A1A"/>
                         </a:solidFill>
@@ -251,7 +251,7 @@
                   <a:lstStyle/>
                   <a:p>
                     <a:r>
-                      <a:rPr sz="1000" b="1">
+                      <a:rPr sz="1100" b="1">
                         <a:solidFill>
                           <a:srgbClr val="1A1A1A"/>
                         </a:solidFill>
@@ -277,7 +277,7 @@
                   <a:lstStyle/>
                   <a:p>
                     <a:r>
-                      <a:rPr sz="1000" b="1">
+                      <a:rPr sz="1100" b="1">
                         <a:solidFill>
                           <a:srgbClr val="1A1A1A"/>
                         </a:solidFill>
@@ -303,7 +303,7 @@
                   <a:lstStyle/>
                   <a:p>
                     <a:r>
-                      <a:rPr sz="1000" b="1">
+                      <a:rPr sz="1100" b="1">
                         <a:solidFill>
                           <a:srgbClr val="1A1A1A"/>
                         </a:solidFill>
@@ -408,7 +408,7 @@
           <a:lstStyle/>
           <a:p>
             <a:pPr>
-              <a:defRPr sz="900">
+              <a:defRPr sz="1000">
                 <a:solidFill>
                   <a:srgbClr val="595959"/>
                 </a:solidFill>
@@ -451,7 +451,7 @@
     <a:lstStyle/>
     <a:p>
       <a:pPr>
-        <a:defRPr sz="900">
+        <a:defRPr sz="1000">
           <a:solidFill>
             <a:srgbClr val="595959"/>
           </a:solidFill>
@@ -485,7 +485,7 @@
               <c:strCache>
                 <c:ptCount val="1"/>
                 <c:pt idx="0">
-                  <c:v>Moeda estrangeira</c:v>
+                  <c:v>%</c:v>
                 </c:pt>
               </c:strCache>
             </c:strRef>
@@ -510,6 +510,14 @@
             <c:idx val="2"/>
             <c:spPr>
               <a:solidFill>
+                <a:srgbClr val="1A1A1A"/>
+              </a:solidFill>
+            </c:spPr>
+          </c:dPt>
+          <c:dPt>
+            <c:idx val="3"/>
+            <c:spPr>
+              <a:solidFill>
                 <a:srgbClr val="009F41"/>
               </a:solidFill>
             </c:spPr>
@@ -523,12 +531,12 @@
                   <a:lstStyle/>
                   <a:p>
                     <a:r>
-                      <a:rPr sz="1100" b="1">
+                      <a:rPr sz="1200" b="1">
                         <a:solidFill>
                           <a:srgbClr val="1A1A1A"/>
                         </a:solidFill>
                       </a:rPr>
-                      <a:t>~80%</a:t>
+                      <a:t>85%</a:t>
                     </a:r>
                   </a:p>
                 </c:rich>
@@ -549,12 +557,12 @@
                   <a:lstStyle/>
                   <a:p>
                     <a:r>
-                      <a:rPr sz="1100" b="1">
+                      <a:rPr sz="1200" b="1">
                         <a:solidFill>
                           <a:srgbClr val="1A1A1A"/>
                         </a:solidFill>
                       </a:rPr>
-                      <a:t>92%</a:t>
+                      <a:t>~80%</a:t>
                     </a:r>
                   </a:p>
                 </c:rich>
@@ -575,7 +583,33 @@
                   <a:lstStyle/>
                   <a:p>
                     <a:r>
-                      <a:rPr sz="1100" b="1">
+                      <a:rPr sz="1200" b="1">
+                        <a:solidFill>
+                          <a:srgbClr val="1A1A1A"/>
+                        </a:solidFill>
+                      </a:rPr>
+                      <a:t>92%</a:t>
+                    </a:r>
+                  </a:p>
+                </c:rich>
+              </c:tx>
+              <c:dLblPos val="outEnd"/>
+              <c:showLegendKey val="0"/>
+              <c:showVal val="1"/>
+              <c:showCatName val="0"/>
+              <c:showSerName val="0"/>
+              <c:showPercent val="0"/>
+              <c:showBubbleSize val="0"/>
+            </c:dLbl>
+            <c:dLbl>
+              <c:idx val="3"/>
+              <c:tx>
+                <c:rich>
+                  <a:bodyPr/>
+                  <a:lstStyle/>
+                  <a:p>
+                    <a:r>
+                      <a:rPr sz="1200" b="1">
                         <a:solidFill>
                           <a:srgbClr val="1A1A1A"/>
                         </a:solidFill>
@@ -603,41 +637,47 @@
           </c:dLbls>
           <c:cat>
             <c:strRef>
-              <c:f>Sheet1!$A$2:$A$4</c:f>
+              <c:f>Sheet1!$A$2:$A$5</c:f>
               <c:strCache>
-                <c:ptCount val="3"/>
+                <c:ptCount val="4"/>
                 <c:pt idx="0">
-                  <c:v>Custo dos produtos vendidos</c:v>
+                  <c:v>Custo comprado de terceiros</c:v>
                 </c:pt>
                 <c:pt idx="1">
-                  <c:v>Contas a pagar a fornecedores</c:v>
+                  <c:v>Custo atrelado ao dólar</c:v>
                 </c:pt>
                 <c:pt idx="2">
-                  <c:v>Contas a receber de clientes</c:v>
+                  <c:v>Contas a pagar no exterior</c:v>
+                </c:pt>
+                <c:pt idx="3">
+                  <c:v>Contas a receber em moeda estrangeira</c:v>
                 </c:pt>
               </c:strCache>
             </c:strRef>
           </c:cat>
           <c:val>
             <c:numRef>
-              <c:f>Sheet1!$B$2:$B$4</c:f>
+              <c:f>Sheet1!$B$2:$B$5</c:f>
               <c:numCache>
                 <c:formatCode>General</c:formatCode>
-                <c:ptCount val="3"/>
+                <c:ptCount val="4"/>
                 <c:pt idx="0">
+                  <c:v>85.5</c:v>
+                </c:pt>
+                <c:pt idx="1">
                   <c:v>80.0</c:v>
                 </c:pt>
-                <c:pt idx="1">
+                <c:pt idx="2">
                   <c:v>91.5</c:v>
                 </c:pt>
-                <c:pt idx="2">
+                <c:pt idx="3">
                   <c:v>4.1</c:v>
                 </c:pt>
               </c:numCache>
             </c:numRef>
           </c:val>
         </c:ser>
-        <c:gapWidth val="40"/>
+        <c:gapWidth val="45"/>
         <c:axId val="-2068027336"/>
         <c:axId val="-2113994440"/>
       </c:barChart>
@@ -661,7 +701,7 @@
           <a:lstStyle/>
           <a:p>
             <a:pPr>
-              <a:defRPr sz="1000">
+              <a:defRPr sz="1100">
                 <a:solidFill>
                   <a:srgbClr val="595959"/>
                 </a:solidFill>
@@ -679,7 +719,7 @@
       <c:valAx>
         <c:axId val="-2113994440"/>
         <c:scaling>
-          <c:max val="115.0"/>
+          <c:max val="108.0"/>
           <c:min val="0.0"/>
         </c:scaling>
         <c:delete/>
@@ -704,7 +744,7 @@
     <a:lstStyle/>
     <a:p>
       <a:pPr>
-        <a:defRPr sz="900">
+        <a:defRPr sz="1100">
           <a:solidFill>
             <a:srgbClr val="595959"/>
           </a:solidFill>
@@ -721,259 +761,6 @@
 </file>
 
 <file path=ppt/charts/chart7.xml><?xml version="1.0" encoding="utf-8"?>
-<c:chartSpace xmlns:c="http://schemas.openxmlformats.org/drawingml/2006/chart" xmlns:a="http://schemas.openxmlformats.org/drawingml/2006/main" xmlns:r="http://schemas.openxmlformats.org/officeDocument/2006/relationships">
-  <c:date1904 val="0"/>
-  <c:chart>
-    <c:autoTitleDeleted val="1"/>
-    <c:plotArea>
-      <c:barChart>
-        <c:barDir val="bar"/>
-        <c:grouping val="clustered"/>
-        <c:ser>
-          <c:idx val="0"/>
-          <c:order val="0"/>
-          <c:tx>
-            <c:strRef>
-              <c:f>Sheet1!$B$1</c:f>
-              <c:strCache>
-                <c:ptCount val="1"/>
-                <c:pt idx="0">
-                  <c:v>R$ mi</c:v>
-                </c:pt>
-              </c:strCache>
-            </c:strRef>
-          </c:tx>
-          <c:dPt>
-            <c:idx val="0"/>
-            <c:spPr>
-              <a:solidFill>
-                <a:srgbClr val="BFBFBF"/>
-              </a:solidFill>
-            </c:spPr>
-          </c:dPt>
-          <c:dPt>
-            <c:idx val="1"/>
-            <c:spPr>
-              <a:solidFill>
-                <a:srgbClr val="1A1A1A"/>
-              </a:solidFill>
-            </c:spPr>
-          </c:dPt>
-          <c:dPt>
-            <c:idx val="2"/>
-            <c:spPr>
-              <a:solidFill>
-                <a:srgbClr val="009F41"/>
-              </a:solidFill>
-            </c:spPr>
-          </c:dPt>
-          <c:dLbls>
-            <c:dLbl>
-              <c:idx val="0"/>
-              <c:tx>
-                <c:rich>
-                  <a:bodyPr/>
-                  <a:lstStyle/>
-                  <a:p>
-                    <a:r>
-                      <a:rPr sz="1100" b="1">
-                        <a:solidFill>
-                          <a:srgbClr val="1A1A1A"/>
-                        </a:solidFill>
-                      </a:rPr>
-                      <a:t>2.667 (85%)</a:t>
-                    </a:r>
-                  </a:p>
-                </c:rich>
-              </c:tx>
-              <c:dLblPos val="outEnd"/>
-              <c:showLegendKey val="0"/>
-              <c:showVal val="1"/>
-              <c:showCatName val="0"/>
-              <c:showSerName val="0"/>
-              <c:showPercent val="0"/>
-              <c:showBubbleSize val="0"/>
-            </c:dLbl>
-            <c:dLbl>
-              <c:idx val="1"/>
-              <c:tx>
-                <c:rich>
-                  <a:bodyPr/>
-                  <a:lstStyle/>
-                  <a:p>
-                    <a:r>
-                      <a:rPr sz="1100" b="1">
-                        <a:solidFill>
-                          <a:srgbClr val="1A1A1A"/>
-                        </a:solidFill>
-                      </a:rPr>
-                      <a:t>451 (15%)</a:t>
-                    </a:r>
-                  </a:p>
-                </c:rich>
-              </c:tx>
-              <c:dLblPos val="outEnd"/>
-              <c:showLegendKey val="0"/>
-              <c:showVal val="1"/>
-              <c:showCatName val="0"/>
-              <c:showSerName val="0"/>
-              <c:showPercent val="0"/>
-              <c:showBubbleSize val="0"/>
-            </c:dLbl>
-            <c:dLbl>
-              <c:idx val="2"/>
-              <c:tx>
-                <c:rich>
-                  <a:bodyPr/>
-                  <a:lstStyle/>
-                  <a:p>
-                    <a:r>
-                      <a:rPr sz="1100" b="1">
-                        <a:solidFill>
-                          <a:srgbClr val="1A1A1A"/>
-                        </a:solidFill>
-                      </a:rPr>
-                      <a:t>460</a:t>
-                    </a:r>
-                  </a:p>
-                </c:rich>
-              </c:tx>
-              <c:dLblPos val="outEnd"/>
-              <c:showLegendKey val="0"/>
-              <c:showVal val="1"/>
-              <c:showCatName val="0"/>
-              <c:showSerName val="0"/>
-              <c:showPercent val="0"/>
-              <c:showBubbleSize val="0"/>
-            </c:dLbl>
-            <c:showLegendKey val="0"/>
-            <c:showVal val="0"/>
-            <c:showCatName val="0"/>
-            <c:showSerName val="0"/>
-            <c:showPercent val="0"/>
-            <c:showBubbleSize val="0"/>
-            <c:showLeaderLines val="1"/>
-          </c:dLbls>
-          <c:cat>
-            <c:strRef>
-              <c:f>Sheet1!$A$2:$A$4</c:f>
-              <c:strCache>
-                <c:ptCount val="3"/>
-                <c:pt idx="0">
-                  <c:v>Insumos e produtos comprados</c:v>
-                </c:pt>
-                <c:pt idx="1">
-                  <c:v>Produção própria (fábrica + depreciação)</c:v>
-                </c:pt>
-                <c:pt idx="2">
-                  <c:v>Incentivos fiscais</c:v>
-                </c:pt>
-              </c:strCache>
-            </c:strRef>
-          </c:cat>
-          <c:val>
-            <c:numRef>
-              <c:f>Sheet1!$B$2:$B$4</c:f>
-              <c:numCache>
-                <c:formatCode>General</c:formatCode>
-                <c:ptCount val="3"/>
-                <c:pt idx="0">
-                  <c:v>2667</c:v>
-                </c:pt>
-                <c:pt idx="1">
-                  <c:v>451</c:v>
-                </c:pt>
-                <c:pt idx="2">
-                  <c:v>460</c:v>
-                </c:pt>
-              </c:numCache>
-            </c:numRef>
-          </c:val>
-        </c:ser>
-        <c:gapWidth val="40"/>
-        <c:axId val="-2068027336"/>
-        <c:axId val="-2113994440"/>
-      </c:barChart>
-      <c:catAx>
-        <c:axId val="-2068027336"/>
-        <c:scaling>
-          <c:orientation val="maxMin"/>
-        </c:scaling>
-        <c:delete val="0"/>
-        <c:axPos val="l"/>
-        <c:majorTickMark val="none"/>
-        <c:minorTickMark val="none"/>
-        <c:tickLblPos val="nextTo"/>
-        <c:spPr>
-          <a:ln>
-            <a:noFill/>
-          </a:ln>
-        </c:spPr>
-        <c:txPr>
-          <a:bodyPr/>
-          <a:lstStyle/>
-          <a:p>
-            <a:pPr>
-              <a:defRPr sz="1000">
-                <a:solidFill>
-                  <a:srgbClr val="595959"/>
-                </a:solidFill>
-              </a:defRPr>
-            </a:pPr>
-          </a:p>
-        </c:txPr>
-        <c:crossAx val="-2113994440"/>
-        <c:crosses val="autoZero"/>
-        <c:auto val="1"/>
-        <c:lblAlgn val="ctr"/>
-        <c:lblOffset val="100"/>
-        <c:noMultiLvlLbl val="0"/>
-      </c:catAx>
-      <c:valAx>
-        <c:axId val="-2113994440"/>
-        <c:scaling>
-          <c:max val="4300.0"/>
-          <c:min val="0.0"/>
-        </c:scaling>
-        <c:delete/>
-        <c:axPos val="b"/>
-        <c:majorTickMark val="out"/>
-        <c:minorTickMark val="none"/>
-        <c:tickLblPos val="nextTo"/>
-        <c:crossAx val="-2068027336"/>
-        <c:crosses val="autoZero"/>
-      </c:valAx>
-    </c:plotArea>
-    <c:dispBlanksAs val="gap"/>
-  </c:chart>
-  <c:spPr>
-    <a:noFill/>
-    <a:ln>
-      <a:noFill/>
-    </a:ln>
-  </c:spPr>
-  <c:txPr>
-    <a:bodyPr/>
-    <a:lstStyle/>
-    <a:p>
-      <a:pPr>
-        <a:defRPr sz="900">
-          <a:solidFill>
-            <a:srgbClr val="595959"/>
-          </a:solidFill>
-          <a:latin typeface="Calibri"/>
-        </a:defRPr>
-      </a:pPr>
-      <a:endParaRPr lang="en-US"/>
-    </a:p>
-  </c:txPr>
-  <c:externalData r:id="rId1">
-    <c:autoUpdate val="0"/>
-  </c:externalData>
-</c:chartSpace>
-</file>
-
-<file path=ppt/charts/chart8.xml><?xml version="1.0" encoding="utf-8"?>
 <c:chartSpace xmlns:c="http://schemas.openxmlformats.org/drawingml/2006/chart" xmlns:a="http://schemas.openxmlformats.org/drawingml/2006/main" xmlns:r="http://schemas.openxmlformats.org/officeDocument/2006/relationships">
   <c:date1904 val="0"/>
   <c:chart>
@@ -1123,7 +910,7 @@
             <a:lstStyle/>
             <a:p>
               <a:pPr>
-                <a:defRPr sz="900">
+                <a:defRPr sz="1100" b="1">
                   <a:solidFill>
                     <a:srgbClr val="595959"/>
                   </a:solidFill>
@@ -1140,8 +927,8 @@
           <c:showBubbleSize val="0"/>
           <c:showLeaderLines val="1"/>
         </c:dLbls>
-        <c:gapWidth val="60"/>
-        <c:overlap val="-10"/>
+        <c:gapWidth val="90"/>
+        <c:overlap val="-5"/>
         <c:axId val="-2068027336"/>
         <c:axId val="-2113994440"/>
       </c:barChart>
@@ -1167,7 +954,7 @@
           <a:lstStyle/>
           <a:p>
             <a:pPr>
-              <a:defRPr sz="900">
+              <a:defRPr sz="1100">
                 <a:solidFill>
                   <a:srgbClr val="595959"/>
                 </a:solidFill>
@@ -1205,7 +992,7 @@
         <a:lstStyle/>
         <a:p>
           <a:pPr>
-            <a:defRPr sz="900"/>
+            <a:defRPr sz="1000"/>
           </a:pPr>
         </a:p>
       </c:txPr>
@@ -1223,7 +1010,7 @@
     <a:lstStyle/>
     <a:p>
       <a:pPr>
-        <a:defRPr sz="900">
+        <a:defRPr sz="1000">
           <a:solidFill>
             <a:srgbClr val="595959"/>
           </a:solidFill>
@@ -1239,7 +1026,7 @@
 </c:chartSpace>
 </file>
 
-<file path=ppt/charts/chart9.xml><?xml version="1.0" encoding="utf-8"?>
+<file path=ppt/charts/chart8.xml><?xml version="1.0" encoding="utf-8"?>
 <c:chartSpace xmlns:c="http://schemas.openxmlformats.org/drawingml/2006/chart" xmlns:a="http://schemas.openxmlformats.org/drawingml/2006/main" xmlns:r="http://schemas.openxmlformats.org/officeDocument/2006/relationships">
   <c:date1904 val="0"/>
   <c:chart>
@@ -1263,7 +1050,7 @@
             </c:strRef>
           </c:tx>
           <c:spPr>
-            <a:ln w="28575">
+            <a:ln w="31750">
               <a:solidFill>
                 <a:srgbClr val="009F41"/>
               </a:solidFill>
@@ -1272,7 +1059,7 @@
           </c:spPr>
           <c:marker>
             <c:symbol val="circle"/>
-            <c:size val="6"/>
+            <c:size val="7"/>
             <c:spPr>
               <a:solidFill>
                 <a:srgbClr val="009F41"/>
@@ -1293,7 +1080,7 @@
                   <a:lstStyle/>
                   <a:p>
                     <a:r>
-                      <a:rPr sz="1000" b="1">
+                      <a:rPr sz="1100" b="1">
                         <a:solidFill>
                           <a:srgbClr val="009F41"/>
                         </a:solidFill>
@@ -1319,7 +1106,7 @@
                   <a:lstStyle/>
                   <a:p>
                     <a:r>
-                      <a:rPr sz="1000" b="1">
+                      <a:rPr sz="1100" b="1">
                         <a:solidFill>
                           <a:srgbClr val="009F41"/>
                         </a:solidFill>
@@ -1400,7 +1187,7 @@
             </c:strRef>
           </c:tx>
           <c:spPr>
-            <a:ln w="28575">
+            <a:ln w="31750">
               <a:solidFill>
                 <a:srgbClr val="1A1A1A"/>
               </a:solidFill>
@@ -1408,7 +1195,7 @@
           </c:spPr>
           <c:marker>
             <c:symbol val="circle"/>
-            <c:size val="6"/>
+            <c:size val="7"/>
             <c:spPr>
               <a:solidFill>
                 <a:srgbClr val="1A1A1A"/>
@@ -1429,7 +1216,7 @@
                   <a:lstStyle/>
                   <a:p>
                     <a:r>
-                      <a:rPr sz="900" b="1">
+                      <a:rPr sz="1000" b="1">
                         <a:solidFill>
                           <a:srgbClr val="1A1A1A"/>
                         </a:solidFill>
@@ -1455,7 +1242,7 @@
                   <a:lstStyle/>
                   <a:p>
                     <a:r>
-                      <a:rPr sz="900" b="1">
+                      <a:rPr sz="1000" b="1">
                         <a:solidFill>
                           <a:srgbClr val="1A1A1A"/>
                         </a:solidFill>
@@ -1481,7 +1268,7 @@
                   <a:lstStyle/>
                   <a:p>
                     <a:r>
-                      <a:rPr sz="900" b="1">
+                      <a:rPr sz="1000" b="1">
                         <a:solidFill>
                           <a:srgbClr val="1A1A1A"/>
                         </a:solidFill>
@@ -1507,7 +1294,7 @@
                   <a:lstStyle/>
                   <a:p>
                     <a:r>
-                      <a:rPr sz="900" b="1">
+                      <a:rPr sz="1000" b="1">
                         <a:solidFill>
                           <a:srgbClr val="1A1A1A"/>
                         </a:solidFill>
@@ -1517,7 +1304,7 @@
                   </a:p>
                   <a:p>
                     <a:r>
-                      <a:rPr sz="900" b="1">
+                      <a:rPr sz="1000" b="1">
                         <a:solidFill>
                           <a:srgbClr val="1A1A1A"/>
                         </a:solidFill>
@@ -1543,7 +1330,7 @@
                   <a:lstStyle/>
                   <a:p>
                     <a:r>
-                      <a:rPr sz="900" b="1">
+                      <a:rPr sz="1000" b="1">
                         <a:solidFill>
                           <a:srgbClr val="1A1A1A"/>
                         </a:solidFill>
@@ -1645,7 +1432,7 @@
           <a:lstStyle/>
           <a:p>
             <a:pPr>
-              <a:defRPr sz="900">
+              <a:defRPr sz="1000">
                 <a:solidFill>
                   <a:srgbClr val="595959"/>
                 </a:solidFill>
@@ -1684,7 +1471,7 @@
         <a:lstStyle/>
         <a:p>
           <a:pPr>
-            <a:defRPr sz="900"/>
+            <a:defRPr sz="1000"/>
           </a:pPr>
         </a:p>
       </c:txPr>
@@ -1704,7 +1491,220 @@
     <a:lstStyle/>
     <a:p>
       <a:pPr>
-        <a:defRPr sz="900">
+        <a:defRPr sz="1000">
+          <a:solidFill>
+            <a:srgbClr val="595959"/>
+          </a:solidFill>
+          <a:latin typeface="Calibri"/>
+        </a:defRPr>
+      </a:pPr>
+      <a:endParaRPr lang="en-US"/>
+    </a:p>
+  </c:txPr>
+  <c:externalData r:id="rId1">
+    <c:autoUpdate val="0"/>
+  </c:externalData>
+</c:chartSpace>
+</file>
+
+<file path=ppt/charts/chart9.xml><?xml version="1.0" encoding="utf-8"?>
+<c:chartSpace xmlns:c="http://schemas.openxmlformats.org/drawingml/2006/chart" xmlns:a="http://schemas.openxmlformats.org/drawingml/2006/main" xmlns:r="http://schemas.openxmlformats.org/officeDocument/2006/relationships">
+  <c:date1904 val="0"/>
+  <c:chart>
+    <c:autoTitleDeleted val="1"/>
+    <c:plotArea>
+      <c:barChart>
+        <c:barDir val="bar"/>
+        <c:grouping val="clustered"/>
+        <c:ser>
+          <c:idx val="0"/>
+          <c:order val="0"/>
+          <c:tx>
+            <c:strRef>
+              <c:f>Sheet1!$B$1</c:f>
+              <c:strCache>
+                <c:ptCount val="1"/>
+                <c:pt idx="0">
+                  <c:v>%</c:v>
+                </c:pt>
+              </c:strCache>
+            </c:strRef>
+          </c:tx>
+          <c:dPt>
+            <c:idx val="0"/>
+            <c:spPr>
+              <a:solidFill>
+                <a:srgbClr val="009F41"/>
+              </a:solidFill>
+            </c:spPr>
+          </c:dPt>
+          <c:dPt>
+            <c:idx val="1"/>
+            <c:spPr>
+              <a:solidFill>
+                <a:srgbClr val="1A1A1A"/>
+              </a:solidFill>
+            </c:spPr>
+          </c:dPt>
+          <c:dLbls>
+            <c:dLbl>
+              <c:idx val="0"/>
+              <c:tx>
+                <c:rich>
+                  <a:bodyPr/>
+                  <a:lstStyle/>
+                  <a:p>
+                    <a:r>
+                      <a:rPr sz="1300" b="1">
+                        <a:solidFill>
+                          <a:srgbClr val="009F41"/>
+                        </a:solidFill>
+                      </a:rPr>
+                      <a:t>23%</a:t>
+                    </a:r>
+                  </a:p>
+                </c:rich>
+              </c:tx>
+              <c:dLblPos val="outEnd"/>
+              <c:showLegendKey val="0"/>
+              <c:showVal val="1"/>
+              <c:showCatName val="0"/>
+              <c:showSerName val="0"/>
+              <c:showPercent val="0"/>
+              <c:showBubbleSize val="0"/>
+            </c:dLbl>
+            <c:dLbl>
+              <c:idx val="1"/>
+              <c:tx>
+                <c:rich>
+                  <a:bodyPr/>
+                  <a:lstStyle/>
+                  <a:p>
+                    <a:r>
+                      <a:rPr sz="1300" b="1">
+                        <a:solidFill>
+                          <a:srgbClr val="1A1A1A"/>
+                        </a:solidFill>
+                      </a:rPr>
+                      <a:t>~3%</a:t>
+                    </a:r>
+                  </a:p>
+                </c:rich>
+              </c:tx>
+              <c:dLblPos val="outEnd"/>
+              <c:showLegendKey val="0"/>
+              <c:showVal val="1"/>
+              <c:showCatName val="0"/>
+              <c:showSerName val="0"/>
+              <c:showPercent val="0"/>
+              <c:showBubbleSize val="0"/>
+            </c:dLbl>
+            <c:showLegendKey val="0"/>
+            <c:showVal val="0"/>
+            <c:showCatName val="0"/>
+            <c:showSerName val="0"/>
+            <c:showPercent val="0"/>
+            <c:showBubbleSize val="0"/>
+            <c:showLeaderLines val="1"/>
+          </c:dLbls>
+          <c:cat>
+            <c:strRef>
+              <c:f>Sheet1!$A$2:$A$3</c:f>
+              <c:strCache>
+                <c:ptCount val="2"/>
+                <c:pt idx="0">
+                  <c:v>Dahua no custo da Intelbras</c:v>
+                </c:pt>
+                <c:pt idx="1">
+                  <c:v>Intelbras na receita da Dahua</c:v>
+                </c:pt>
+              </c:strCache>
+            </c:strRef>
+          </c:cat>
+          <c:val>
+            <c:numRef>
+              <c:f>Sheet1!$B$2:$B$3</c:f>
+              <c:numCache>
+                <c:formatCode>General</c:formatCode>
+                <c:ptCount val="2"/>
+                <c:pt idx="0">
+                  <c:v>23.4</c:v>
+                </c:pt>
+                <c:pt idx="1">
+                  <c:v>2.9</c:v>
+                </c:pt>
+              </c:numCache>
+            </c:numRef>
+          </c:val>
+        </c:ser>
+        <c:gapWidth val="40"/>
+        <c:axId val="-2068027336"/>
+        <c:axId val="-2113994440"/>
+      </c:barChart>
+      <c:catAx>
+        <c:axId val="-2068027336"/>
+        <c:scaling>
+          <c:orientation val="maxMin"/>
+        </c:scaling>
+        <c:delete val="0"/>
+        <c:axPos val="l"/>
+        <c:majorTickMark val="none"/>
+        <c:minorTickMark val="none"/>
+        <c:tickLblPos val="nextTo"/>
+        <c:spPr>
+          <a:ln>
+            <a:noFill/>
+          </a:ln>
+        </c:spPr>
+        <c:txPr>
+          <a:bodyPr/>
+          <a:lstStyle/>
+          <a:p>
+            <a:pPr>
+              <a:defRPr sz="1000">
+                <a:solidFill>
+                  <a:srgbClr val="595959"/>
+                </a:solidFill>
+              </a:defRPr>
+            </a:pPr>
+          </a:p>
+        </c:txPr>
+        <c:crossAx val="-2113994440"/>
+        <c:crosses val="autoZero"/>
+        <c:auto val="1"/>
+        <c:lblAlgn val="ctr"/>
+        <c:lblOffset val="100"/>
+        <c:noMultiLvlLbl val="0"/>
+      </c:catAx>
+      <c:valAx>
+        <c:axId val="-2113994440"/>
+        <c:scaling>
+          <c:max val="30.0"/>
+          <c:min val="0.0"/>
+        </c:scaling>
+        <c:delete/>
+        <c:axPos val="b"/>
+        <c:majorTickMark val="out"/>
+        <c:minorTickMark val="none"/>
+        <c:tickLblPos val="nextTo"/>
+        <c:crossAx val="-2068027336"/>
+        <c:crosses val="autoZero"/>
+      </c:valAx>
+    </c:plotArea>
+    <c:dispBlanksAs val="gap"/>
+  </c:chart>
+  <c:spPr>
+    <a:noFill/>
+    <a:ln>
+      <a:noFill/>
+    </a:ln>
+  </c:spPr>
+  <c:txPr>
+    <a:bodyPr/>
+    <a:lstStyle/>
+    <a:p>
+      <a:pPr>
+        <a:defRPr sz="1000">
           <a:solidFill>
             <a:srgbClr val="595959"/>
           </a:solidFill>
@@ -2114,135 +2114,98 @@
           <a:lstStyle/>
           <a:p>
             <a:r>
-              <a:t>ROTEIRO (≈2 min) — Slide 1: Fornecedores</a:t>
+              <a:t>ROTEIRO (≈1 min) — Slide 1: Fornecedores</a:t>
             </a:r>
           </a:p>
           <a:p/>
           <a:p>
             <a:r>
-              <a:t>ABERTURA (título, 10s)</a:t>
-            </a:r>
-          </a:p>
-          <a:p>
-            <a:r>
-              <a:t>"Para entender a margem da Intelbras, primeiro é preciso entender de quem ela compra. A resposta: ela compra quase tudo de fora, em dólar, de poucos gigantes, e não define o preço."</a:t>
+              <a:t>ABERTURA (10s)</a:t>
+            </a:r>
+          </a:p>
+          <a:p>
+            <a:r>
+              <a:t>"A Intelbras tem pouco poder de barganha com quem vende para ela. Dois números explicam por quê."</a:t>
             </a:r>
           </a:p>
           <a:p/>
           <a:p>
             <a:r>
-              <a:t>I. CUSTO EM DÓLAR, RECEITA EM REAL (aponte para as barras pretas, depois para a verde, 25s)</a:t>
-            </a:r>
-          </a:p>
-          <a:p>
-            <a:r>
-              <a:t>"Cerca de 80% do custo segue o dólar e 92% do que ela deve a fornecedores está no exterior. Do lado da receita, só 4% do que ela tem a receber está em moeda estrangeira, e as exportações são cerca de meio por cento. Quando o dólar sobe, o custo sobe na hora e a receita não acompanha."</a:t>
+              <a:t>I. (aponte para as barras pretas, depois para a verde, 25s)</a:t>
+            </a:r>
+          </a:p>
+          <a:p>
+            <a:r>
+              <a:t>"85% do custo é comprado de terceiros, cerca de 80% segue o dólar e 92% do que ela deve a fornecedores está no exterior. Do lado de quem paga a Intelbras, só 4% está em moeda estrangeira. Resultado: cada 10% de alta no dólar soma uns R$249 milhões ao custo do ano."</a:t>
             </a:r>
           </a:p>
           <a:p/>
           <a:p>
             <a:r>
-              <a:t>II. COMPRA PRONTO; A FÁBRICA SE PAGA COM INCENTIVO (aponte para 85%, depois para 451 vs 460, 30s)</a:t>
-            </a:r>
-          </a:p>
-          <a:p>
-            <a:r>
-              <a:t>"85% do custo é insumo ou produto comprado pronto. A produção própria, fábrica mais depreciação, custa R$451 milhões por ano, e os incentivos fiscais renderam R$460 milhões. Ou seja: montar no Brasil agrega pouco ao custo, mas é o que destrava o regime fiscal. Fabricar aqui é mais uma decisão tributária do que industrial."</a:t>
+              <a:t>II. (aponte para o vão entre as barras, 20s)</a:t>
+            </a:r>
+          </a:p>
+          <a:p>
+            <a:r>
+              <a:t>"Sem barganha, a defesa é estoque. Ela carrega uns 170 dias de estoque, mas os fornecedores só dão uns 120 de prazo. Esse vão é dinheiro dela: perto de R$0,4 bilhão em 2025."</a:t>
             </a:r>
           </a:p>
           <a:p/>
           <a:p>
             <a:r>
-              <a:t>III. MAPA DE SUPRIMENTO (percorra os três elos, depois a barra da Dahua, 25s)</a:t>
-            </a:r>
-          </a:p>
-          <a:p>
-            <a:r>
-              <a:t>"A Intelbras compra componentes, monta as placas no Brasil e compra produtos prontos de parceiros: Dahua em câmeras, H3C em redes, e até janeiro a FiberHome em GPON. Onde a troca é difícil, nos chips e nas câmeras, ela depende de poucos. E um único parceiro, a Dahua, responde por 36% de tudo que ela gasta com fornecedores."</a:t>
+              <a:t>PONTE (5s)</a:t>
+            </a:r>
+          </a:p>
+          <a:p>
+            <a:r>
+              <a:t>"E um terço de tudo que ela gasta com fornecedores vai para um único parceiro: a Dahua."</a:t>
             </a:r>
           </a:p>
           <a:p/>
           <a:p>
             <a:r>
-              <a:t>IV. CONSEQUÊNCIA NO CAPITAL (aponte para o vão entre as barras, 25s)</a:t>
-            </a:r>
-          </a:p>
-          <a:p>
-            <a:r>
-              <a:t>"Comprar longe, em dólar e de poucos tem um custo de capital. A Intelbras carrega uns 170 dias de estoque contra uns 120 de prazo dos fornecedores. Esse vão, de 40 a 70 dias, ela financia com caixa próprio: perto de R$0,4 bilhão em 2025. Em 2021 e 2024 o estoque subiu de propósito, para não faltar produto. E parte do prazo vem da própria Dahua, como veremos agora."</a:t>
+              <a:t>DETALHES (se perguntarem)</a:t>
+            </a:r>
+          </a:p>
+          <a:p>
+            <a:r>
+              <a:t>• Origem por país não é divulgada. Usamos moeda (DFP NE 25) e a lista do FRE: fábricas na China, Coreia e Vietnã; parceiros chineses (Dahua, H3C, FiberHome); 7% do saldo a pagar em yuan.</a:t>
+            </a:r>
+          </a:p>
+          <a:p>
+            <a:r>
+              <a:t>• Chips: a própria empresa diz que há poucas opções de chipset e que trocar pode suspender parte da produção (FRE 1.4.e).</a:t>
+            </a:r>
+          </a:p>
+          <a:p>
+            <a:r>
+              <a:t>• Estoque alto de propósito em 2021 (~180 dias) e no 2S24, para mitigar risco de suprimento (teleconferências 4T21 e 4T24). Custo: ciclo de caixa de 145 dias e provisão de obsolescência de R$73 mi em 2025.</a:t>
+            </a:r>
+          </a:p>
+          <a:p>
+            <a:r>
+              <a:t>• Hedge: contratos a termo (NDF) cobrem ~50% dos fornecedores em dólar no balanço, com prazo de ~90 dias. Protegem o caixa de curto prazo, não a margem.</a:t>
+            </a:r>
+          </a:p>
+          <a:p>
+            <a:r>
+              <a:t>• O efeito do câmbio na margem e a estrutura do mercado de chips ficam na análise setorial (eixo de preços). A montagem local e os incentivos ficam na seção de produção.</a:t>
             </a:r>
           </a:p>
           <a:p/>
           <a:p>
             <a:r>
-              <a:t>PONTE PARA O SLIDE 2 (10s)</a:t>
-            </a:r>
-          </a:p>
-          <a:p>
-            <a:r>
-              <a:t>"Baixo poder de barganha, custo em dólar e estoque alto. E entre todos os fornecedores, um pesa mais que os outros: a Dahua."</a:t>
-            </a:r>
-          </a:p>
-          <a:p/>
-          <a:p>
-            <a:r>
-              <a:t>PERGUNTAS PROVÁVEIS</a:t>
-            </a:r>
-          </a:p>
-          <a:p>
-            <a:r>
-              <a:t>• "Por que não aparece a origem por país (China %)?" A companhia não divulga gastos por país. Usamos moeda (DFP NE 25) e a lista de parceiros (FRE 1.4.e: China, Coreia e Vietnã). Dahua, H3C e FiberHome são chinesas; 7% do saldo a pagar é em yuan.</a:t>
-            </a:r>
-          </a:p>
-          <a:p>
-            <a:r>
-              <a:t>• "Por que os chips são escassos?" A própria Intelbras diz que há poucas opções de chipset e que trocar pode suspender parte da produção (FRE 1.4.e). A estrutura do mercado global de chips (TSMC, memória) fica na análise setorial.</a:t>
-            </a:r>
-          </a:p>
-          <a:p>
-            <a:r>
-              <a:t>• "A fábrica é pretexto para incentivo?" Os números mostram que o incentivo (R$460 mi) cobre o custo da produção própria (R$451 mi). Mas a fábrica também dá prazo de entrega, controle de qualidade e homologação local. Melhor dizer: a fábrica se paga pelo regime fiscal.</a:t>
-            </a:r>
-          </a:p>
-          <a:p>
-            <a:r>
-              <a:t>• "E o efeito do câmbio na margem?" Fica na análise setorial (eixo de preços): margem bruta × dólar trimestral. Aqui mostramos a exposição (I) e o mecanismo de defesa, que é o estoque (IV).</a:t>
-            </a:r>
-          </a:p>
-          <a:p>
-            <a:r>
-              <a:t>• "Estoque alto é ruim?" É o preço do modelo: garante disponibilidade ao instalador e protege contra falta de componentes. Mas custa capital (ciclo de caixa de 145 dias em 2025) e gera obsolescência (provisão de R$73 mi).</a:t>
-            </a:r>
-          </a:p>
-          <a:p>
-            <a:r>
-              <a:t>• "Tem hedge?" Sim: contratos a termo (NDF) cobrem ~50% dos fornecedores em dólar no balanço, com prazo de ~90 dias. Protegem o caixa de curto prazo, não a margem de longo prazo.</a:t>
-            </a:r>
-          </a:p>
-          <a:p/>
-          <a:p>
-            <a:r>
               <a:t>FONTES E CONTAS</a:t>
             </a:r>
           </a:p>
           <a:p>
             <a:r>
-              <a:t>I: FRE 2.2 (~80% do CPV em moeda estrangeira); DFP NE 14/25 (fornecedores + risco sacado no exterior R$972,6 mi ÷ R$1.062,6 mi = 91,5%; recebíveis em US$ R$26,6 mi + COP R$20,8 mi = R$47,5 mi ÷ R$1.169,5 mi = 4,1%). Exportações ≈ 0,5% da receita: teleconferência do 4T21.</a:t>
-            </a:r>
-          </a:p>
-          <a:p>
-            <a:r>
-              <a:t>II: DFP NE 27: matéria-prima e revenda R$2.666,9 mi (85,5%); custos de produção R$396,1 mi + depreciação R$54,8 mi = R$450,9 mi (14,5%). DFP NE 23: incentivos R$459,7 mi (ICMS R$336,3 mi + Lei de TICs R$123,3 mi).</a:t>
-            </a:r>
-          </a:p>
-          <a:p>
-            <a:r>
-              <a:t>III: FRE 1.4.a (fábricas: São José e Tubarão/SC, Manaus/AM, Santa Rita do Sapucaí/MG; SMD ~450 mi componentes/mês); FRE 1.4.e (três categorias de fornecedores; produtos de fábricas na China, Coreia e Vietnã; poucas opções de chipsets; Dahua 36,0% dos gastos com fornecedores em 2025). FRE 11.3 (prioridade de compra de CFTV pela Dahua até 2028). H3C em redes corporativas (Teletime, out/2024); FiberHome em GPON até 12/01/2026 (Teletime).</a:t>
-            </a:r>
-          </a:p>
-          <a:p>
-            <a:r>
-              <a:t>IV: dias de estoque = estoque ÷ CPV × 365 = 217/161/151/196/173 (2021–25); prazo = (fornecedores + risco sacado) ÷ CPV × 365 = 146/121/113/135/123; vão = 71/40/38/61/50 dias; 2025: 50 × R$3.117,8 mi ÷ 365 ≈ R$427 mi. Estoque elevado para mitigar riscos de suprimento: teleconferências 4T21 (~180 dias) e 4T24. Provisão de obsolescência R$73,1 mi (DFP NE 8).</a:t>
+              <a:t>I: DFP NE 27 (matéria-prima e revenda R$2.666,9 mi ÷ CPV R$3.117,8 mi = 85,5%); FRE 2.2 (~80% do CPV em moeda estrangeira); DFP NE 14/25 (fornecedores + risco sacado no exterior R$972,6 mi ÷ R$1.062,6 mi = 91,5%; recebíveis em US$ e COP R$47,5 mi ÷ R$1.169,5 mi = 4,1%). Sensibilidade: 80% × R$3.117,8 mi × 10% = R$249 mi.</a:t>
+            </a:r>
+          </a:p>
+          <a:p>
+            <a:r>
+              <a:t>II: dias de estoque = estoque ÷ CPV × 365 = 217/161/151/196/173; prazo = (fornecedores + risco sacado) ÷ CPV × 365 = 146/121/113/135/123; vão de 2025 = 50 dias × R$3.117,8 mi ÷ 365 ≈ R$427 mi.</a:t>
             </a:r>
           </a:p>
         </p:txBody>
@@ -2312,135 +2275,134 @@
           <a:lstStyle/>
           <a:p>
             <a:r>
-              <a:t>ROTEIRO (≈2,5 min) — Slide 2: Dahua</a:t>
+              <a:t>ROTEIRO (≈1 min 15s) — Slide 2: Dahua</a:t>
             </a:r>
           </a:p>
           <a:p/>
           <a:p>
             <a:r>
-              <a:t>ABERTURA (10s)</a:t>
-            </a:r>
-          </a:p>
-          <a:p>
-            <a:r>
-              <a:t>"A Dahua é o fornecedor mais importante da Intelbras. Em cima, o que é essa relação; embaixo, por que ela virou o maior risco isolado da tese."</a:t>
+              <a:t>ABERTURA (5s)</a:t>
+            </a:r>
+          </a:p>
+          <a:p>
+            <a:r>
+              <a:t>"A Dahua é o fornecedor que mais pesa. Em cima, a relação; embaixo, por que ela virou risco."</a:t>
             </a:r>
           </a:p>
           <a:p/>
           <a:p>
             <a:r>
-              <a:t>I. CONCENTRAÇÃO (aponte para a linha tracejada, depois para o pico de 2024, 25s)</a:t>
-            </a:r>
-          </a:p>
-          <a:p>
-            <a:r>
-              <a:t>"A Dahua já é 36% dos gastos com fornecedores, contra 28,6% em 2021. No custo dos produtos vendidos, fica entre 20% e 25%. O pico de 2024 foi compra antecipada para proteger o suprimento. Em 2025 foram R$729 milhões comprados da Dahua."</a:t>
+              <a:t>I. (aponte para a linha tracejada, 15s)</a:t>
+            </a:r>
+          </a:p>
+          <a:p>
+            <a:r>
+              <a:t>"A Dahua já leva 36% dos gastos com fornecedores, contra 28,6% em 2021. No custo dos produtos vendidos fica entre 20% e 25%; o pico de 2024 foi estoque antecipado."</a:t>
             </a:r>
           </a:p>
           <a:p/>
           <a:p>
             <a:r>
-              <a:t>II. A TROCA (aponte para as setas, depois para 23% vs ~3%, 35s)</a:t>
-            </a:r>
-          </a:p>
-          <a:p>
-            <a:r>
-              <a:t>"Por que a Dahua? Porque câmera é uma corrida de P&amp;D, e a Dahua investe 18 vezes mais que a Intelbras inteira. A Dahua entrega tecnologia, exclusividade da marca no Brasil e ~7 meses de prazo. A Intelbras entrega o canal, com 500 distribuidores e 90 mil instaladores, e prioridade de compra até 2028. Há uma proteção: se a Dahua cobrar 5% acima do mercado, a Intelbras pode comprar de outro. Mas a dependência é assimétrica: a Dahua é 23% do custo da Intelbras, e a Intelbras é só ~3% da receita da Dahua."</a:t>
+              <a:t>II. (aponte para as setas, depois para 23% vs ~3%, 20s)</a:t>
+            </a:r>
+          </a:p>
+          <a:p>
+            <a:r>
+              <a:t>"A troca: a Dahua entrega a tecnologia das câmeras e prazo de pagamento; a Intelbras entrega o canal. Mas a Dahua é 23% do custo da Intelbras, e a Intelbras é só ~3% da receita da Dahua. Quem precisa mais é a Intelbras."</a:t>
             </a:r>
           </a:p>
           <a:p/>
           <a:p>
             <a:r>
-              <a:t>III. CRÉDITO (aponte para a barra verde e para 225 dias, 25s)</a:t>
-            </a:r>
-          </a:p>
-          <a:p>
-            <a:r>
-              <a:t>"A Dahua não só vende: ela financia. São R$449 milhões a pagar, 43% de tudo que a Intelbras deve a fornecedores, com prazo de 225 dias. É crédito barato e conveniente. Mas se a Dahua voltar a cobrar em 90 dias, a Intelbras precisa de R$269 milhões a mais de capital de giro, e o ROIC cai 1,7 ponto."</a:t>
+              <a:t>III. (aponte para a barra verde, 15s)</a:t>
+            </a:r>
+          </a:p>
+          <a:p>
+            <a:r>
+              <a:t>"A Dahua também financia: 43% de tudo que a Intelbras deve a fornecedores, com 225 dias de prazo. Se esse prazo cair para 90 dias, a Intelbras precisa de R$269 milhões a mais de capital de giro."</a:t>
             </a:r>
           </a:p>
           <a:p/>
           <a:p>
             <a:r>
-              <a:t>IV. AFASTAMENTO (percorra a linha da esquerda para a direita, 30s)</a:t>
-            </a:r>
-          </a:p>
-          <a:p>
-            <a:r>
-              <a:t>"A linha do tempo tem duas fases. Aproximação: parceria desde 2007, acordo de 10 anos em 2018, 10% do capital em 2019. Afastamento: a Dahua vende parte em 2023 e, em agosto de 2025, aprova vender o resto em até três anos. Ela também ganhou operação própria no Brasil, e a FiberHome, outra parceira chinesa, já encerrou sua exclusividade com a Intelbras. Tudo converge para dezembro de 2028."</a:t>
+              <a:t>IV. (percorra a linha da esquerda para a direita, 15s)</a:t>
+            </a:r>
+          </a:p>
+          <a:p>
+            <a:r>
+              <a:t>"E a Dahua está saindo: chegou a 10% do capital, vendeu parte em 2023 e, em 2025, aprovou vender o resto. O acordo vence em dezembro de 2028. Em jogo: cerca de metade do custo de Segurança."</a:t>
             </a:r>
           </a:p>
           <a:p/>
           <a:p>
             <a:r>
-              <a:t>FECHO (15s)</a:t>
-            </a:r>
-          </a:p>
-          <a:p>
-            <a:r>
-              <a:t>"Em jogo: cerca de metade do custo de Segurança, o negócio que gera 68% do lucro bruto, e R$449 milhões de crédito. Não é previsão de rompimento: é o evento que mais pode mexer na margem e no capital da Intelbras nos próximos anos."</a:t>
+              <a:t>DETALHES (se perguntarem)</a:t>
+            </a:r>
+          </a:p>
+          <a:p>
+            <a:r>
+              <a:t>• Por que Dahua e não fazer sozinha? P&amp;D da Dahua ~US$590 mi/ano (2024) vs ~US$32 mi da Intelbras inteira (2025): ~18x. Trocar exige redesenvolver produto, firmware e app (FRE: a troca pode suspender produção). Concorrentes ficam na análise setorial.</a:t>
+            </a:r>
+          </a:p>
+          <a:p>
+            <a:r>
+              <a:t>• Proteção contratual: a prioridade cai se a Dahua cobrar ≥5% acima de produto equivalente ou falhar em tecnologia ou qualidade. Se a Dahua rescindir, a Intelbras pode comprar por mais 3 anos (FRE 11.3).</a:t>
+            </a:r>
+          </a:p>
+          <a:p>
+            <a:r>
+              <a:t>• Exclusividade da marca Dahua no Brasil durante o acordo + 6 meses. A Dahua tem subsidiária própria no Brasil (região independente desde ~2021) e marca de consumo (Imou) vendida via cross-border.</a:t>
+            </a:r>
+          </a:p>
+          <a:p>
+            <a:r>
+              <a:t>• Precedente: a FiberHome (GPON) encerrou a exclusividade com a Intelbras em jan/2026 (Teletime).</a:t>
+            </a:r>
+          </a:p>
+          <a:p>
+            <a:r>
+              <a:t>• 36% × 23%: bases diferentes (gastos com fornecedores no FRE × custo dos produtos vendidos na DFP).</a:t>
+            </a:r>
+          </a:p>
+          <a:p>
+            <a:r>
+              <a:t>• R$449 mi × R$524 mi: a DFP (auditada, consolidada) informa R$448,8 mi; o FRE 11.2, R$524,4 mi (provavelmente inclui faturas antecipadas via risco sacado; não conciliado).</a:t>
+            </a:r>
+          </a:p>
+          <a:p>
+            <a:r>
+              <a:t>• Venda das ações: motivo não divulgado; a Dahua vendeu a operação nos EUA após queda de lucro em 2024. Leitura conservadora: menos alinhamento.</a:t>
+            </a:r>
+          </a:p>
+          <a:p>
+            <a:r>
+              <a:t>• É red flag? É risco de evento, não piora comprovada de termos. Acompanhar: % das compras, prazo a pagar, comunicados sobre renovação e venda das ações.</a:t>
             </a:r>
           </a:p>
           <a:p/>
           <a:p>
             <a:r>
-              <a:t>PERGUNTAS PROVÁVEIS</a:t>
-            </a:r>
-          </a:p>
-          <a:p>
-            <a:r>
-              <a:t>• "Por que não troca de fornecedor ou faz sozinha?" P&amp;D da Dahua ~US$590 mi/ano vs ~US$32 mi da Intelbras (todas as BUs). A outra gigante (Hikvision) é concorrente no Brasil: é tema da análise setorial. Trocar exige redesenvolver produto, firmware e app; o FRE diz que a troca pode suspender parte da produção.</a:t>
-            </a:r>
-          </a:p>
-          <a:p>
-            <a:r>
-              <a:t>• "Por que 36% e não 23%?" Bases diferentes. 36% é sobre os gastos com fornecedores (FRE); 23%, sobre o custo dos produtos vendidos (DFP). Ambos corretos.</a:t>
-            </a:r>
-          </a:p>
-          <a:p>
-            <a:r>
-              <a:t>• "O FRE fala em R$524 mi a pagar, não R$449 mi." Os R$449 mi são o saldo consolidado auditado (DFP NE 32). O FRE (item 11.2) informa R$524 mi; a diferença provavelmente inclui faturas da Dahua antecipadas via risco sacado, mas não conciliamos. Usamos a DFP para manter a série 2021–25 comparável.</a:t>
-            </a:r>
-          </a:p>
-          <a:p>
-            <a:r>
-              <a:t>• "A Dahua pode entrar sozinha?" Há exclusividade até o fim do acordo + 6 meses. Ela já tem subsidiária e marca de consumo (Imou) vendida via cross-border. O que falta é canal, e é isso que dá poder à Intelbras na renovação. [inferência]</a:t>
-            </a:r>
-          </a:p>
-          <a:p>
-            <a:r>
-              <a:t>• "Por que a Dahua vende a participação?" Não divulgado. A Dahua vendeu a operação nos EUA após queda de lucro em 2024; pode ser realocação de capital. Leitura conservadora: menos alinhamento.</a:t>
-            </a:r>
-          </a:p>
-          <a:p>
-            <a:r>
-              <a:t>• "É red flag?" É risco de evento, não piora comprovada: preços e condições não são divulgados. Acompanhar: % das compras, prazo a pagar, comunicados sobre renovação e sobre a venda das ações.</a:t>
-            </a:r>
-          </a:p>
-          <a:p/>
-          <a:p>
-            <a:r>
               <a:t>FONTES E CONTAS</a:t>
             </a:r>
           </a:p>
           <a:p>
             <a:r>
-              <a:t>I: FRE 1.4.e (36,0% dos gastos com fornecedores em 2025); 28,6% em 2021 (Nord Research, citando o FRE 2022). DFPs 2021–25: compras da Dahua R$515/664/545/1.187/729 mi ÷ CPV R$2.178/3.031/2.827/3.294/3.118 mi = 23,6/21,9/19,3/36,0/23,4%. 2024: estoque elevado no 3T e 4T para mitigar riscos de suprimentos (teleconferência 4T24).</a:t>
-            </a:r>
-          </a:p>
-          <a:p>
-            <a:r>
-              <a:t>II: Acordo de 31/12/2018, 10 anos; prioridade cai com preço ≥5% acima ou falha técnica/qualidade (FRE 1.2/11.3). P&amp;D: Dahua RMB 4,213 bi (2024) ≈ US$587 mi; Intelbras R$179 mi (FRE 2.10) ≈ US$32 mi → ~18x. Canal: ~500 pontos de distribuição e &gt;90 mil revendedores (FRE 1.4.b). Assimetria: R$729 mi ÷ 5,58 ≈ US$131 mi ÷ receita da Dahua ≈ US$4,5 bi (RMB 32,3 bi) ≈ 2,9%.</a:t>
-            </a:r>
-          </a:p>
-          <a:p>
-            <a:r>
-              <a:t>III: Saldo a pagar à Dahua (DFP NE 32, consolidado) R$263/350/225/506/449 mi ÷ fornecedores + risco sacado R$870/1.003/877/1.220/1.049 mi = 30/35/26/41/43%. Prazo implícito = saldo ÷ compras × 365 = 187/192/151/156/225 dias. Com 90 dias: 729 × 90/365 = R$180 mi → +R$269 mi de capital; ROIC pré-IR LTM 2T26 18,8% → 17,1%.</a:t>
-            </a:r>
-          </a:p>
-          <a:p>
-            <a:r>
-              <a:t>IV: 10% em ago/2019 (FRE 1.1); recomposição de 10% em out/2021 após diluição no IPO (comunicado Intelbras); venda de 2,44% em jun/2023 → 7,56% (Brazil Journal); aprovação da venda dos 7,56% em até 36 meses em ago/2025 (FilingReader); Dahua Brasil região independente após crescer três dígitos em 2020 (comunicado Dahua; data aproximada); FiberHome em 12/01/2026 (Teletime); acordo vence em 31/12/2028. ~metade = compras da Dahua ÷ CPV de Segurança, média de 2021–25 ≈ 50%.</a:t>
+              <a:t>I: FRE 1.4.e (36,0% em 2025); Nord Research citando o FRE 2022 (28,6% em 2021). DFPs: compras R$515/664/545/1.187/729 mi ÷ CPV R$2.178/3.031/2.827/3.294/3.118 mi. 2024: estoque elevado para mitigar risco de suprimento (teleconferência 4T24).</a:t>
+            </a:r>
+          </a:p>
+          <a:p>
+            <a:r>
+              <a:t>II: Acordo de 31/12/2018, 10 anos (FRE 1.2/11.3). Canal: &gt;90 mil revendedores e instaladores (FRE 1.4.b). Assimetria: R$729,2 mi ÷ R$3.117,8 mi = 23,4%; R$729,2 mi ÷ 5,58 ≈ US$131 mi ÷ receita da Dahua 2025 ≈ US$4,5 bi (RMB 32,3 bi) ≈ 2,9%. Prazo ~7 meses = 225 dias.</a:t>
+            </a:r>
+          </a:p>
+          <a:p>
+            <a:r>
+              <a:t>III: Saldo à Dahua (DFP NE 32) R$263/350/225/506/449 mi ÷ fornecedores + risco sacado R$870/1.003/877/1.220/1.049 mi. Prazo = saldo ÷ compras × 365 = 187/192/151/156/225. Com 90 dias: 729 × 90/365 = R$180 mi → +R$269 mi; ROIC pré-IR LTM 2T26 18,8% → 17,1%.</a:t>
+            </a:r>
+          </a:p>
+          <a:p>
+            <a:r>
+              <a:t>IV: 10% em ago/2019 (FRE 1.1); recomposição de 10% em out/2021 após diluição no IPO; venda de 2,44% em jun/2023 → 7,56% (Brazil Journal); aprovação da venda dos 7,56% em até 36 meses em ago/2025 (FilingReader); acordo vence em 31/12/2028. ~metade do custo de Segurança = compras da Dahua ÷ CPV de Segurança, média 2021–25 ≈ 50%.</a:t>
             </a:r>
           </a:p>
         </p:txBody>
@@ -7067,7 +7029,7 @@
           <a:lstStyle/>
           <a:p>
             <a:r>
-              <a:t>Custo em dólar, chips escassos e um terço dos gastos em um só fornecedor: a Intelbras aceita o preço e carrega estoque para garantir o suprimento</a:t>
+              <a:t>O custo é comprado e dolarizado, com um terço dos gastos em um só fornecedor: a Intelbras aceita o preço e carrega o estoque</a:t>
             </a:r>
           </a:p>
         </p:txBody>
@@ -7088,7 +7050,7 @@
           <a:lstStyle/>
           <a:p>
             <a:r>
-              <a:t>I. O custo é dolarizado e asiático; a receita é em reais: o câmbio bate na margem</a:t>
+              <a:t>I. Quase todo o custo é comprado e atrelado ao dólar; a receita é em reais</a:t>
             </a:r>
           </a:p>
         </p:txBody>
@@ -7109,7 +7071,7 @@
           <a:lstStyle/>
           <a:p>
             <a:r>
-              <a:t>Parcela em moeda estrangeira, 2025 (%)</a:t>
+              <a:t>Parcela de cada item ligada a terceiros ou a moeda estrangeira, 2025 (%)</a:t>
             </a:r>
           </a:p>
         </p:txBody>
@@ -7121,7 +7083,7 @@
             <a:spLocks noGrp="1"/>
           </p:cNvSpPr>
           <p:nvPr>
-            <p:ph type="body" idx="11" sz="quarter"/>
+            <p:ph type="body" idx="12" sz="quarter"/>
           </p:nvPr>
         </p:nvSpPr>
         <p:spPr/>
@@ -7130,7 +7092,7 @@
           <a:lstStyle/>
           <a:p>
             <a:r>
-              <a:t>II. 85% do custo é comprado pronto; a fábrica local se paga com incentivos</a:t>
+              <a:t>II. Sem poder de barganha, a Intelbras carrega o estoque e financia a diferença</a:t>
             </a:r>
           </a:p>
         </p:txBody>
@@ -7142,7 +7104,7 @@
             <a:spLocks noGrp="1"/>
           </p:cNvSpPr>
           <p:nvPr>
-            <p:ph type="body" idx="15" sz="quarter"/>
+            <p:ph type="body" idx="16" sz="quarter"/>
           </p:nvPr>
         </p:nvSpPr>
         <p:spPr/>
@@ -7151,7 +7113,7 @@
           <a:lstStyle/>
           <a:p>
             <a:r>
-              <a:t>Custo dos produtos vendidos e incentivos fiscais, 2025 (R$ milhões)</a:t>
+              <a:t>Dias de estoque vs prazo médio pago aos fornecedores, 2021–2025 (dias de custo dos produtos vendidos)</a:t>
             </a:r>
           </a:p>
         </p:txBody>
@@ -7163,7 +7125,7 @@
             <a:spLocks noGrp="1"/>
           </p:cNvSpPr>
           <p:nvPr>
-            <p:ph type="body" idx="12" sz="quarter"/>
+            <p:ph type="body" idx="20" sz="quarter"/>
           </p:nvPr>
         </p:nvSpPr>
         <p:spPr/>
@@ -7172,106 +7134,22 @@
           <a:lstStyle/>
           <a:p>
             <a:r>
-              <a:t>III. A Intelbras monta pouco e depende de poucos parceiros nos elos críticos</a:t>
-            </a:r>
-          </a:p>
-        </p:txBody>
-      </p:sp>
-      <p:sp>
-        <p:nvSpPr>
-          <p:cNvPr id="11" name="Text Placeholder 10"/>
-          <p:cNvSpPr>
-            <a:spLocks noGrp="1"/>
-          </p:cNvSpPr>
-          <p:nvPr>
-            <p:ph type="body" idx="16" sz="quarter"/>
-          </p:nvPr>
-        </p:nvSpPr>
-        <p:spPr/>
-        <p:txBody>
-          <a:bodyPr/>
-          <a:lstStyle/>
-          <a:p>
-            <a:r>
-              <a:t>O que a Intelbras compra, de quem e se dá para trocar</a:t>
-            </a:r>
-          </a:p>
-        </p:txBody>
-      </p:sp>
-      <p:sp>
-        <p:nvSpPr>
-          <p:cNvPr id="13" name="Text Placeholder 12"/>
-          <p:cNvSpPr>
-            <a:spLocks noGrp="1"/>
-          </p:cNvSpPr>
-          <p:nvPr>
-            <p:ph type="body" idx="13" sz="quarter"/>
-          </p:nvPr>
-        </p:nvSpPr>
-        <p:spPr/>
-        <p:txBody>
-          <a:bodyPr/>
-          <a:lstStyle/>
-          <a:p>
-            <a:r>
-              <a:t>IV. Consequência: o modelo exige estoque alto, financiado em parte por fornecedores</a:t>
-            </a:r>
-          </a:p>
-        </p:txBody>
-      </p:sp>
-      <p:sp>
-        <p:nvSpPr>
-          <p:cNvPr id="14" name="Text Placeholder 13"/>
-          <p:cNvSpPr>
-            <a:spLocks noGrp="1"/>
-          </p:cNvSpPr>
-          <p:nvPr>
-            <p:ph type="body" idx="17" sz="quarter"/>
-          </p:nvPr>
-        </p:nvSpPr>
-        <p:spPr/>
-        <p:txBody>
-          <a:bodyPr/>
-          <a:lstStyle/>
-          <a:p>
-            <a:r>
-              <a:t>Dias de estoque vs prazo médio pago aos fornecedores (dias de custo)</a:t>
-            </a:r>
-          </a:p>
-        </p:txBody>
-      </p:sp>
-      <p:sp>
-        <p:nvSpPr>
-          <p:cNvPr id="16" name="Text Placeholder 15"/>
-          <p:cNvSpPr>
-            <a:spLocks noGrp="1"/>
-          </p:cNvSpPr>
-          <p:nvPr>
-            <p:ph type="body" idx="20" sz="quarter"/>
-          </p:nvPr>
-        </p:nvSpPr>
-        <p:spPr/>
-        <p:txBody>
-          <a:bodyPr/>
-          <a:lstStyle/>
-          <a:p>
-            <a:r>
-              <a:t>Fontes: Intelbras DFPs 2021–25 (NE 8, 14, 23, 25, 27), FRE 2026 (1.4.a, 1.4.e, 2.2), planilha 2T26 e teleconferências 4T21/4T24; Teletime (H3C, FiberHome). Dias = estoque e fornecedores (incl. risco sacado) ÷ custo dos produtos vendidos × 365.</a:t>
+              <a:t>Fontes: Intelbras DFPs 2021–25 (NE 8, 14, 25, 27) e FRE 2026 (2.2). Dias = estoque e fornecedores (incl. risco sacado) ÷ custo dos produtos vendidos × 365.</a:t>
             </a:r>
           </a:p>
         </p:txBody>
       </p:sp>
       <p:graphicFrame>
         <p:nvGraphicFramePr>
-          <p:cNvPr id="17" name="Grafico moeda estrangeira"/>
+          <p:cNvPr id="11" name="Grafico comprado e dolarizado"/>
           <p:cNvGraphicFramePr>
             <a:graphicFrameLocks noGrp="1"/>
           </p:cNvGraphicFramePr>
           <p:nvPr/>
         </p:nvGraphicFramePr>
         <p:xfrm>
-          <a:off x="566928" y="1591056"/>
-          <a:ext cx="3794760" cy="1892807"/>
+          <a:off x="566928" y="1563624"/>
+          <a:ext cx="8503920" cy="1938528"/>
         </p:xfrm>
         <a:graphic>
           <a:graphicData uri="http://schemas.openxmlformats.org/drawingml/2006/chart">
@@ -7281,14 +7159,14 @@
       </p:graphicFrame>
       <p:sp>
         <p:nvSpPr>
-          <p:cNvPr id="18" name="Callout descasamento"/>
+          <p:cNvPr id="12" name="Destaque cambio"/>
           <p:cNvSpPr txBox="1"/>
           <p:nvPr/>
         </p:nvSpPr>
         <p:spPr>
           <a:xfrm>
-            <a:off x="4498848" y="1655064"/>
-            <a:ext cx="1600200" cy="1828800"/>
+            <a:off x="9482328" y="1956816"/>
+            <a:ext cx="2468880" cy="1097280"/>
           </a:xfrm>
           <a:prstGeom prst="rect">
             <a:avLst/>
@@ -7303,69 +7181,46 @@
           <a:p>
             <a:pPr algn="l">
               <a:spcAft>
-                <a:spcPts val="600"/>
+                <a:spcPts val="0"/>
               </a:spcAft>
             </a:pPr>
             <a:r>
-              <a:rPr sz="1100" b="1" i="0">
+              <a:rPr sz="2600" b="1" i="0">
                 <a:solidFill>
                   <a:srgbClr val="1A1A1A"/>
                 </a:solidFill>
               </a:rPr>
-              <a:t>Custo em dólar, receita em real</a:t>
+              <a:t>+R$249 mi</a:t>
             </a:r>
           </a:p>
           <a:p>
             <a:pPr algn="l">
               <a:spcAft>
-                <a:spcPts val="800"/>
+                <a:spcPts val="0"/>
               </a:spcAft>
             </a:pPr>
             <a:r>
-              <a:rPr sz="1000" b="0" i="0">
+              <a:rPr sz="1100" b="0" i="0">
                 <a:solidFill>
                   <a:srgbClr val="595959"/>
                 </a:solidFill>
               </a:rPr>
-              <a:t>Exportações ≈ 0,5% da receita. Um dólar mais caro chega ao custo, não à receita</a:t>
-            </a:r>
-          </a:p>
-          <a:p>
-            <a:pPr algn="l">
-              <a:spcAft>
-                <a:spcPts val="0"/>
-              </a:spcAft>
-            </a:pPr>
-            <a:r>
-              <a:rPr sz="1000" b="1" i="0">
-                <a:solidFill>
-                  <a:srgbClr val="009F41"/>
-                </a:solidFill>
-              </a:rPr>
-              <a:t>O que pesa: </a:t>
-            </a:r>
-            <a:r>
-              <a:rPr sz="1000" b="0" i="0">
-                <a:solidFill>
-                  <a:srgbClr val="595959"/>
-                </a:solidFill>
-              </a:rPr>
-              <a:t>chips, placas de circuito, resina ABS e componentes</a:t>
+              <a:t>de custo por ano a cada +10% no dólar</a:t>
             </a:r>
           </a:p>
         </p:txBody>
       </p:sp>
       <p:graphicFrame>
         <p:nvGraphicFramePr>
-          <p:cNvPr id="19" name="Grafico comprado vs produzido"/>
+          <p:cNvPr id="13" name="Grafico estoque vs prazo"/>
           <p:cNvGraphicFramePr>
             <a:graphicFrameLocks noGrp="1"/>
           </p:cNvGraphicFramePr>
           <p:nvPr/>
         </p:nvGraphicFramePr>
         <p:xfrm>
-          <a:off x="6428232" y="1591056"/>
-          <a:ext cx="3840480" cy="1892807"/>
+          <a:off x="566928" y="4407408"/>
+          <a:ext cx="8503920" cy="1984248"/>
         </p:xfrm>
         <a:graphic>
           <a:graphicData uri="http://schemas.openxmlformats.org/drawingml/2006/chart">
@@ -7375,14 +7230,14 @@
       </p:graphicFrame>
       <p:sp>
         <p:nvSpPr>
-          <p:cNvPr id="20" name="Callout incentivos"/>
+          <p:cNvPr id="14" name="Destaque capital de giro"/>
           <p:cNvSpPr txBox="1"/>
           <p:nvPr/>
         </p:nvSpPr>
         <p:spPr>
           <a:xfrm>
-            <a:off x="10405872" y="1655064"/>
-            <a:ext cx="1554480" cy="1828800"/>
+            <a:off x="9482328" y="4818888"/>
+            <a:ext cx="2468880" cy="1097280"/>
           </a:xfrm>
           <a:prstGeom prst="rect">
             <a:avLst/>
@@ -7401,659 +7256,27 @@
               </a:spcAft>
             </a:pPr>
             <a:r>
-              <a:rPr sz="2000" b="1" i="0">
+              <a:rPr sz="2600" b="1" i="0">
                 <a:solidFill>
                   <a:srgbClr val="009F41"/>
                 </a:solidFill>
               </a:rPr>
-              <a:t>≈100%</a:t>
+              <a:t>≈R$0,4 bi</a:t>
             </a:r>
           </a:p>
           <a:p>
             <a:pPr algn="l">
               <a:spcAft>
-                <a:spcPts val="800"/>
+                <a:spcPts val="0"/>
               </a:spcAft>
             </a:pPr>
             <a:r>
-              <a:rPr sz="1000" b="0" i="0">
+              <a:rPr sz="1100" b="0" i="0">
                 <a:solidFill>
                   <a:srgbClr val="595959"/>
                 </a:solidFill>
               </a:rPr>
-              <a:t>do custo de produzir no Brasil é coberto pelos incentivos</a:t>
-            </a:r>
-          </a:p>
-          <a:p>
-            <a:pPr algn="l">
-              <a:spcAft>
-                <a:spcPts val="0"/>
-              </a:spcAft>
-            </a:pPr>
-            <a:r>
-              <a:rPr sz="1000" b="1" i="0">
-                <a:solidFill>
-                  <a:srgbClr val="1A1A1A"/>
-                </a:solidFill>
-              </a:rPr>
-              <a:t>A montagem local agrega pouco ao custo, mas é o que destrava o regime fiscal</a:t>
-            </a:r>
-          </a:p>
-        </p:txBody>
-      </p:sp>
-      <p:sp>
-        <p:nvSpPr>
-          <p:cNvPr id="21" name="Elo 1"/>
-          <p:cNvSpPr/>
-          <p:nvPr/>
-        </p:nvSpPr>
-        <p:spPr>
-          <a:xfrm>
-            <a:off x="566928" y="4425696"/>
-            <a:ext cx="1682496" cy="530352"/>
-          </a:xfrm>
-          <a:prstGeom prst="roundRect">
-            <a:avLst>
-              <a:gd name="adj" fmla="val 8000"/>
-            </a:avLst>
-          </a:prstGeom>
-          <a:solidFill>
-            <a:srgbClr val="F2F2F2"/>
-          </a:solidFill>
-          <a:ln>
-            <a:noFill/>
-          </a:ln>
-          <a:effectLst/>
-        </p:spPr>
-        <p:style>
-          <a:lnRef idx="1">
-            <a:schemeClr val="accent1"/>
-          </a:lnRef>
-          <a:fillRef idx="3">
-            <a:schemeClr val="accent1"/>
-          </a:fillRef>
-          <a:effectRef idx="2">
-            <a:schemeClr val="accent1"/>
-          </a:effectRef>
-          <a:fontRef idx="minor">
-            <a:schemeClr val="lt1"/>
-          </a:fontRef>
-        </p:style>
-        <p:txBody>
-          <a:bodyPr rtlCol="0" anchor="ctr" lIns="54864" rIns="54864" tIns="18288" bIns="18288" wrap="square"/>
-          <a:lstStyle/>
-          <a:p>
-            <a:pPr algn="ctr"/>
-            <a:r>
-              <a:rPr sz="1000" b="1">
-                <a:solidFill>
-                  <a:srgbClr val="1A1A1A"/>
-                </a:solidFill>
-              </a:rPr>
-              <a:t>Componentes</a:t>
-            </a:r>
-          </a:p>
-          <a:p>
-            <a:pPr algn="ctr"/>
-            <a:r>
-              <a:rPr sz="850">
-                <a:solidFill>
-                  <a:srgbClr val="595959"/>
-                </a:solidFill>
-              </a:rPr>
-              <a:t>chips, memória, placas, resina ABS, passivos</a:t>
-            </a:r>
-          </a:p>
-        </p:txBody>
-      </p:sp>
-      <p:cxnSp>
-        <p:nvCxnSpPr>
-          <p:cNvPr id="22" name="Connector 21"/>
-          <p:cNvCxnSpPr/>
-          <p:nvPr/>
-        </p:nvCxnSpPr>
-        <p:spPr>
-          <a:xfrm>
-            <a:off x="2276856" y="4690872"/>
-            <a:ext cx="192024" cy="0"/>
-          </a:xfrm>
-          <a:prstGeom prst="line">
-            <a:avLst/>
-          </a:prstGeom>
-          <a:ln w="19050">
-            <a:solidFill>
-              <a:srgbClr val="8C8C8C"/>
-            </a:solidFill>
-            <a:tailEnd type="triangle" w="med" len="med"/>
-          </a:ln>
-        </p:spPr>
-        <p:style>
-          <a:lnRef idx="2">
-            <a:schemeClr val="accent1"/>
-          </a:lnRef>
-          <a:fillRef idx="0">
-            <a:schemeClr val="accent1"/>
-          </a:fillRef>
-          <a:effectRef idx="1">
-            <a:schemeClr val="accent1"/>
-          </a:effectRef>
-          <a:fontRef idx="minor">
-            <a:schemeClr val="tx1"/>
-          </a:fontRef>
-        </p:style>
-      </p:cxnSp>
-      <p:sp>
-        <p:nvSpPr>
-          <p:cNvPr id="23" name="Detalhe elo 1"/>
-          <p:cNvSpPr txBox="1"/>
-          <p:nvPr/>
-        </p:nvSpPr>
-        <p:spPr>
-          <a:xfrm>
-            <a:off x="566928" y="5020056"/>
-            <a:ext cx="1682496" cy="566928"/>
-          </a:xfrm>
-          <a:prstGeom prst="rect">
-            <a:avLst/>
-          </a:prstGeom>
-          <a:noFill/>
-        </p:spPr>
-        <p:txBody>
-          <a:bodyPr wrap="square" lIns="0" rIns="0" tIns="0" bIns="0" anchor="t">
-            <a:spAutoFit/>
-          </a:bodyPr>
-          <a:lstStyle/>
-          <a:p>
-            <a:pPr algn="ctr">
-              <a:spcAft>
-                <a:spcPts val="0"/>
-              </a:spcAft>
-            </a:pPr>
-            <a:r>
-              <a:rPr sz="850" b="0" i="0">
-                <a:solidFill>
-                  <a:srgbClr val="595959"/>
-                </a:solidFill>
-              </a:rPr>
-              <a:t>Fornecedores asiáticos. Chips: troca difícil (“poucas opções”, FRE). Placas e ABS: substituíveis</a:t>
-            </a:r>
-          </a:p>
-        </p:txBody>
-      </p:sp>
-      <p:sp>
-        <p:nvSpPr>
-          <p:cNvPr id="24" name="Elo 2"/>
-          <p:cNvSpPr/>
-          <p:nvPr/>
-        </p:nvSpPr>
-        <p:spPr>
-          <a:xfrm>
-            <a:off x="2496312" y="4425696"/>
-            <a:ext cx="1682496" cy="530352"/>
-          </a:xfrm>
-          <a:prstGeom prst="roundRect">
-            <a:avLst>
-              <a:gd name="adj" fmla="val 8000"/>
-            </a:avLst>
-          </a:prstGeom>
-          <a:solidFill>
-            <a:srgbClr val="009F41"/>
-          </a:solidFill>
-          <a:ln>
-            <a:noFill/>
-          </a:ln>
-          <a:effectLst/>
-        </p:spPr>
-        <p:style>
-          <a:lnRef idx="1">
-            <a:schemeClr val="accent1"/>
-          </a:lnRef>
-          <a:fillRef idx="3">
-            <a:schemeClr val="accent1"/>
-          </a:fillRef>
-          <a:effectRef idx="2">
-            <a:schemeClr val="accent1"/>
-          </a:effectRef>
-          <a:fontRef idx="minor">
-            <a:schemeClr val="lt1"/>
-          </a:fontRef>
-        </p:style>
-        <p:txBody>
-          <a:bodyPr rtlCol="0" anchor="ctr" lIns="54864" rIns="54864" tIns="18288" bIns="18288" wrap="square"/>
-          <a:lstStyle/>
-          <a:p>
-            <a:pPr algn="ctr"/>
-            <a:r>
-              <a:rPr sz="1000" b="1">
-                <a:solidFill>
-                  <a:srgbClr val="FFFFFF"/>
-                </a:solidFill>
-              </a:rPr>
-              <a:t>Montagem no Brasil</a:t>
-            </a:r>
-          </a:p>
-          <a:p>
-            <a:pPr algn="ctr"/>
-            <a:r>
-              <a:rPr sz="850">
-                <a:solidFill>
-                  <a:srgbClr val="FFFFFF"/>
-                </a:solidFill>
-              </a:rPr>
-              <a:t>4 fábricas (SC, AM, MG); ~15% do custo</a:t>
-            </a:r>
-          </a:p>
-        </p:txBody>
-      </p:sp>
-      <p:cxnSp>
-        <p:nvCxnSpPr>
-          <p:cNvPr id="25" name="Connector 24"/>
-          <p:cNvCxnSpPr/>
-          <p:nvPr/>
-        </p:nvCxnSpPr>
-        <p:spPr>
-          <a:xfrm>
-            <a:off x="4206240" y="4690872"/>
-            <a:ext cx="192024" cy="0"/>
-          </a:xfrm>
-          <a:prstGeom prst="line">
-            <a:avLst/>
-          </a:prstGeom>
-          <a:ln w="19050">
-            <a:solidFill>
-              <a:srgbClr val="8C8C8C"/>
-            </a:solidFill>
-            <a:tailEnd type="triangle" w="med" len="med"/>
-          </a:ln>
-        </p:spPr>
-        <p:style>
-          <a:lnRef idx="2">
-            <a:schemeClr val="accent1"/>
-          </a:lnRef>
-          <a:fillRef idx="0">
-            <a:schemeClr val="accent1"/>
-          </a:fillRef>
-          <a:effectRef idx="1">
-            <a:schemeClr val="accent1"/>
-          </a:effectRef>
-          <a:fontRef idx="minor">
-            <a:schemeClr val="tx1"/>
-          </a:fontRef>
-        </p:style>
-      </p:cxnSp>
-      <p:sp>
-        <p:nvSpPr>
-          <p:cNvPr id="26" name="Detalhe elo 2"/>
-          <p:cNvSpPr txBox="1"/>
-          <p:nvPr/>
-        </p:nvSpPr>
-        <p:spPr>
-          <a:xfrm>
-            <a:off x="2496312" y="5020056"/>
-            <a:ext cx="1682496" cy="566928"/>
-          </a:xfrm>
-          <a:prstGeom prst="rect">
-            <a:avLst/>
-          </a:prstGeom>
-          <a:noFill/>
-        </p:spPr>
-        <p:txBody>
-          <a:bodyPr wrap="square" lIns="0" rIns="0" tIns="0" bIns="0" anchor="t">
-            <a:spAutoFit/>
-          </a:bodyPr>
-          <a:lstStyle/>
-          <a:p>
-            <a:pPr algn="ctr">
-              <a:spcAft>
-                <a:spcPts val="0"/>
-              </a:spcAft>
-            </a:pPr>
-            <a:r>
-              <a:rPr sz="850" b="0" i="0">
-                <a:solidFill>
-                  <a:srgbClr val="595959"/>
-                </a:solidFill>
-              </a:rPr>
-              <a:t>Própria: placas montadas em linhas SMD, homologação e processo produtivo exigido pelos incentivos</a:t>
-            </a:r>
-          </a:p>
-        </p:txBody>
-      </p:sp>
-      <p:sp>
-        <p:nvSpPr>
-          <p:cNvPr id="27" name="Elo 3"/>
-          <p:cNvSpPr/>
-          <p:nvPr/>
-        </p:nvSpPr>
-        <p:spPr>
-          <a:xfrm>
-            <a:off x="4425696" y="4425696"/>
-            <a:ext cx="1682496" cy="530352"/>
-          </a:xfrm>
-          <a:prstGeom prst="roundRect">
-            <a:avLst>
-              <a:gd name="adj" fmla="val 8000"/>
-            </a:avLst>
-          </a:prstGeom>
-          <a:solidFill>
-            <a:srgbClr val="1A1A1A"/>
-          </a:solidFill>
-          <a:ln>
-            <a:noFill/>
-          </a:ln>
-          <a:effectLst/>
-        </p:spPr>
-        <p:style>
-          <a:lnRef idx="1">
-            <a:schemeClr val="accent1"/>
-          </a:lnRef>
-          <a:fillRef idx="3">
-            <a:schemeClr val="accent1"/>
-          </a:fillRef>
-          <a:effectRef idx="2">
-            <a:schemeClr val="accent1"/>
-          </a:effectRef>
-          <a:fontRef idx="minor">
-            <a:schemeClr val="lt1"/>
-          </a:fontRef>
-        </p:style>
-        <p:txBody>
-          <a:bodyPr rtlCol="0" anchor="ctr" lIns="54864" rIns="54864" tIns="18288" bIns="18288" wrap="square"/>
-          <a:lstStyle/>
-          <a:p>
-            <a:pPr algn="ctr"/>
-            <a:r>
-              <a:rPr sz="1000" b="1">
-                <a:solidFill>
-                  <a:srgbClr val="FFFFFF"/>
-                </a:solidFill>
-              </a:rPr>
-              <a:t>Produto pronto</a:t>
-            </a:r>
-          </a:p>
-          <a:p>
-            <a:pPr algn="ctr"/>
-            <a:r>
-              <a:rPr sz="850">
-                <a:solidFill>
-                  <a:srgbClr val="FFFFFF"/>
-                </a:solidFill>
-              </a:rPr>
-              <a:t>comprado de parceiros</a:t>
-            </a:r>
-          </a:p>
-        </p:txBody>
-      </p:sp>
-      <p:sp>
-        <p:nvSpPr>
-          <p:cNvPr id="28" name="Detalhe elo 3"/>
-          <p:cNvSpPr txBox="1"/>
-          <p:nvPr/>
-        </p:nvSpPr>
-        <p:spPr>
-          <a:xfrm>
-            <a:off x="4425696" y="5020056"/>
-            <a:ext cx="1682496" cy="566928"/>
-          </a:xfrm>
-          <a:prstGeom prst="rect">
-            <a:avLst/>
-          </a:prstGeom>
-          <a:noFill/>
-        </p:spPr>
-        <p:txBody>
-          <a:bodyPr wrap="square" lIns="0" rIns="0" tIns="0" bIns="0" anchor="t">
-            <a:spAutoFit/>
-          </a:bodyPr>
-          <a:lstStyle/>
-          <a:p>
-            <a:pPr algn="ctr">
-              <a:spcAft>
-                <a:spcPts val="0"/>
-              </a:spcAft>
-            </a:pPr>
-            <a:r>
-              <a:rPr sz="850" b="0" i="0">
-                <a:solidFill>
-                  <a:srgbClr val="595959"/>
-                </a:solidFill>
-              </a:rPr>
-              <a:t>Dahua (CFTV, por contrato até 2028), H3C (redes), FiberHome (GPON, até jan/26), OEMs na Ásia</a:t>
-            </a:r>
-          </a:p>
-        </p:txBody>
-      </p:sp>
-      <p:sp>
-        <p:nvSpPr>
-          <p:cNvPr id="29" name="Rotulo peso Dahua"/>
-          <p:cNvSpPr txBox="1"/>
-          <p:nvPr/>
-        </p:nvSpPr>
-        <p:spPr>
-          <a:xfrm>
-            <a:off x="566928" y="5669280"/>
-            <a:ext cx="5532120" cy="164592"/>
-          </a:xfrm>
-          <a:prstGeom prst="rect">
-            <a:avLst/>
-          </a:prstGeom>
-          <a:noFill/>
-        </p:spPr>
-        <p:txBody>
-          <a:bodyPr wrap="square" lIns="0" rIns="0" tIns="0" bIns="0" anchor="t">
-            <a:spAutoFit/>
-          </a:bodyPr>
-          <a:lstStyle/>
-          <a:p>
-            <a:pPr algn="l">
-              <a:spcAft>
-                <a:spcPts val="0"/>
-              </a:spcAft>
-            </a:pPr>
-            <a:r>
-              <a:rPr sz="800" b="1" i="0">
-                <a:solidFill>
-                  <a:srgbClr val="6B6B6B"/>
-                </a:solidFill>
-              </a:rPr>
-              <a:t>Peso do maior fornecedor nos gastos, 2025</a:t>
-            </a:r>
-          </a:p>
-        </p:txBody>
-      </p:sp>
-      <p:sp>
-        <p:nvSpPr>
-          <p:cNvPr id="30" name="Barra Dahua 36"/>
-          <p:cNvSpPr/>
-          <p:nvPr/>
-        </p:nvSpPr>
-        <p:spPr>
-          <a:xfrm>
-            <a:off x="566928" y="5852160"/>
-            <a:ext cx="1991563" cy="384048"/>
-          </a:xfrm>
-          <a:prstGeom prst="rect">
-            <a:avLst/>
-          </a:prstGeom>
-          <a:solidFill>
-            <a:srgbClr val="009F41"/>
-          </a:solidFill>
-          <a:ln>
-            <a:noFill/>
-          </a:ln>
-          <a:effectLst/>
-        </p:spPr>
-        <p:style>
-          <a:lnRef idx="1">
-            <a:schemeClr val="accent1"/>
-          </a:lnRef>
-          <a:fillRef idx="3">
-            <a:schemeClr val="accent1"/>
-          </a:fillRef>
-          <a:effectRef idx="2">
-            <a:schemeClr val="accent1"/>
-          </a:effectRef>
-          <a:fontRef idx="minor">
-            <a:schemeClr val="lt1"/>
-          </a:fontRef>
-        </p:style>
-        <p:txBody>
-          <a:bodyPr rtlCol="0" anchor="ctr" lIns="45720" rIns="45720"/>
-          <a:lstStyle/>
-          <a:p>
-            <a:pPr algn="ctr"/>
-            <a:r>
-              <a:rPr sz="1100" b="1">
-                <a:solidFill>
-                  <a:srgbClr val="FFFFFF"/>
-                </a:solidFill>
-              </a:rPr>
-              <a:t>Dahua  36%</a:t>
-            </a:r>
-          </a:p>
-        </p:txBody>
-      </p:sp>
-      <p:sp>
-        <p:nvSpPr>
-          <p:cNvPr id="31" name="Barra demais 64"/>
-          <p:cNvSpPr/>
-          <p:nvPr/>
-        </p:nvSpPr>
-        <p:spPr>
-          <a:xfrm>
-            <a:off x="2585923" y="5852160"/>
-            <a:ext cx="3513124" cy="384048"/>
-          </a:xfrm>
-          <a:prstGeom prst="rect">
-            <a:avLst/>
-          </a:prstGeom>
-          <a:solidFill>
-            <a:srgbClr val="E3E3E3"/>
-          </a:solidFill>
-          <a:ln>
-            <a:noFill/>
-          </a:ln>
-          <a:effectLst/>
-        </p:spPr>
-        <p:style>
-          <a:lnRef idx="1">
-            <a:schemeClr val="accent1"/>
-          </a:lnRef>
-          <a:fillRef idx="3">
-            <a:schemeClr val="accent1"/>
-          </a:fillRef>
-          <a:effectRef idx="2">
-            <a:schemeClr val="accent1"/>
-          </a:effectRef>
-          <a:fontRef idx="minor">
-            <a:schemeClr val="lt1"/>
-          </a:fontRef>
-        </p:style>
-        <p:txBody>
-          <a:bodyPr rtlCol="0" anchor="ctr" lIns="45720" rIns="45720"/>
-          <a:lstStyle/>
-          <a:p>
-            <a:pPr algn="ctr"/>
-            <a:r>
-              <a:rPr sz="1100" b="0">
-                <a:solidFill>
-                  <a:srgbClr val="595959"/>
-                </a:solidFill>
-              </a:rPr>
-              <a:t>Todos os demais fornecedores  64%</a:t>
-            </a:r>
-          </a:p>
-        </p:txBody>
-      </p:sp>
-      <p:graphicFrame>
-        <p:nvGraphicFramePr>
-          <p:cNvPr id="32" name="Grafico estoque vs prazo"/>
-          <p:cNvGraphicFramePr>
-            <a:graphicFrameLocks noGrp="1"/>
-          </p:cNvGraphicFramePr>
-          <p:nvPr/>
-        </p:nvGraphicFramePr>
-        <p:xfrm>
-          <a:off x="6428232" y="4407408"/>
-          <a:ext cx="3840480" cy="1984248"/>
-        </p:xfrm>
-        <a:graphic>
-          <a:graphicData uri="http://schemas.openxmlformats.org/drawingml/2006/chart">
-            <c:chart xmlns:c="http://schemas.openxmlformats.org/drawingml/2006/chart" r:id="rId4"/>
-          </a:graphicData>
-        </a:graphic>
-      </p:graphicFrame>
-      <p:sp>
-        <p:nvSpPr>
-          <p:cNvPr id="33" name="Callout capital de giro"/>
-          <p:cNvSpPr txBox="1"/>
-          <p:nvPr/>
-        </p:nvSpPr>
-        <p:spPr>
-          <a:xfrm>
-            <a:off x="10405872" y="4498848"/>
-            <a:ext cx="1554480" cy="1874519"/>
-          </a:xfrm>
-          <a:prstGeom prst="rect">
-            <a:avLst/>
-          </a:prstGeom>
-          <a:noFill/>
-        </p:spPr>
-        <p:txBody>
-          <a:bodyPr wrap="square" lIns="0" rIns="0" tIns="0" bIns="0" anchor="t">
-            <a:spAutoFit/>
-          </a:bodyPr>
-          <a:lstStyle/>
-          <a:p>
-            <a:pPr algn="l">
-              <a:spcAft>
-                <a:spcPts val="0"/>
-              </a:spcAft>
-            </a:pPr>
-            <a:r>
-              <a:rPr sz="2000" b="1" i="0">
-                <a:solidFill>
-                  <a:srgbClr val="009F41"/>
-                </a:solidFill>
-              </a:rPr>
-              <a:t>~40–70 dias</a:t>
-            </a:r>
-          </a:p>
-          <a:p>
-            <a:pPr algn="l">
-              <a:spcAft>
-                <a:spcPts val="800"/>
-              </a:spcAft>
-            </a:pPr>
-            <a:r>
-              <a:rPr sz="1000" b="0" i="0">
-                <a:solidFill>
-                  <a:srgbClr val="595959"/>
-                </a:solidFill>
-              </a:rPr>
-              <a:t>de compras que a Intelbras financia com caixa próprio (≈R$0,4 bi em 2025)</a:t>
-            </a:r>
-          </a:p>
-          <a:p>
-            <a:pPr algn="l">
-              <a:spcAft>
-                <a:spcPts val="0"/>
-              </a:spcAft>
-            </a:pPr>
-            <a:r>
-              <a:rPr sz="1000" b="1" i="0">
-                <a:solidFill>
-                  <a:srgbClr val="1A1A1A"/>
-                </a:solidFill>
-              </a:rPr>
-              <a:t>2021 e 2024: </a:t>
-            </a:r>
-            <a:r>
-              <a:rPr sz="1000" b="0" i="0">
-                <a:solidFill>
-                  <a:srgbClr val="595959"/>
-                </a:solidFill>
-              </a:rPr>
-              <a:t>estoque elevado de propósito, para proteger o suprimento</a:t>
+              <a:t>do caixa da Intelbras financia esse vão (2025)</a:t>
             </a:r>
           </a:p>
         </p:txBody>
@@ -8113,7 +7336,7 @@
           <a:lstStyle/>
           <a:p>
             <a:r>
-              <a:t>A Dahua entrega a tecnologia de CFTV e recebe o canal; mas pesa cada vez mais nas compras e no crédito da Intelbras e está saindo do capital antes de 2028</a:t>
+              <a:t>A Dahua troca tecnologia pelo canal da Intelbras, mas pesa cada vez mais e está saindo antes de 2028</a:t>
             </a:r>
           </a:p>
         </p:txBody>
@@ -8134,7 +7357,7 @@
           <a:lstStyle/>
           <a:p>
             <a:r>
-              <a:t>I. Concentração em alta: 36% dos gastos com fornecedores (28,6% em 2021)</a:t>
+              <a:t>I. Um terço dos gastos com fornecedores já vai para a Dahua</a:t>
             </a:r>
           </a:p>
         </p:txBody>
@@ -8155,7 +7378,7 @@
           <a:lstStyle/>
           <a:p>
             <a:r>
-              <a:t>Dahua em % dos gastos com fornecedores (FRE) e em % do custo dos produtos vendidos (DFP)</a:t>
+              <a:t>Dahua em % dos gastos com fornecedores (FRE) e do custo dos produtos vendidos (DFP)</a:t>
             </a:r>
           </a:p>
         </p:txBody>
@@ -8176,7 +7399,7 @@
           <a:lstStyle/>
           <a:p>
             <a:r>
-              <a:t>II. Dependência mútua, mas assimétrica: a Intelbras precisa mais da Dahua</a:t>
+              <a:t>II. A troca é mútua, mas quem mais precisa é a Intelbras</a:t>
             </a:r>
           </a:p>
         </p:txBody>
@@ -8197,7 +7420,7 @@
           <a:lstStyle/>
           <a:p>
             <a:r>
-              <a:t>Acordo de Cooperação (dez/2018 → dez/2028): o que cada lado entrega</a:t>
+              <a:t>Acordo de 2018 a 2028: o que cada lado entrega e quanto um pesa no outro (2025)</a:t>
             </a:r>
           </a:p>
         </p:txBody>
@@ -8218,7 +7441,7 @@
           <a:lstStyle/>
           <a:p>
             <a:r>
-              <a:t>III. A Dahua também financia a Intelbras: 43% das contas a pagar, 225 dias de prazo</a:t>
+              <a:t>III. A Dahua também financia a Intelbras: 43% das contas a pagar</a:t>
             </a:r>
           </a:p>
         </p:txBody>
@@ -8239,7 +7462,7 @@
           <a:lstStyle/>
           <a:p>
             <a:r>
-              <a:t>Saldo a pagar à Dahua (R$ milhões) e % do total de fornecedores + risco sacado</a:t>
+              <a:t>Saldo a pagar à Dahua (R$ mi) e % do total de fornecedores; prazo implícito de 225 dias em 2025</a:t>
             </a:r>
           </a:p>
         </p:txBody>
@@ -8260,7 +7483,7 @@
           <a:lstStyle/>
           <a:p>
             <a:r>
-              <a:t>IV. Sinais de afastamento: a Dahua sai do capital e o acordo vence em 2028</a:t>
+              <a:t>IV. A Dahua está saindo do capital, e o acordo vence em 2028</a:t>
             </a:r>
           </a:p>
         </p:txBody>
@@ -8281,7 +7504,7 @@
           <a:lstStyle/>
           <a:p>
             <a:r>
-              <a:t>Linha do tempo da relação: participação acionária e marcos</a:t>
+              <a:t>Participação da Dahua no capital da Intelbras (%) e marcos do acordo</a:t>
             </a:r>
           </a:p>
         </p:txBody>
@@ -8302,7 +7525,7 @@
           <a:lstStyle/>
           <a:p>
             <a:r>
-              <a:t>Fontes: Intelbras DFPs 2021–25 (NE partes relacionadas e fornecedores), FRE 2026 (1.4.e, 11.2, 11.3); Nord Research (2021); Hikvision e Dahua (P&amp;D); Brazil Journal; FilingReader; Dahua Brasil; Teletime.</a:t>
+              <a:t>Fontes: Intelbras DFPs 2021–25 (NE partes relacionadas e fornecedores), FRE 2026 (1.4.e, 11.3); Nord Research (2021); Dahua (P&amp;D 2024, receita 2025); Brazil Journal; FilingReader.</a:t>
             </a:r>
           </a:p>
         </p:txBody>
@@ -8317,7 +7540,7 @@
         </p:nvGraphicFramePr>
         <p:xfrm>
           <a:off x="566928" y="1545336"/>
-          <a:ext cx="3794760" cy="1984248"/>
+          <a:ext cx="5532120" cy="1984248"/>
         </p:xfrm>
         <a:graphic>
           <a:graphicData uri="http://schemas.openxmlformats.org/drawingml/2006/chart">
@@ -8327,90 +7550,14 @@
       </p:graphicFrame>
       <p:sp>
         <p:nvSpPr>
-          <p:cNvPr id="18" name="Callout compras Dahua"/>
-          <p:cNvSpPr txBox="1"/>
-          <p:nvPr/>
-        </p:nvSpPr>
-        <p:spPr>
-          <a:xfrm>
-            <a:off x="4498848" y="1636776"/>
-            <a:ext cx="1600200" cy="1874519"/>
-          </a:xfrm>
-          <a:prstGeom prst="rect">
-            <a:avLst/>
-          </a:prstGeom>
-          <a:noFill/>
-        </p:spPr>
-        <p:txBody>
-          <a:bodyPr wrap="square" lIns="0" rIns="0" tIns="0" bIns="0" anchor="t">
-            <a:spAutoFit/>
-          </a:bodyPr>
-          <a:lstStyle/>
-          <a:p>
-            <a:pPr algn="l">
-              <a:spcAft>
-                <a:spcPts val="0"/>
-              </a:spcAft>
-            </a:pPr>
-            <a:r>
-              <a:rPr sz="2000" b="1" i="0">
-                <a:solidFill>
-                  <a:srgbClr val="1A1A1A"/>
-                </a:solidFill>
-              </a:rPr>
-              <a:t>R$729 mi</a:t>
-            </a:r>
-          </a:p>
-          <a:p>
-            <a:pPr algn="l">
-              <a:spcAft>
-                <a:spcPts val="800"/>
-              </a:spcAft>
-            </a:pPr>
-            <a:r>
-              <a:rPr sz="1000" b="0" i="0">
-                <a:solidFill>
-                  <a:srgbClr val="595959"/>
-                </a:solidFill>
-              </a:rPr>
-              <a:t>comprados da Dahua em 2025 (R$515 mi em 2021)</a:t>
-            </a:r>
-          </a:p>
-          <a:p>
-            <a:pPr algn="l">
-              <a:spcAft>
-                <a:spcPts val="0"/>
-              </a:spcAft>
-            </a:pPr>
-            <a:r>
-              <a:rPr sz="1000" b="1" i="0">
-                <a:solidFill>
-                  <a:srgbClr val="009F41"/>
-                </a:solidFill>
-              </a:rPr>
-              <a:t>2024: </a:t>
-            </a:r>
-            <a:r>
-              <a:rPr sz="1000" b="0" i="0">
-                <a:solidFill>
-                  <a:srgbClr val="595959"/>
-                </a:solidFill>
-              </a:rPr>
-              <a:t>R$1,19 bi, compra antecipada para proteger o suprimento</a:t>
-            </a:r>
-          </a:p>
-        </p:txBody>
-      </p:sp>
-      <p:sp>
-        <p:nvSpPr>
-          <p:cNvPr id="19" name="Caixa Intelbras"/>
+          <p:cNvPr id="18" name="Caixa Intelbras"/>
           <p:cNvSpPr/>
           <p:nvPr/>
         </p:nvSpPr>
         <p:spPr>
           <a:xfrm>
-            <a:off x="6428232" y="1591056"/>
-            <a:ext cx="1143000" cy="822960"/>
+            <a:off x="6428232" y="1563624"/>
+            <a:ext cx="1234440" cy="731520"/>
           </a:xfrm>
           <a:prstGeom prst="roundRect">
             <a:avLst>
@@ -8440,12 +7587,12 @@
           </a:fontRef>
         </p:style>
         <p:txBody>
-          <a:bodyPr rtlCol="0" anchor="ctr" lIns="45720" rIns="45720" wrap="square"/>
+          <a:bodyPr rtlCol="0" anchor="ctr"/>
           <a:lstStyle/>
           <a:p>
             <a:pPr algn="ctr"/>
             <a:r>
-              <a:rPr sz="1300" b="1">
+              <a:rPr sz="1400" b="1">
                 <a:solidFill>
                   <a:srgbClr val="FFFFFF"/>
                 </a:solidFill>
@@ -8453,29 +7600,18 @@
               <a:t>Intelbras</a:t>
             </a:r>
           </a:p>
-          <a:p>
-            <a:pPr algn="ctr"/>
-            <a:r>
-              <a:rPr sz="850">
-                <a:solidFill>
-                  <a:srgbClr val="FFFFFF"/>
-                </a:solidFill>
-              </a:rPr>
-              <a:t>marca e canal</a:t>
-            </a:r>
-          </a:p>
-        </p:txBody>
-      </p:sp>
-      <p:sp>
-        <p:nvSpPr>
-          <p:cNvPr id="20" name="Caixa Dahua"/>
+        </p:txBody>
+      </p:sp>
+      <p:sp>
+        <p:nvSpPr>
+          <p:cNvPr id="19" name="Caixa Dahua"/>
           <p:cNvSpPr/>
           <p:nvPr/>
         </p:nvSpPr>
         <p:spPr>
           <a:xfrm>
-            <a:off x="10817352" y="1591056"/>
-            <a:ext cx="1143000" cy="822960"/>
+            <a:off x="10725912" y="1563624"/>
+            <a:ext cx="1234440" cy="731520"/>
           </a:xfrm>
           <a:prstGeom prst="roundRect">
             <a:avLst>
@@ -8505,12 +7641,12 @@
           </a:fontRef>
         </p:style>
         <p:txBody>
-          <a:bodyPr rtlCol="0" anchor="ctr" lIns="45720" rIns="45720" wrap="square"/>
+          <a:bodyPr rtlCol="0" anchor="ctr"/>
           <a:lstStyle/>
           <a:p>
             <a:pPr algn="ctr"/>
             <a:r>
-              <a:rPr sz="1300" b="1">
+              <a:rPr sz="1400" b="1">
                 <a:solidFill>
                   <a:srgbClr val="FFFFFF"/>
                 </a:solidFill>
@@ -8518,34 +7654,23 @@
               <a:t>Dahua</a:t>
             </a:r>
           </a:p>
-          <a:p>
-            <a:pPr algn="ctr"/>
-            <a:r>
-              <a:rPr sz="850">
-                <a:solidFill>
-                  <a:srgbClr val="FFFFFF"/>
-                </a:solidFill>
-              </a:rPr>
-              <a:t>nº 2 mundial em câmeras e acionista</a:t>
-            </a:r>
-          </a:p>
         </p:txBody>
       </p:sp>
       <p:cxnSp>
         <p:nvCxnSpPr>
-          <p:cNvPr id="21" name="Connector 20"/>
+          <p:cNvPr id="20" name="Connector 19"/>
           <p:cNvCxnSpPr/>
           <p:nvPr/>
         </p:nvCxnSpPr>
         <p:spPr>
           <a:xfrm flipH="1">
-            <a:off x="7644384" y="1920240"/>
-            <a:ext cx="3099816" cy="0"/>
+            <a:off x="7735824" y="1819656"/>
+            <a:ext cx="2916936" cy="0"/>
           </a:xfrm>
           <a:prstGeom prst="line">
             <a:avLst/>
           </a:prstGeom>
-          <a:ln w="19050">
+          <a:ln w="22225">
             <a:solidFill>
               <a:srgbClr val="1A1A1A"/>
             </a:solidFill>
@@ -8569,19 +7694,19 @@
       </p:cxnSp>
       <p:cxnSp>
         <p:nvCxnSpPr>
-          <p:cNvPr id="22" name="Connector 21"/>
+          <p:cNvPr id="21" name="Connector 20"/>
           <p:cNvCxnSpPr/>
           <p:nvPr/>
         </p:nvCxnSpPr>
         <p:spPr>
           <a:xfrm>
-            <a:off x="7644384" y="2139696"/>
-            <a:ext cx="3099816" cy="0"/>
+            <a:off x="7735824" y="2057400"/>
+            <a:ext cx="2916936" cy="0"/>
           </a:xfrm>
           <a:prstGeom prst="line">
             <a:avLst/>
           </a:prstGeom>
-          <a:ln w="19050">
+          <a:ln w="22225">
             <a:solidFill>
               <a:srgbClr val="009F41"/>
             </a:solidFill>
@@ -8605,14 +7730,14 @@
       </p:cxnSp>
       <p:sp>
         <p:nvSpPr>
-          <p:cNvPr id="23" name="Texto Dahua entrega"/>
+          <p:cNvPr id="22" name="Seta Dahua entrega"/>
           <p:cNvSpPr txBox="1"/>
           <p:nvPr/>
         </p:nvSpPr>
         <p:spPr>
           <a:xfrm>
-            <a:off x="7644384" y="1517904"/>
-            <a:ext cx="3099815" cy="365760"/>
+            <a:off x="7735824" y="1527048"/>
+            <a:ext cx="2916935" cy="237744"/>
           </a:xfrm>
           <a:prstGeom prst="rect">
             <a:avLst/>
@@ -8631,34 +7756,26 @@
               </a:spcAft>
             </a:pPr>
             <a:r>
-              <a:rPr sz="900" b="1" i="0">
+              <a:rPr sz="1000" b="1" i="0">
                 <a:solidFill>
                   <a:srgbClr val="1A1A1A"/>
                 </a:solidFill>
               </a:rPr>
-              <a:t>Dahua entrega: </a:t>
-            </a:r>
-            <a:r>
-              <a:rPr sz="900" b="0" i="0">
-                <a:solidFill>
-                  <a:srgbClr val="595959"/>
-                </a:solidFill>
-              </a:rPr>
-              <a:t>tecnologia de CFTV (P&amp;D 18x maior), exclusividade da marca e ~7 meses de prazo</a:t>
-            </a:r>
-          </a:p>
-        </p:txBody>
-      </p:sp>
-      <p:sp>
-        <p:nvSpPr>
-          <p:cNvPr id="24" name="Texto Intelbras entrega"/>
+              <a:t>tecnologia de câmeras + prazo</a:t>
+            </a:r>
+          </a:p>
+        </p:txBody>
+      </p:sp>
+      <p:sp>
+        <p:nvSpPr>
+          <p:cNvPr id="23" name="Seta Intelbras entrega"/>
           <p:cNvSpPr txBox="1"/>
           <p:nvPr/>
         </p:nvSpPr>
         <p:spPr>
           <a:xfrm>
-            <a:off x="7644384" y="2194560"/>
-            <a:ext cx="3099815" cy="365760"/>
+            <a:off x="7735824" y="2093976"/>
+            <a:ext cx="2916935" cy="237744"/>
           </a:xfrm>
           <a:prstGeom prst="rect">
             <a:avLst/>
@@ -8677,248 +7794,37 @@
               </a:spcAft>
             </a:pPr>
             <a:r>
-              <a:rPr sz="900" b="1" i="0">
+              <a:rPr sz="1000" b="1" i="0">
                 <a:solidFill>
                   <a:srgbClr val="009F41"/>
                 </a:solidFill>
               </a:rPr>
-              <a:t>Intelbras entrega: </a:t>
-            </a:r>
-            <a:r>
-              <a:rPr sz="900" b="0" i="0">
-                <a:solidFill>
-                  <a:srgbClr val="595959"/>
-                </a:solidFill>
-              </a:rPr>
-              <a:t>canal de 500 distribuidores e 90 mil instaladores e prioridade de compra até 2028</a:t>
-            </a:r>
-          </a:p>
-        </p:txBody>
-      </p:sp>
-      <p:sp>
-        <p:nvSpPr>
-          <p:cNvPr id="25" name="Moldura protecao"/>
-          <p:cNvSpPr/>
-          <p:nvPr/>
-        </p:nvSpPr>
-        <p:spPr>
-          <a:xfrm>
-            <a:off x="6428232" y="2660904"/>
-            <a:ext cx="2606040" cy="841248"/>
-          </a:xfrm>
-          <a:prstGeom prst="rect">
-            <a:avLst/>
-          </a:prstGeom>
-          <a:noFill/>
-          <a:ln w="12700">
-            <a:solidFill>
-              <a:srgbClr val="009F41"/>
-            </a:solidFill>
-            <a:prstDash val="dash"/>
-          </a:ln>
-          <a:effectLst/>
-        </p:spPr>
-        <p:style>
-          <a:lnRef idx="1">
-            <a:schemeClr val="accent1"/>
-          </a:lnRef>
-          <a:fillRef idx="3">
-            <a:schemeClr val="accent1"/>
-          </a:fillRef>
-          <a:effectRef idx="2">
-            <a:schemeClr val="accent1"/>
-          </a:effectRef>
-          <a:fontRef idx="minor">
-            <a:schemeClr val="lt1"/>
-          </a:fontRef>
-        </p:style>
-        <p:txBody>
-          <a:bodyPr rtlCol="0" anchor="ctr"/>
-          <a:lstStyle/>
-          <a:p>
-            <a:pPr algn="ctr"/>
-          </a:p>
-        </p:txBody>
-      </p:sp>
-      <p:sp>
-        <p:nvSpPr>
-          <p:cNvPr id="26" name="Texto protecao"/>
-          <p:cNvSpPr txBox="1"/>
-          <p:nvPr/>
-        </p:nvSpPr>
-        <p:spPr>
-          <a:xfrm>
-            <a:off x="6519672" y="2715768"/>
-            <a:ext cx="2423160" cy="731520"/>
-          </a:xfrm>
-          <a:prstGeom prst="rect">
-            <a:avLst/>
-          </a:prstGeom>
-          <a:noFill/>
-        </p:spPr>
-        <p:txBody>
-          <a:bodyPr wrap="square" lIns="0" rIns="0" tIns="0" bIns="0" anchor="ctr">
-            <a:spAutoFit/>
-          </a:bodyPr>
-          <a:lstStyle/>
-          <a:p>
-            <a:pPr algn="l">
-              <a:spcAft>
-                <a:spcPts val="0"/>
-              </a:spcAft>
-            </a:pPr>
-            <a:r>
-              <a:rPr sz="900" b="1" i="0">
-                <a:solidFill>
-                  <a:srgbClr val="009F41"/>
-                </a:solidFill>
-              </a:rPr>
-              <a:t>Proteção: </a:t>
-            </a:r>
-            <a:r>
-              <a:rPr sz="900" b="0" i="0">
-                <a:solidFill>
-                  <a:srgbClr val="595959"/>
-                </a:solidFill>
-              </a:rPr>
-              <a:t>a prioridade cai se a Dahua cobrar ≥5% acima de produto equivalente ou falhar em tecnologia ou qualidade</a:t>
-            </a:r>
-          </a:p>
-        </p:txBody>
-      </p:sp>
-      <p:sp>
-        <p:nvSpPr>
-          <p:cNvPr id="27" name="Rotulo assimetria"/>
-          <p:cNvSpPr txBox="1"/>
-          <p:nvPr/>
-        </p:nvSpPr>
-        <p:spPr>
-          <a:xfrm>
-            <a:off x="9217152" y="2642616"/>
-            <a:ext cx="2743200" cy="164592"/>
-          </a:xfrm>
-          <a:prstGeom prst="rect">
-            <a:avLst/>
-          </a:prstGeom>
-          <a:noFill/>
-        </p:spPr>
-        <p:txBody>
-          <a:bodyPr wrap="square" lIns="0" rIns="0" tIns="0" bIns="0" anchor="t">
-            <a:spAutoFit/>
-          </a:bodyPr>
-          <a:lstStyle/>
-          <a:p>
-            <a:pPr algn="l">
-              <a:spcAft>
-                <a:spcPts val="0"/>
-              </a:spcAft>
-            </a:pPr>
-            <a:r>
-              <a:rPr sz="800" b="1" i="0">
-                <a:solidFill>
-                  <a:srgbClr val="6B6B6B"/>
-                </a:solidFill>
-              </a:rPr>
-              <a:t>Dependência assimétrica (2025)</a:t>
-            </a:r>
-          </a:p>
-        </p:txBody>
-      </p:sp>
-      <p:sp>
-        <p:nvSpPr>
-          <p:cNvPr id="28" name="Stat 23"/>
-          <p:cNvSpPr txBox="1"/>
-          <p:nvPr/>
-        </p:nvSpPr>
-        <p:spPr>
-          <a:xfrm>
-            <a:off x="9217152" y="2825496"/>
-            <a:ext cx="2743200" cy="329184"/>
-          </a:xfrm>
-          <a:prstGeom prst="rect">
-            <a:avLst/>
-          </a:prstGeom>
-          <a:noFill/>
-        </p:spPr>
-        <p:txBody>
-          <a:bodyPr wrap="square" lIns="0" rIns="0" tIns="0" bIns="0" anchor="ctr">
-            <a:spAutoFit/>
-          </a:bodyPr>
-          <a:lstStyle/>
-          <a:p>
-            <a:pPr algn="l">
-              <a:spcAft>
-                <a:spcPts val="0"/>
-              </a:spcAft>
-            </a:pPr>
-            <a:r>
-              <a:rPr sz="1800" b="1" i="0">
-                <a:solidFill>
-                  <a:srgbClr val="009F41"/>
-                </a:solidFill>
-              </a:rPr>
-              <a:t>23% </a:t>
-            </a:r>
-            <a:r>
-              <a:rPr sz="900" b="0" i="0">
-                <a:solidFill>
-                  <a:srgbClr val="595959"/>
-                </a:solidFill>
-              </a:rPr>
-              <a:t>do custo da Intelbras vem da Dahua</a:t>
-            </a:r>
-          </a:p>
-        </p:txBody>
-      </p:sp>
-      <p:sp>
-        <p:nvSpPr>
-          <p:cNvPr id="29" name="Stat 3"/>
-          <p:cNvSpPr txBox="1"/>
-          <p:nvPr/>
-        </p:nvSpPr>
-        <p:spPr>
-          <a:xfrm>
-            <a:off x="9217152" y="3172968"/>
-            <a:ext cx="2743200" cy="329184"/>
-          </a:xfrm>
-          <a:prstGeom prst="rect">
-            <a:avLst/>
-          </a:prstGeom>
-          <a:noFill/>
-        </p:spPr>
-        <p:txBody>
-          <a:bodyPr wrap="square" lIns="0" rIns="0" tIns="0" bIns="0" anchor="ctr">
-            <a:spAutoFit/>
-          </a:bodyPr>
-          <a:lstStyle/>
-          <a:p>
-            <a:pPr algn="l">
-              <a:spcAft>
-                <a:spcPts val="0"/>
-              </a:spcAft>
-            </a:pPr>
-            <a:r>
-              <a:rPr sz="1800" b="1" i="0">
-                <a:solidFill>
-                  <a:srgbClr val="1A1A1A"/>
-                </a:solidFill>
-              </a:rPr>
-              <a:t>~3% </a:t>
-            </a:r>
-            <a:r>
-              <a:rPr sz="900" b="0" i="0">
-                <a:solidFill>
-                  <a:srgbClr val="595959"/>
-                </a:solidFill>
-              </a:rPr>
-              <a:t>da receita da Dahua vem da Intelbras</a:t>
+              <a:t>canal de 90 mil instaladores</a:t>
             </a:r>
           </a:p>
         </p:txBody>
       </p:sp>
       <p:graphicFrame>
         <p:nvGraphicFramePr>
-          <p:cNvPr id="30" name="Grafico credito Dahua"/>
+          <p:cNvPr id="24" name="Grafico assimetria"/>
+          <p:cNvGraphicFramePr>
+            <a:graphicFrameLocks noGrp="1"/>
+          </p:cNvGraphicFramePr>
+          <p:nvPr/>
+        </p:nvGraphicFramePr>
+        <p:xfrm>
+          <a:off x="6428232" y="2386584"/>
+          <a:ext cx="5532120" cy="1143000"/>
+        </p:xfrm>
+        <a:graphic>
+          <a:graphicData uri="http://schemas.openxmlformats.org/drawingml/2006/chart">
+            <c:chart xmlns:c="http://schemas.openxmlformats.org/drawingml/2006/chart" r:id="rId3"/>
+          </a:graphicData>
+        </a:graphic>
+      </p:graphicFrame>
+      <p:graphicFrame>
+        <p:nvGraphicFramePr>
+          <p:cNvPr id="25" name="Grafico credito Dahua"/>
           <p:cNvGraphicFramePr>
             <a:graphicFrameLocks noGrp="1"/>
           </p:cNvGraphicFramePr>
@@ -8926,24 +7832,24 @@
         </p:nvGraphicFramePr>
         <p:xfrm>
           <a:off x="566928" y="4407408"/>
-          <a:ext cx="3794760" cy="1984248"/>
+          <a:ext cx="3657600" cy="1984248"/>
         </p:xfrm>
         <a:graphic>
           <a:graphicData uri="http://schemas.openxmlformats.org/drawingml/2006/chart">
-            <c:chart xmlns:c="http://schemas.openxmlformats.org/drawingml/2006/chart" r:id="rId3"/>
+            <c:chart xmlns:c="http://schemas.openxmlformats.org/drawingml/2006/chart" r:id="rId4"/>
           </a:graphicData>
         </a:graphic>
       </p:graphicFrame>
       <p:sp>
         <p:nvSpPr>
-          <p:cNvPr id="31" name="Callout credito Dahua"/>
+          <p:cNvPr id="26" name="Destaque credito"/>
           <p:cNvSpPr txBox="1"/>
           <p:nvPr/>
         </p:nvSpPr>
         <p:spPr>
           <a:xfrm>
-            <a:off x="4498848" y="4498848"/>
-            <a:ext cx="1600200" cy="1874519"/>
+            <a:off x="4361688" y="4818888"/>
+            <a:ext cx="1737360" cy="1097280"/>
           </a:xfrm>
           <a:prstGeom prst="rect">
             <a:avLst/>
@@ -8962,218 +7868,46 @@
               </a:spcAft>
             </a:pPr>
             <a:r>
-              <a:rPr sz="2000" b="1" i="0">
+              <a:rPr sz="2600" b="1" i="0">
                 <a:solidFill>
                   <a:srgbClr val="1A1A1A"/>
                 </a:solidFill>
               </a:rPr>
-              <a:t>225 dias</a:t>
+              <a:t>+R$269 mi</a:t>
             </a:r>
           </a:p>
           <a:p>
             <a:pPr algn="l">
               <a:spcAft>
-                <a:spcPts val="800"/>
+                <a:spcPts val="0"/>
               </a:spcAft>
             </a:pPr>
             <a:r>
-              <a:rPr sz="1000" b="0" i="0">
+              <a:rPr sz="1100" b="0" i="0">
                 <a:solidFill>
                   <a:srgbClr val="595959"/>
                 </a:solidFill>
               </a:rPr>
-              <a:t>de prazo implícito pago à Dahua em 2025 (151 em 2023)</a:t>
-            </a:r>
-          </a:p>
-          <a:p>
-            <a:pPr algn="l">
-              <a:spcAft>
-                <a:spcPts val="0"/>
-              </a:spcAft>
-            </a:pPr>
-            <a:r>
-              <a:rPr sz="1000" b="1" i="0">
-                <a:solidFill>
-                  <a:srgbClr val="009F41"/>
-                </a:solidFill>
-              </a:rPr>
-              <a:t>Se cair a 90 dias: </a:t>
-            </a:r>
-            <a:r>
-              <a:rPr sz="1000" b="0" i="0">
-                <a:solidFill>
-                  <a:srgbClr val="595959"/>
-                </a:solidFill>
-              </a:rPr>
-              <a:t>+R$269 mi de capital de giro e ROIC −1,7 p.p.</a:t>
-            </a:r>
-          </a:p>
-        </p:txBody>
-      </p:sp>
-      <p:sp>
-        <p:nvSpPr>
-          <p:cNvPr id="32" name="Fase aproximacao"/>
-          <p:cNvSpPr txBox="1"/>
-          <p:nvPr/>
-        </p:nvSpPr>
-        <p:spPr>
-          <a:xfrm>
-            <a:off x="6428232" y="4407408"/>
-            <a:ext cx="2377440" cy="164592"/>
-          </a:xfrm>
-          <a:prstGeom prst="rect">
-            <a:avLst/>
-          </a:prstGeom>
-          <a:noFill/>
-        </p:spPr>
-        <p:txBody>
-          <a:bodyPr wrap="square" lIns="0" rIns="0" tIns="0" bIns="0" anchor="t">
-            <a:spAutoFit/>
-          </a:bodyPr>
-          <a:lstStyle/>
-          <a:p>
-            <a:pPr algn="l">
-              <a:spcAft>
-                <a:spcPts val="0"/>
-              </a:spcAft>
-            </a:pPr>
-            <a:r>
-              <a:rPr sz="800" b="1" i="0">
-                <a:solidFill>
-                  <a:srgbClr val="009F41"/>
-                </a:solidFill>
-              </a:rPr>
-              <a:t>APROXIMAÇÃO  2007–2021</a:t>
-            </a:r>
-          </a:p>
-        </p:txBody>
-      </p:sp>
-      <p:sp>
-        <p:nvSpPr>
-          <p:cNvPr id="33" name="Fase afastamento"/>
-          <p:cNvSpPr txBox="1"/>
-          <p:nvPr/>
-        </p:nvSpPr>
-        <p:spPr>
-          <a:xfrm>
-            <a:off x="9582912" y="4407408"/>
-            <a:ext cx="2377440" cy="164592"/>
-          </a:xfrm>
-          <a:prstGeom prst="rect">
-            <a:avLst/>
-          </a:prstGeom>
-          <a:noFill/>
-        </p:spPr>
-        <p:txBody>
-          <a:bodyPr wrap="square" lIns="0" rIns="0" tIns="0" bIns="0" anchor="t">
-            <a:spAutoFit/>
-          </a:bodyPr>
-          <a:lstStyle/>
-          <a:p>
-            <a:pPr algn="r">
-              <a:spcAft>
-                <a:spcPts val="0"/>
-              </a:spcAft>
-            </a:pPr>
-            <a:r>
-              <a:rPr sz="800" b="1" i="0">
-                <a:solidFill>
-                  <a:srgbClr val="1A1A1A"/>
-                </a:solidFill>
-              </a:rPr>
-              <a:t>AFASTAMENTO  2023–2028</a:t>
+              <a:t>de capital de giro se o prazo cair a 90 dias</a:t>
             </a:r>
           </a:p>
         </p:txBody>
       </p:sp>
       <p:cxnSp>
         <p:nvCxnSpPr>
-          <p:cNvPr id="34" name="Eixo 2007"/>
+          <p:cNvPr id="27" name="Eixo aproximacao"/>
           <p:cNvCxnSpPr/>
           <p:nvPr/>
         </p:nvCxnSpPr>
         <p:spPr>
           <a:xfrm>
-            <a:off x="6611112" y="5340096"/>
-            <a:ext cx="320040" cy="0"/>
+            <a:off x="6748272" y="5504688"/>
+            <a:ext cx="1876598" cy="0"/>
           </a:xfrm>
           <a:prstGeom prst="line">
             <a:avLst/>
           </a:prstGeom>
-          <a:ln w="38100">
-            <a:solidFill>
-              <a:srgbClr val="009F41"/>
-            </a:solidFill>
-          </a:ln>
-        </p:spPr>
-        <p:style>
-          <a:lnRef idx="2">
-            <a:schemeClr val="accent1"/>
-          </a:lnRef>
-          <a:fillRef idx="0">
-            <a:schemeClr val="accent1"/>
-          </a:fillRef>
-          <a:effectRef idx="1">
-            <a:schemeClr val="accent1"/>
-          </a:effectRef>
-          <a:fontRef idx="minor">
-            <a:schemeClr val="tx1"/>
-          </a:fontRef>
-        </p:style>
-      </p:cxnSp>
-      <p:sp>
-        <p:nvSpPr>
-          <p:cNvPr id="35" name="Quebra eixo"/>
-          <p:cNvSpPr txBox="1"/>
-          <p:nvPr/>
-        </p:nvSpPr>
-        <p:spPr>
-          <a:xfrm>
-            <a:off x="6958584" y="5230368"/>
-            <a:ext cx="228600" cy="201168"/>
-          </a:xfrm>
-          <a:prstGeom prst="rect">
-            <a:avLst/>
-          </a:prstGeom>
-          <a:noFill/>
-        </p:spPr>
-        <p:txBody>
-          <a:bodyPr wrap="square" lIns="0" rIns="0" tIns="0" bIns="0" anchor="t">
-            <a:spAutoFit/>
-          </a:bodyPr>
-          <a:lstStyle/>
-          <a:p>
-            <a:pPr algn="ctr">
-              <a:spcAft>
-                <a:spcPts val="0"/>
-              </a:spcAft>
-            </a:pPr>
-            <a:r>
-              <a:rPr sz="1000" b="1" i="0">
-                <a:solidFill>
-                  <a:srgbClr val="8C8C8C"/>
-                </a:solidFill>
-              </a:rPr>
-              <a:t>//</a:t>
-            </a:r>
-          </a:p>
-        </p:txBody>
-      </p:sp>
-      <p:cxnSp>
-        <p:nvCxnSpPr>
-          <p:cNvPr id="36" name="Eixo aproximacao"/>
-          <p:cNvCxnSpPr/>
-          <p:nvPr/>
-        </p:nvCxnSpPr>
-        <p:spPr>
-          <a:xfrm>
-            <a:off x="7178040" y="5340096"/>
-            <a:ext cx="1698290" cy="0"/>
-          </a:xfrm>
-          <a:prstGeom prst="line">
-            <a:avLst/>
-          </a:prstGeom>
-          <a:ln w="38100">
+          <a:ln w="44450">
             <a:solidFill>
               <a:srgbClr val="009F41"/>
             </a:solidFill>
@@ -9196,19 +7930,19 @@
       </p:cxnSp>
       <p:cxnSp>
         <p:nvCxnSpPr>
-          <p:cNvPr id="37" name="Eixo afastamento"/>
+          <p:cNvPr id="28" name="Eixo afastamento"/>
           <p:cNvCxnSpPr/>
           <p:nvPr/>
         </p:nvCxnSpPr>
         <p:spPr>
           <a:xfrm>
-            <a:off x="8876330" y="5340096"/>
-            <a:ext cx="2763982" cy="0"/>
+            <a:off x="8624870" y="5504688"/>
+            <a:ext cx="2924002" cy="0"/>
           </a:xfrm>
           <a:prstGeom prst="line">
             <a:avLst/>
           </a:prstGeom>
-          <a:ln w="38100">
+          <a:ln w="44450">
             <a:solidFill>
               <a:srgbClr val="1A1A1A"/>
             </a:solidFill>
@@ -9231,14 +7965,14 @@
       </p:cxnSp>
       <p:sp>
         <p:nvSpPr>
-          <p:cNvPr id="38" name="Ponto 10% 2019.6"/>
+          <p:cNvPr id="29" name="Ponto 2019"/>
           <p:cNvSpPr/>
           <p:nvPr/>
         </p:nvSpPr>
         <p:spPr>
           <a:xfrm>
-            <a:off x="7869243" y="5280659"/>
-            <a:ext cx="118872" cy="118872"/>
+            <a:off x="7373389" y="5431536"/>
+            <a:ext cx="146304" cy="146304"/>
           </a:xfrm>
           <a:prstGeom prst="ellipse">
             <a:avLst/>
@@ -9246,7 +7980,7 @@
           <a:solidFill>
             <a:srgbClr val="009F41"/>
           </a:solidFill>
-          <a:ln w="12700">
+          <a:ln w="15875">
             <a:solidFill>
               <a:srgbClr val="FFFFFF"/>
             </a:solidFill>
@@ -9277,14 +8011,14 @@
       </p:sp>
       <p:sp>
         <p:nvSpPr>
-          <p:cNvPr id="39" name="Valor 2019.6"/>
+          <p:cNvPr id="30" name="Valor 2019"/>
           <p:cNvSpPr txBox="1"/>
           <p:nvPr/>
         </p:nvSpPr>
         <p:spPr>
           <a:xfrm>
-            <a:off x="7562919" y="4663440"/>
-            <a:ext cx="731520" cy="256032"/>
+            <a:off x="6943621" y="4937760"/>
+            <a:ext cx="1005840" cy="310896"/>
           </a:xfrm>
           <a:prstGeom prst="rect">
             <a:avLst/>
@@ -9303,7 +8037,7 @@
               </a:spcAft>
             </a:pPr>
             <a:r>
-              <a:rPr sz="1400" b="1" i="0">
+              <a:rPr sz="1800" b="1" i="0">
                 <a:solidFill>
                   <a:srgbClr val="009F41"/>
                 </a:solidFill>
@@ -9315,14 +8049,14 @@
       </p:sp>
       <p:sp>
         <p:nvSpPr>
-          <p:cNvPr id="40" name="Rotulo 2019.6"/>
+          <p:cNvPr id="31" name="Ano 2019"/>
           <p:cNvSpPr txBox="1"/>
           <p:nvPr/>
         </p:nvSpPr>
         <p:spPr>
           <a:xfrm>
-            <a:off x="7562919" y="4919472"/>
-            <a:ext cx="731520" cy="347472"/>
+            <a:off x="6943621" y="5632704"/>
+            <a:ext cx="1005840" cy="384048"/>
           </a:xfrm>
           <a:prstGeom prst="rect">
             <a:avLst/>
@@ -9330,7 +8064,7 @@
           <a:noFill/>
         </p:spPr>
         <p:txBody>
-          <a:bodyPr wrap="square" lIns="0" rIns="0" tIns="0" bIns="0" anchor="b">
+          <a:bodyPr wrap="square" lIns="0" rIns="0" tIns="0" bIns="0" anchor="t">
             <a:spAutoFit/>
           </a:bodyPr>
           <a:lstStyle/>
@@ -9341,26 +8075,26 @@
               </a:spcAft>
             </a:pPr>
             <a:r>
-              <a:rPr sz="800" b="0" i="0">
+              <a:rPr sz="900" b="0" i="0">
                 <a:solidFill>
                   <a:srgbClr val="595959"/>
                 </a:solidFill>
               </a:rPr>
-              <a:t>compra</a:t>
-            </a:r>
-          </a:p>
-        </p:txBody>
-      </p:sp>
-      <p:sp>
-        <p:nvSpPr>
-          <p:cNvPr id="41" name="Ponto 10% 2021.8"/>
+              <a:t>2019</a:t>
+            </a:r>
+          </a:p>
+        </p:txBody>
+      </p:sp>
+      <p:sp>
+        <p:nvSpPr>
+          <p:cNvPr id="32" name="Ponto 2021"/>
           <p:cNvSpPr/>
           <p:nvPr/>
         </p:nvSpPr>
         <p:spPr>
           <a:xfrm>
-            <a:off x="8737923" y="5280659"/>
-            <a:ext cx="118872" cy="118872"/>
+            <a:off x="8333509" y="5431536"/>
+            <a:ext cx="146304" cy="146304"/>
           </a:xfrm>
           <a:prstGeom prst="ellipse">
             <a:avLst/>
@@ -9368,7 +8102,7 @@
           <a:solidFill>
             <a:srgbClr val="009F41"/>
           </a:solidFill>
-          <a:ln w="12700">
+          <a:ln w="15875">
             <a:solidFill>
               <a:srgbClr val="FFFFFF"/>
             </a:solidFill>
@@ -9399,14 +8133,14 @@
       </p:sp>
       <p:sp>
         <p:nvSpPr>
-          <p:cNvPr id="42" name="Valor 2021.8"/>
+          <p:cNvPr id="33" name="Valor 2021"/>
           <p:cNvSpPr txBox="1"/>
           <p:nvPr/>
         </p:nvSpPr>
         <p:spPr>
           <a:xfrm>
-            <a:off x="8431599" y="4663440"/>
-            <a:ext cx="731520" cy="256032"/>
+            <a:off x="7903741" y="4937760"/>
+            <a:ext cx="1005840" cy="310896"/>
           </a:xfrm>
           <a:prstGeom prst="rect">
             <a:avLst/>
@@ -9425,7 +8159,7 @@
               </a:spcAft>
             </a:pPr>
             <a:r>
-              <a:rPr sz="1400" b="1" i="0">
+              <a:rPr sz="1800" b="1" i="0">
                 <a:solidFill>
                   <a:srgbClr val="009F41"/>
                 </a:solidFill>
@@ -9437,14 +8171,14 @@
       </p:sp>
       <p:sp>
         <p:nvSpPr>
-          <p:cNvPr id="43" name="Rotulo 2021.8"/>
+          <p:cNvPr id="34" name="Ano 2021"/>
           <p:cNvSpPr txBox="1"/>
           <p:nvPr/>
         </p:nvSpPr>
         <p:spPr>
           <a:xfrm>
-            <a:off x="8431599" y="4919472"/>
-            <a:ext cx="731520" cy="347472"/>
+            <a:off x="7903741" y="5632704"/>
+            <a:ext cx="1005840" cy="384048"/>
           </a:xfrm>
           <a:prstGeom prst="rect">
             <a:avLst/>
@@ -9452,7 +8186,7 @@
           <a:noFill/>
         </p:spPr>
         <p:txBody>
-          <a:bodyPr wrap="square" lIns="0" rIns="0" tIns="0" bIns="0" anchor="b">
+          <a:bodyPr wrap="square" lIns="0" rIns="0" tIns="0" bIns="0" anchor="t">
             <a:spAutoFit/>
           </a:bodyPr>
           <a:lstStyle/>
@@ -9463,26 +8197,26 @@
               </a:spcAft>
             </a:pPr>
             <a:r>
-              <a:rPr sz="800" b="0" i="0">
+              <a:rPr sz="900" b="0" i="0">
                 <a:solidFill>
                   <a:srgbClr val="595959"/>
                 </a:solidFill>
               </a:rPr>
-              <a:t>recompõe após IPO</a:t>
-            </a:r>
-          </a:p>
-        </p:txBody>
-      </p:sp>
-      <p:sp>
-        <p:nvSpPr>
-          <p:cNvPr id="44" name="Ponto 7,56% 2023.45"/>
+              <a:t>2021</a:t>
+            </a:r>
+          </a:p>
+        </p:txBody>
+      </p:sp>
+      <p:sp>
+        <p:nvSpPr>
+          <p:cNvPr id="35" name="Ponto 2023"/>
           <p:cNvSpPr/>
           <p:nvPr/>
         </p:nvSpPr>
         <p:spPr>
           <a:xfrm>
-            <a:off x="9389433" y="5280659"/>
-            <a:ext cx="118872" cy="118872"/>
+            <a:off x="9053599" y="5431536"/>
+            <a:ext cx="146304" cy="146304"/>
           </a:xfrm>
           <a:prstGeom prst="ellipse">
             <a:avLst/>
@@ -9490,7 +8224,7 @@
           <a:solidFill>
             <a:srgbClr val="1A1A1A"/>
           </a:solidFill>
-          <a:ln w="12700">
+          <a:ln w="15875">
             <a:solidFill>
               <a:srgbClr val="FFFFFF"/>
             </a:solidFill>
@@ -9521,14 +8255,14 @@
       </p:sp>
       <p:sp>
         <p:nvSpPr>
-          <p:cNvPr id="45" name="Valor 2023.45"/>
+          <p:cNvPr id="36" name="Valor 2023"/>
           <p:cNvSpPr txBox="1"/>
           <p:nvPr/>
         </p:nvSpPr>
         <p:spPr>
           <a:xfrm>
-            <a:off x="9083109" y="4663440"/>
-            <a:ext cx="731520" cy="256032"/>
+            <a:off x="8623831" y="4937760"/>
+            <a:ext cx="1005840" cy="310896"/>
           </a:xfrm>
           <a:prstGeom prst="rect">
             <a:avLst/>
@@ -9547,7 +8281,7 @@
               </a:spcAft>
             </a:pPr>
             <a:r>
-              <a:rPr sz="1400" b="1" i="0">
+              <a:rPr sz="1800" b="1" i="0">
                 <a:solidFill>
                   <a:srgbClr val="1A1A1A"/>
                 </a:solidFill>
@@ -9559,14 +8293,14 @@
       </p:sp>
       <p:sp>
         <p:nvSpPr>
-          <p:cNvPr id="46" name="Rotulo 2023.45"/>
+          <p:cNvPr id="37" name="Ano 2023"/>
           <p:cNvSpPr txBox="1"/>
           <p:nvPr/>
         </p:nvSpPr>
         <p:spPr>
           <a:xfrm>
-            <a:off x="9083109" y="4919472"/>
-            <a:ext cx="731520" cy="347472"/>
+            <a:off x="8623831" y="5632704"/>
+            <a:ext cx="1005840" cy="384048"/>
           </a:xfrm>
           <a:prstGeom prst="rect">
             <a:avLst/>
@@ -9574,7 +8308,7 @@
           <a:noFill/>
         </p:spPr>
         <p:txBody>
-          <a:bodyPr wrap="square" lIns="0" rIns="0" tIns="0" bIns="0" anchor="b">
+          <a:bodyPr wrap="square" lIns="0" rIns="0" tIns="0" bIns="0" anchor="t">
             <a:spAutoFit/>
           </a:bodyPr>
           <a:lstStyle/>
@@ -9585,26 +8319,26 @@
               </a:spcAft>
             </a:pPr>
             <a:r>
-              <a:rPr sz="800" b="0" i="0">
+              <a:rPr sz="900" b="0" i="0">
                 <a:solidFill>
                   <a:srgbClr val="595959"/>
                 </a:solidFill>
               </a:rPr>
-              <a:t>vende 2,44%</a:t>
-            </a:r>
-          </a:p>
-        </p:txBody>
-      </p:sp>
-      <p:sp>
-        <p:nvSpPr>
-          <p:cNvPr id="47" name="Ponto 0%? 2025.6"/>
+              <a:t>2023</a:t>
+            </a:r>
+          </a:p>
+        </p:txBody>
+      </p:sp>
+      <p:sp>
+        <p:nvSpPr>
+          <p:cNvPr id="38" name="Ponto 2025|venda aprovada"/>
           <p:cNvSpPr/>
           <p:nvPr/>
         </p:nvSpPr>
         <p:spPr>
           <a:xfrm>
-            <a:off x="10238370" y="5280659"/>
-            <a:ext cx="118872" cy="118872"/>
+            <a:off x="9991898" y="5431536"/>
+            <a:ext cx="146304" cy="146304"/>
           </a:xfrm>
           <a:prstGeom prst="ellipse">
             <a:avLst/>
@@ -9612,7 +8346,7 @@
           <a:solidFill>
             <a:srgbClr val="1A1A1A"/>
           </a:solidFill>
-          <a:ln w="12700">
+          <a:ln w="15875">
             <a:solidFill>
               <a:srgbClr val="FFFFFF"/>
             </a:solidFill>
@@ -9643,14 +8377,14 @@
       </p:sp>
       <p:sp>
         <p:nvSpPr>
-          <p:cNvPr id="48" name="Valor 2025.6"/>
+          <p:cNvPr id="39" name="Valor 2025|venda aprovada"/>
           <p:cNvSpPr txBox="1"/>
           <p:nvPr/>
         </p:nvSpPr>
         <p:spPr>
           <a:xfrm>
-            <a:off x="9932046" y="4663440"/>
-            <a:ext cx="731520" cy="256032"/>
+            <a:off x="9562130" y="4937760"/>
+            <a:ext cx="1005840" cy="310896"/>
           </a:xfrm>
           <a:prstGeom prst="rect">
             <a:avLst/>
@@ -9669,7 +8403,7 @@
               </a:spcAft>
             </a:pPr>
             <a:r>
-              <a:rPr sz="1400" b="1" i="0">
+              <a:rPr sz="1800" b="1" i="0">
                 <a:solidFill>
                   <a:srgbClr val="1A1A1A"/>
                 </a:solidFill>
@@ -9681,14 +8415,14 @@
       </p:sp>
       <p:sp>
         <p:nvSpPr>
-          <p:cNvPr id="49" name="Rotulo 2025.6"/>
+          <p:cNvPr id="40" name="Ano 2025|venda aprovada"/>
           <p:cNvSpPr txBox="1"/>
           <p:nvPr/>
         </p:nvSpPr>
         <p:spPr>
           <a:xfrm>
-            <a:off x="9932046" y="4919472"/>
-            <a:ext cx="731520" cy="347472"/>
+            <a:off x="9562130" y="5632704"/>
+            <a:ext cx="1005840" cy="384048"/>
           </a:xfrm>
           <a:prstGeom prst="rect">
             <a:avLst/>
@@ -9696,7 +8430,7 @@
           <a:noFill/>
         </p:spPr>
         <p:txBody>
-          <a:bodyPr wrap="square" lIns="0" rIns="0" tIns="0" bIns="0" anchor="b">
+          <a:bodyPr wrap="square" lIns="0" rIns="0" tIns="0" bIns="0" anchor="t">
             <a:spAutoFit/>
           </a:bodyPr>
           <a:lstStyle/>
@@ -9707,34 +8441,49 @@
               </a:spcAft>
             </a:pPr>
             <a:r>
-              <a:rPr sz="800" b="0" i="0">
+              <a:rPr sz="900" b="0" i="0">
                 <a:solidFill>
                   <a:srgbClr val="595959"/>
                 </a:solidFill>
               </a:rPr>
-              <a:t>aprova venda total até ago/28</a:t>
-            </a:r>
-          </a:p>
-        </p:txBody>
-      </p:sp>
-      <p:sp>
-        <p:nvSpPr>
-          <p:cNvPr id="50" name="Marco 2007"/>
+              <a:t>2025</a:t>
+            </a:r>
+          </a:p>
+          <a:p>
+            <a:pPr algn="ctr">
+              <a:spcAft>
+                <a:spcPts val="0"/>
+              </a:spcAft>
+            </a:pPr>
+            <a:r>
+              <a:rPr sz="900" b="0" i="0">
+                <a:solidFill>
+                  <a:srgbClr val="595959"/>
+                </a:solidFill>
+              </a:rPr>
+              <a:t>venda aprovada</a:t>
+            </a:r>
+          </a:p>
+        </p:txBody>
+      </p:sp>
+      <p:sp>
+        <p:nvSpPr>
+          <p:cNvPr id="41" name="Ponto fim do acordo"/>
           <p:cNvSpPr/>
           <p:nvPr/>
         </p:nvSpPr>
         <p:spPr>
           <a:xfrm>
-            <a:off x="6606540" y="5289804"/>
-            <a:ext cx="100584" cy="100584"/>
+            <a:off x="11408179" y="5385816"/>
+            <a:ext cx="237744" cy="237744"/>
           </a:xfrm>
           <a:prstGeom prst="ellipse">
             <a:avLst/>
           </a:prstGeom>
           <a:solidFill>
-            <a:srgbClr val="009F41"/>
+            <a:srgbClr val="1A1A1A"/>
           </a:solidFill>
-          <a:ln w="12700">
+          <a:ln w="15875">
             <a:solidFill>
               <a:srgbClr val="FFFFFF"/>
             </a:solidFill>
@@ -9765,14 +8514,52 @@
       </p:sp>
       <p:sp>
         <p:nvSpPr>
-          <p:cNvPr id="51" name="Texto 2007"/>
+          <p:cNvPr id="42" name="Valor fim acordo"/>
           <p:cNvSpPr txBox="1"/>
           <p:nvPr/>
         </p:nvSpPr>
         <p:spPr>
           <a:xfrm>
-            <a:off x="6428232" y="5449824"/>
-            <a:ext cx="960120" cy="457200"/>
+            <a:off x="10978411" y="4937760"/>
+            <a:ext cx="1097280" cy="310896"/>
+          </a:xfrm>
+          <a:prstGeom prst="rect">
+            <a:avLst/>
+          </a:prstGeom>
+          <a:noFill/>
+        </p:spPr>
+        <p:txBody>
+          <a:bodyPr wrap="square" lIns="0" rIns="0" tIns="0" bIns="0" anchor="b">
+            <a:spAutoFit/>
+          </a:bodyPr>
+          <a:lstStyle/>
+          <a:p>
+            <a:pPr algn="ctr">
+              <a:spcAft>
+                <a:spcPts val="0"/>
+              </a:spcAft>
+            </a:pPr>
+            <a:r>
+              <a:rPr sz="1400" b="1" i="0">
+                <a:solidFill>
+                  <a:srgbClr val="1A1A1A"/>
+                </a:solidFill>
+              </a:rPr>
+              <a:t>dez/28</a:t>
+            </a:r>
+          </a:p>
+        </p:txBody>
+      </p:sp>
+      <p:sp>
+        <p:nvSpPr>
+          <p:cNvPr id="43" name="Rotulo fim acordo"/>
+          <p:cNvSpPr txBox="1"/>
+          <p:nvPr/>
+        </p:nvSpPr>
+        <p:spPr>
+          <a:xfrm>
+            <a:off x="10978411" y="5650992"/>
+            <a:ext cx="1097280" cy="384048"/>
           </a:xfrm>
           <a:prstGeom prst="rect">
             <a:avLst/>
@@ -9785,93 +8572,32 @@
           </a:bodyPr>
           <a:lstStyle/>
           <a:p>
-            <a:pPr algn="l">
+            <a:pPr algn="ctr">
               <a:spcAft>
                 <a:spcPts val="0"/>
               </a:spcAft>
             </a:pPr>
             <a:r>
-              <a:rPr sz="800" b="1" i="0">
-                <a:solidFill>
-                  <a:srgbClr val="009F41"/>
+              <a:rPr sz="900" b="1" i="0">
+                <a:solidFill>
+                  <a:srgbClr val="1A1A1A"/>
                 </a:solidFill>
               </a:rPr>
-              <a:t>2007</a:t>
-            </a:r>
-          </a:p>
-          <a:p>
-            <a:pPr algn="l">
-              <a:spcAft>
-                <a:spcPts val="0"/>
-              </a:spcAft>
-            </a:pPr>
-            <a:r>
-              <a:rPr sz="800" b="0" i="0">
-                <a:solidFill>
-                  <a:srgbClr val="595959"/>
-                </a:solidFill>
-              </a:rPr>
-              <a:t>parceria começa</a:t>
-            </a:r>
-          </a:p>
-        </p:txBody>
-      </p:sp>
-      <p:sp>
-        <p:nvSpPr>
-          <p:cNvPr id="52" name="Marco dez/18"/>
-          <p:cNvSpPr/>
-          <p:nvPr/>
-        </p:nvSpPr>
-        <p:spPr>
-          <a:xfrm>
-            <a:off x="7621731" y="5289804"/>
-            <a:ext cx="100584" cy="100584"/>
-          </a:xfrm>
-          <a:prstGeom prst="ellipse">
-            <a:avLst/>
-          </a:prstGeom>
-          <a:solidFill>
-            <a:srgbClr val="009F41"/>
-          </a:solidFill>
-          <a:ln w="12700">
-            <a:solidFill>
-              <a:srgbClr val="FFFFFF"/>
-            </a:solidFill>
-          </a:ln>
-          <a:effectLst/>
-        </p:spPr>
-        <p:style>
-          <a:lnRef idx="1">
-            <a:schemeClr val="accent1"/>
-          </a:lnRef>
-          <a:fillRef idx="3">
-            <a:schemeClr val="accent1"/>
-          </a:fillRef>
-          <a:effectRef idx="2">
-            <a:schemeClr val="accent1"/>
-          </a:effectRef>
-          <a:fontRef idx="minor">
-            <a:schemeClr val="lt1"/>
-          </a:fontRef>
-        </p:style>
-        <p:txBody>
-          <a:bodyPr rtlCol="0" anchor="ctr"/>
-          <a:lstStyle/>
-          <a:p>
-            <a:pPr algn="ctr"/>
-          </a:p>
-        </p:txBody>
-      </p:sp>
-      <p:sp>
-        <p:nvSpPr>
-          <p:cNvPr id="53" name="Texto dez/18"/>
+              <a:t>acordo vence</a:t>
+            </a:r>
+          </a:p>
+        </p:txBody>
+      </p:sp>
+      <p:sp>
+        <p:nvSpPr>
+          <p:cNvPr id="44" name="Fase aproximacao"/>
           <p:cNvSpPr txBox="1"/>
           <p:nvPr/>
         </p:nvSpPr>
         <p:spPr>
           <a:xfrm>
-            <a:off x="7191963" y="5449824"/>
-            <a:ext cx="960120" cy="457200"/>
+            <a:off x="6748272" y="6071616"/>
+            <a:ext cx="2194560" cy="182880"/>
           </a:xfrm>
           <a:prstGeom prst="rect">
             <a:avLst/>
@@ -9884,93 +8610,32 @@
           </a:bodyPr>
           <a:lstStyle/>
           <a:p>
-            <a:pPr algn="ctr">
+            <a:pPr algn="l">
               <a:spcAft>
                 <a:spcPts val="0"/>
               </a:spcAft>
             </a:pPr>
             <a:r>
-              <a:rPr sz="800" b="1" i="0">
+              <a:rPr sz="900" b="1" i="0">
                 <a:solidFill>
                   <a:srgbClr val="009F41"/>
                 </a:solidFill>
               </a:rPr>
-              <a:t>dez/18</a:t>
-            </a:r>
-          </a:p>
-          <a:p>
-            <a:pPr algn="ctr">
-              <a:spcAft>
-                <a:spcPts val="0"/>
-              </a:spcAft>
-            </a:pPr>
-            <a:r>
-              <a:rPr sz="800" b="0" i="0">
-                <a:solidFill>
-                  <a:srgbClr val="595959"/>
-                </a:solidFill>
-              </a:rPr>
-              <a:t>acordo de 10 anos</a:t>
-            </a:r>
-          </a:p>
-        </p:txBody>
-      </p:sp>
-      <p:sp>
-        <p:nvSpPr>
-          <p:cNvPr id="54" name="Marco c.2021"/>
-          <p:cNvSpPr/>
-          <p:nvPr/>
-        </p:nvSpPr>
-        <p:spPr>
-          <a:xfrm>
-            <a:off x="8431183" y="5289804"/>
-            <a:ext cx="100584" cy="100584"/>
-          </a:xfrm>
-          <a:prstGeom prst="ellipse">
-            <a:avLst/>
-          </a:prstGeom>
-          <a:solidFill>
-            <a:srgbClr val="009F41"/>
-          </a:solidFill>
-          <a:ln w="12700">
-            <a:solidFill>
-              <a:srgbClr val="FFFFFF"/>
-            </a:solidFill>
-          </a:ln>
-          <a:effectLst/>
-        </p:spPr>
-        <p:style>
-          <a:lnRef idx="1">
-            <a:schemeClr val="accent1"/>
-          </a:lnRef>
-          <a:fillRef idx="3">
-            <a:schemeClr val="accent1"/>
-          </a:fillRef>
-          <a:effectRef idx="2">
-            <a:schemeClr val="accent1"/>
-          </a:effectRef>
-          <a:fontRef idx="minor">
-            <a:schemeClr val="lt1"/>
-          </a:fontRef>
-        </p:style>
-        <p:txBody>
-          <a:bodyPr rtlCol="0" anchor="ctr"/>
-          <a:lstStyle/>
-          <a:p>
-            <a:pPr algn="ctr"/>
-          </a:p>
-        </p:txBody>
-      </p:sp>
-      <p:sp>
-        <p:nvSpPr>
-          <p:cNvPr id="55" name="Texto c.2021"/>
+              <a:t>aproximação</a:t>
+            </a:r>
+          </a:p>
+        </p:txBody>
+      </p:sp>
+      <p:sp>
+        <p:nvSpPr>
+          <p:cNvPr id="45" name="Fase afastamento"/>
           <p:cNvSpPr txBox="1"/>
           <p:nvPr/>
         </p:nvSpPr>
         <p:spPr>
           <a:xfrm>
-            <a:off x="8001415" y="5449824"/>
-            <a:ext cx="960120" cy="457200"/>
+            <a:off x="9354312" y="6071616"/>
+            <a:ext cx="2194560" cy="182880"/>
           </a:xfrm>
           <a:prstGeom prst="rect">
             <a:avLst/>
@@ -9983,277 +8648,18 @@
           </a:bodyPr>
           <a:lstStyle/>
           <a:p>
-            <a:pPr algn="ctr">
+            <a:pPr algn="r">
               <a:spcAft>
                 <a:spcPts val="0"/>
               </a:spcAft>
             </a:pPr>
             <a:r>
-              <a:rPr sz="800" b="1" i="0">
-                <a:solidFill>
-                  <a:srgbClr val="009F41"/>
+              <a:rPr sz="900" b="1" i="0">
+                <a:solidFill>
+                  <a:srgbClr val="1A1A1A"/>
                 </a:solidFill>
               </a:rPr>
-              <a:t>c.2021</a:t>
-            </a:r>
-          </a:p>
-          <a:p>
-            <a:pPr algn="ctr">
-              <a:spcAft>
-                <a:spcPts val="0"/>
-              </a:spcAft>
-            </a:pPr>
-            <a:r>
-              <a:rPr sz="800" b="0" i="0">
-                <a:solidFill>
-                  <a:srgbClr val="595959"/>
-                </a:solidFill>
-              </a:rPr>
-              <a:t>Dahua Brasil vira região própria</a:t>
-            </a:r>
-          </a:p>
-        </p:txBody>
-      </p:sp>
-      <p:sp>
-        <p:nvSpPr>
-          <p:cNvPr id="56" name="Marco jan/26"/>
-          <p:cNvSpPr/>
-          <p:nvPr/>
-        </p:nvSpPr>
-        <p:spPr>
-          <a:xfrm>
-            <a:off x="10425199" y="5289804"/>
-            <a:ext cx="100584" cy="100584"/>
-          </a:xfrm>
-          <a:prstGeom prst="ellipse">
-            <a:avLst/>
-          </a:prstGeom>
-          <a:solidFill>
-            <a:srgbClr val="595959"/>
-          </a:solidFill>
-          <a:ln w="12700">
-            <a:solidFill>
-              <a:srgbClr val="FFFFFF"/>
-            </a:solidFill>
-          </a:ln>
-          <a:effectLst/>
-        </p:spPr>
-        <p:style>
-          <a:lnRef idx="1">
-            <a:schemeClr val="accent1"/>
-          </a:lnRef>
-          <a:fillRef idx="3">
-            <a:schemeClr val="accent1"/>
-          </a:fillRef>
-          <a:effectRef idx="2">
-            <a:schemeClr val="accent1"/>
-          </a:effectRef>
-          <a:fontRef idx="minor">
-            <a:schemeClr val="lt1"/>
-          </a:fontRef>
-        </p:style>
-        <p:txBody>
-          <a:bodyPr rtlCol="0" anchor="ctr"/>
-          <a:lstStyle/>
-          <a:p>
-            <a:pPr algn="ctr"/>
-          </a:p>
-        </p:txBody>
-      </p:sp>
-      <p:sp>
-        <p:nvSpPr>
-          <p:cNvPr id="57" name="Texto jan/26"/>
-          <p:cNvSpPr txBox="1"/>
-          <p:nvPr/>
-        </p:nvSpPr>
-        <p:spPr>
-          <a:xfrm>
-            <a:off x="9995431" y="5449824"/>
-            <a:ext cx="960120" cy="457200"/>
-          </a:xfrm>
-          <a:prstGeom prst="rect">
-            <a:avLst/>
-          </a:prstGeom>
-          <a:noFill/>
-        </p:spPr>
-        <p:txBody>
-          <a:bodyPr wrap="square" lIns="0" rIns="0" tIns="0" bIns="0" anchor="t">
-            <a:spAutoFit/>
-          </a:bodyPr>
-          <a:lstStyle/>
-          <a:p>
-            <a:pPr algn="ctr">
-              <a:spcAft>
-                <a:spcPts val="0"/>
-              </a:spcAft>
-            </a:pPr>
-            <a:r>
-              <a:rPr sz="800" b="1" i="0">
-                <a:solidFill>
-                  <a:srgbClr val="595959"/>
-                </a:solidFill>
-              </a:rPr>
-              <a:t>jan/26</a:t>
-            </a:r>
-          </a:p>
-          <a:p>
-            <a:pPr algn="ctr">
-              <a:spcAft>
-                <a:spcPts val="0"/>
-              </a:spcAft>
-            </a:pPr>
-            <a:r>
-              <a:rPr sz="800" b="0" i="0">
-                <a:solidFill>
-                  <a:srgbClr val="595959"/>
-                </a:solidFill>
-              </a:rPr>
-              <a:t>FiberHome encerra exclusividade (precedente)</a:t>
-            </a:r>
-          </a:p>
-        </p:txBody>
-      </p:sp>
-      <p:sp>
-        <p:nvSpPr>
-          <p:cNvPr id="58" name="Marco dez/28"/>
-          <p:cNvSpPr/>
-          <p:nvPr/>
-        </p:nvSpPr>
-        <p:spPr>
-          <a:xfrm>
-            <a:off x="11529129" y="5248656"/>
-            <a:ext cx="182880" cy="182880"/>
-          </a:xfrm>
-          <a:prstGeom prst="ellipse">
-            <a:avLst/>
-          </a:prstGeom>
-          <a:solidFill>
-            <a:srgbClr val="1A1A1A"/>
-          </a:solidFill>
-          <a:ln w="12700">
-            <a:solidFill>
-              <a:srgbClr val="FFFFFF"/>
-            </a:solidFill>
-          </a:ln>
-          <a:effectLst/>
-        </p:spPr>
-        <p:style>
-          <a:lnRef idx="1">
-            <a:schemeClr val="accent1"/>
-          </a:lnRef>
-          <a:fillRef idx="3">
-            <a:schemeClr val="accent1"/>
-          </a:fillRef>
-          <a:effectRef idx="2">
-            <a:schemeClr val="accent1"/>
-          </a:effectRef>
-          <a:fontRef idx="minor">
-            <a:schemeClr val="lt1"/>
-          </a:fontRef>
-        </p:style>
-        <p:txBody>
-          <a:bodyPr rtlCol="0" anchor="ctr"/>
-          <a:lstStyle/>
-          <a:p>
-            <a:pPr algn="ctr"/>
-          </a:p>
-        </p:txBody>
-      </p:sp>
-      <p:sp>
-        <p:nvSpPr>
-          <p:cNvPr id="59" name="Texto dez/28"/>
-          <p:cNvSpPr txBox="1"/>
-          <p:nvPr/>
-        </p:nvSpPr>
-        <p:spPr>
-          <a:xfrm>
-            <a:off x="11000232" y="5449824"/>
-            <a:ext cx="960120" cy="457200"/>
-          </a:xfrm>
-          <a:prstGeom prst="rect">
-            <a:avLst/>
-          </a:prstGeom>
-          <a:noFill/>
-        </p:spPr>
-        <p:txBody>
-          <a:bodyPr wrap="square" lIns="0" rIns="0" tIns="0" bIns="0" anchor="t">
-            <a:spAutoFit/>
-          </a:bodyPr>
-          <a:lstStyle/>
-          <a:p>
-            <a:pPr algn="ctr">
-              <a:spcAft>
-                <a:spcPts val="0"/>
-              </a:spcAft>
-            </a:pPr>
-            <a:r>
-              <a:rPr sz="800" b="1" i="0">
-                <a:solidFill>
-                  <a:srgbClr val="1A1A1A"/>
-                </a:solidFill>
-              </a:rPr>
-              <a:t>dez/28</a:t>
-            </a:r>
-          </a:p>
-          <a:p>
-            <a:pPr algn="ctr">
-              <a:spcAft>
-                <a:spcPts val="0"/>
-              </a:spcAft>
-            </a:pPr>
-            <a:r>
-              <a:rPr sz="800" b="0" i="0">
-                <a:solidFill>
-                  <a:srgbClr val="595959"/>
-                </a:solidFill>
-              </a:rPr>
-              <a:t>acordo vence</a:t>
-            </a:r>
-          </a:p>
-        </p:txBody>
-      </p:sp>
-      <p:sp>
-        <p:nvSpPr>
-          <p:cNvPr id="60" name="Em jogo"/>
-          <p:cNvSpPr txBox="1"/>
-          <p:nvPr/>
-        </p:nvSpPr>
-        <p:spPr>
-          <a:xfrm>
-            <a:off x="6428232" y="6035040"/>
-            <a:ext cx="5532120" cy="329184"/>
-          </a:xfrm>
-          <a:prstGeom prst="rect">
-            <a:avLst/>
-          </a:prstGeom>
-          <a:noFill/>
-        </p:spPr>
-        <p:txBody>
-          <a:bodyPr wrap="square" lIns="0" rIns="0" tIns="0" bIns="0" anchor="ctr">
-            <a:spAutoFit/>
-          </a:bodyPr>
-          <a:lstStyle/>
-          <a:p>
-            <a:pPr algn="l">
-              <a:spcAft>
-                <a:spcPts val="0"/>
-              </a:spcAft>
-            </a:pPr>
-            <a:r>
-              <a:rPr sz="1100" b="1" i="0">
-                <a:solidFill>
-                  <a:srgbClr val="1A1A1A"/>
-                </a:solidFill>
-              </a:rPr>
-              <a:t>Em jogo em dez/28: </a:t>
-            </a:r>
-            <a:r>
-              <a:rPr sz="1100" b="1" i="0">
-                <a:solidFill>
-                  <a:srgbClr val="009F41"/>
-                </a:solidFill>
-              </a:rPr>
-              <a:t>~metade do custo de Segurança e R$449 mi de crédito</a:t>
+              <a:t>afastamento</a:t>
             </a:r>
           </a:p>
         </p:txBody>

</xml_diff>